<commit_message>
Update presentation PPTX with light theme and proper bullet points formatting
</commit_message>
<xml_diff>
--- a/Presentation.pptx
+++ b/Presentation.pptx
@@ -3091,7 +3091,7 @@
     <p:bg>
       <p:bgPr>
         <a:solidFill>
-          <a:srgbClr val="0F172A"/>
+          <a:srgbClr val="F8FAFC"/>
         </a:solidFill>
         <a:effectLst/>
       </p:bgPr>
@@ -3128,7 +3128,7 @@
             <a:pPr algn="l">
               <a:defRPr sz="5400" b="1">
                 <a:solidFill>
-                  <a:srgbClr val="F1F5F9"/>
+                  <a:srgbClr val="1E1B4B"/>
                 </a:solidFill>
                 <a:latin typeface="Arial"/>
               </a:defRPr>
@@ -3164,7 +3164,7 @@
         <p:spPr>
           <a:xfrm>
             <a:off x="685800" y="4114800"/>
-            <a:ext cx="7315200" cy="1828800"/>
+            <a:ext cx="9144000" cy="2011680"/>
           </a:xfrm>
           <a:prstGeom prst="rect">
             <a:avLst/>
@@ -3183,7 +3183,7 @@
               </a:spcAft>
               <a:defRPr sz="1400" b="1">
                 <a:solidFill>
-                  <a:srgbClr val="94A3B8"/>
+                  <a:srgbClr val="64748B"/>
                 </a:solidFill>
                 <a:latin typeface="Arial"/>
               </a:defRPr>
@@ -3199,7 +3199,7 @@
               </a:spcBef>
               <a:defRPr sz="1200">
                 <a:solidFill>
-                  <a:srgbClr val="CBD5E1"/>
+                  <a:srgbClr val="334155"/>
                 </a:solidFill>
                 <a:latin typeface="Arial"/>
               </a:defRPr>
@@ -3215,7 +3215,7 @@
               </a:spcBef>
               <a:defRPr sz="1200">
                 <a:solidFill>
-                  <a:srgbClr val="CBD5E1"/>
+                  <a:srgbClr val="334155"/>
                 </a:solidFill>
                 <a:latin typeface="Arial"/>
               </a:defRPr>
@@ -3231,7 +3231,7 @@
               </a:spcBef>
               <a:defRPr sz="1200">
                 <a:solidFill>
-                  <a:srgbClr val="CBD5E1"/>
+                  <a:srgbClr val="334155"/>
                 </a:solidFill>
                 <a:latin typeface="Arial"/>
               </a:defRPr>
@@ -3247,7 +3247,7 @@
               </a:spcBef>
               <a:defRPr sz="1200">
                 <a:solidFill>
-                  <a:srgbClr val="CBD5E1"/>
+                  <a:srgbClr val="334155"/>
                 </a:solidFill>
                 <a:latin typeface="Arial"/>
               </a:defRPr>
@@ -3272,7 +3272,7 @@
     <p:bg>
       <p:bgPr>
         <a:solidFill>
-          <a:srgbClr val="0F172A"/>
+          <a:srgbClr val="F8FAFC"/>
         </a:solidFill>
         <a:effectLst/>
       </p:bgPr>
@@ -3309,7 +3309,7 @@
             <a:pPr>
               <a:defRPr sz="3600" b="1">
                 <a:solidFill>
-                  <a:srgbClr val="F1F5F9"/>
+                  <a:srgbClr val="1E1B4B"/>
                 </a:solidFill>
                 <a:latin typeface="Arial"/>
               </a:defRPr>
@@ -3348,7 +3348,7 @@
               </a:spcAft>
               <a:defRPr sz="2000">
                 <a:solidFill>
-                  <a:srgbClr val="CBD5E1"/>
+                  <a:srgbClr val="334155"/>
                 </a:solidFill>
                 <a:latin typeface="Arial"/>
               </a:defRPr>
@@ -3364,13 +3364,13 @@
               </a:spcBef>
               <a:defRPr sz="1600">
                 <a:solidFill>
-                  <a:srgbClr val="F1F5F9"/>
-                </a:solidFill>
-                <a:latin typeface="Arial"/>
-              </a:defRPr>
-            </a:pPr>
-            <a:r>
-              <a:t>- Standardize mixed casings (camelCase/PascalCase) into uniform lowercase snake_case.</a:t>
+                  <a:srgbClr val="334155"/>
+                </a:solidFill>
+                <a:latin typeface="Arial"/>
+              </a:defRPr>
+            </a:pPr>
+            <a:r>
+              <a:t>•  Standardize mixed casings (camelCase/PascalCase) into uniform lowercase snake_case.</a:t>
             </a:r>
           </a:p>
           <a:p>
@@ -3380,13 +3380,13 @@
               </a:spcBef>
               <a:defRPr sz="1600">
                 <a:solidFill>
-                  <a:srgbClr val="F1F5F9"/>
-                </a:solidFill>
-                <a:latin typeface="Arial"/>
-              </a:defRPr>
-            </a:pPr>
-            <a:r>
-              <a:t>- Enforce SQL keywords capitalization rules locally at zero compute cost.</a:t>
+                  <a:srgbClr val="334155"/>
+                </a:solidFill>
+                <a:latin typeface="Arial"/>
+              </a:defRPr>
+            </a:pPr>
+            <a:r>
+              <a:t>•  Enforce SQL keywords capitalization rules locally at zero compute cost.</a:t>
             </a:r>
           </a:p>
           <a:p>
@@ -3396,13 +3396,13 @@
               </a:spcBef>
               <a:defRPr sz="1600">
                 <a:solidFill>
-                  <a:srgbClr val="F1F5F9"/>
-                </a:solidFill>
-                <a:latin typeface="Arial"/>
-              </a:defRPr>
-            </a:pPr>
-            <a:r>
-              <a:t>- Isolate and purge markdown formatting artifacts to safeguard downstream compiler integrity.</a:t>
+                  <a:srgbClr val="334155"/>
+                </a:solidFill>
+                <a:latin typeface="Arial"/>
+              </a:defRPr>
+            </a:pPr>
+            <a:r>
+              <a:t>•  Isolate and purge markdown formatting artifacts to safeguard downstream compiler integrity.</a:t>
             </a:r>
           </a:p>
           <a:p>
@@ -3412,13 +3412,13 @@
               </a:spcBef>
               <a:defRPr sz="1600">
                 <a:solidFill>
-                  <a:srgbClr val="F1F5F9"/>
-                </a:solidFill>
-                <a:latin typeface="Arial"/>
-              </a:defRPr>
-            </a:pPr>
-            <a:r>
-              <a:t>- Refactor implicit comma-joins and nested subqueries into explicit joins and Common Table Expressions (CTEs) via AI logic.</a:t>
+                  <a:srgbClr val="334155"/>
+                </a:solidFill>
+                <a:latin typeface="Arial"/>
+              </a:defRPr>
+            </a:pPr>
+            <a:r>
+              <a:t>•  Refactor implicit comma-joins and nested subqueries into explicit joins and Common Table Expressions (CTEs) via AI logic.</a:t>
             </a:r>
           </a:p>
           <a:p>
@@ -3428,13 +3428,13 @@
               </a:spcBef>
               <a:defRPr sz="1600">
                 <a:solidFill>
-                  <a:srgbClr val="F1F5F9"/>
-                </a:solidFill>
-                <a:latin typeface="Arial"/>
-              </a:defRPr>
-            </a:pPr>
-            <a:r>
-              <a:t>- Secure syntax correctness using an in-memory Abstract Syntax Tree validation loop.</a:t>
+                  <a:srgbClr val="334155"/>
+                </a:solidFill>
+                <a:latin typeface="Arial"/>
+              </a:defRPr>
+            </a:pPr>
+            <a:r>
+              <a:t>•  Secure syntax correctness using an in-memory Abstract Syntax Tree validation loop.</a:t>
             </a:r>
           </a:p>
         </p:txBody>
@@ -3453,7 +3453,7 @@
     <p:bg>
       <p:bgPr>
         <a:solidFill>
-          <a:srgbClr val="0F172A"/>
+          <a:srgbClr val="F8FAFC"/>
         </a:solidFill>
         <a:effectLst/>
       </p:bgPr>
@@ -3490,7 +3490,7 @@
             <a:pPr>
               <a:defRPr sz="3600" b="1">
                 <a:solidFill>
-                  <a:srgbClr val="F1F5F9"/>
+                  <a:srgbClr val="1E1B4B"/>
                 </a:solidFill>
                 <a:latin typeface="Arial"/>
               </a:defRPr>
@@ -3529,13 +3529,13 @@
               </a:spcAft>
               <a:defRPr sz="1600">
                 <a:solidFill>
-                  <a:srgbClr val="CBD5E1"/>
-                </a:solidFill>
-                <a:latin typeface="Arial"/>
-              </a:defRPr>
-            </a:pPr>
-            <a:r>
-              <a:t>&amp;bull;  Inconsistent Casing: Mixed naming structures (camelCase, PascalCase, lowercase) create style violations and audits complications.</a:t>
+                  <a:srgbClr val="334155"/>
+                </a:solidFill>
+                <a:latin typeface="Arial"/>
+              </a:defRPr>
+            </a:pPr>
+            <a:r>
+              <a:t>•  Inconsistent Casing: Mixed naming structures (camelCase, PascalCase, lowercase) create style violations and audits complications.</a:t>
             </a:r>
           </a:p>
           <a:p>
@@ -3545,13 +3545,13 @@
               </a:spcAft>
               <a:defRPr sz="1600">
                 <a:solidFill>
-                  <a:srgbClr val="CBD5E1"/>
-                </a:solidFill>
-                <a:latin typeface="Arial"/>
-              </a:defRPr>
-            </a:pPr>
-            <a:r>
-              <a:t>&amp;bull;  Legacy Join Syntax: Extensive usage of implicit comma-joins (e.g. FROM TableA, TableB WHERE A.id = B.id) obscures join pathways and increases maintenance overhead.</a:t>
+                  <a:srgbClr val="334155"/>
+                </a:solidFill>
+                <a:latin typeface="Arial"/>
+              </a:defRPr>
+            </a:pPr>
+            <a:r>
+              <a:t>•  Legacy Join Syntax: Extensive usage of implicit comma-joins (e.g. FROM TableA, TableB WHERE A.id = B.id) obscures join pathways and increases maintenance overhead.</a:t>
             </a:r>
           </a:p>
           <a:p>
@@ -3561,13 +3561,13 @@
               </a:spcAft>
               <a:defRPr sz="1600">
                 <a:solidFill>
-                  <a:srgbClr val="CBD5E1"/>
-                </a:solidFill>
-                <a:latin typeface="Arial"/>
-              </a:defRPr>
-            </a:pPr>
-            <a:r>
-              <a:t>&amp;bull;  Complex Subquery Nesting: Deeply nested SELECT projections decrease readability and limit database optimizer index lookup performance.</a:t>
+                  <a:srgbClr val="334155"/>
+                </a:solidFill>
+                <a:latin typeface="Arial"/>
+              </a:defRPr>
+            </a:pPr>
+            <a:r>
+              <a:t>•  Complex Subquery Nesting: Deeply nested SELECT projections decrease readability and limit database optimizer index lookup performance.</a:t>
             </a:r>
           </a:p>
           <a:p>
@@ -3577,13 +3577,13 @@
               </a:spcAft>
               <a:defRPr sz="1600">
                 <a:solidFill>
-                  <a:srgbClr val="CBD5E1"/>
-                </a:solidFill>
-                <a:latin typeface="Arial"/>
-              </a:defRPr>
-            </a:pPr>
-            <a:r>
-              <a:t>&amp;bull;  Cost Inflation: Unrestricted use of SELECT * drives up cloud data processing costs under pay-per-query models.</a:t>
+                  <a:srgbClr val="334155"/>
+                </a:solidFill>
+                <a:latin typeface="Arial"/>
+              </a:defRPr>
+            </a:pPr>
+            <a:r>
+              <a:t>•  Cost Inflation: Unrestricted use of SELECT * drives up cloud data processing costs under pay-per-query models.</a:t>
             </a:r>
           </a:p>
           <a:p>
@@ -3593,13 +3593,13 @@
               </a:spcAft>
               <a:defRPr sz="1600">
                 <a:solidFill>
-                  <a:srgbClr val="CBD5E1"/>
-                </a:solidFill>
-                <a:latin typeface="Arial"/>
-              </a:defRPr>
-            </a:pPr>
-            <a:r>
-              <a:t>&amp;bull;  Validation Vulnerability: Rule-based linters only clean basic whitespace, whereas raw LLM optimization agents can hallucinate and generate syntactically broken SQL queries.</a:t>
+                  <a:srgbClr val="334155"/>
+                </a:solidFill>
+                <a:latin typeface="Arial"/>
+              </a:defRPr>
+            </a:pPr>
+            <a:r>
+              <a:t>•  Validation Vulnerability: Rule-based linters only clean basic whitespace, whereas raw LLM optimization agents can hallucinate and generate syntactically broken SQL queries.</a:t>
             </a:r>
           </a:p>
         </p:txBody>
@@ -3618,7 +3618,7 @@
     <p:bg>
       <p:bgPr>
         <a:solidFill>
-          <a:srgbClr val="0F172A"/>
+          <a:srgbClr val="F8FAFC"/>
         </a:solidFill>
         <a:effectLst/>
       </p:bgPr>
@@ -3655,7 +3655,7 @@
             <a:pPr>
               <a:defRPr sz="3600" b="1">
                 <a:solidFill>
-                  <a:srgbClr val="F1F5F9"/>
+                  <a:srgbClr val="1E1B4B"/>
                 </a:solidFill>
                 <a:latin typeface="Arial"/>
               </a:defRPr>
@@ -3700,12 +3700,12 @@
               </a:defRPr>
             </a:pPr>
             <a:r>
-              <a:t>Python: </a:t>
+              <a:t>•  Python: </a:t>
             </a:r>
             <a:r>
               <a:rPr sz="1600" b="0">
                 <a:solidFill>
-                  <a:srgbClr val="CBD5E1"/>
+                  <a:srgbClr val="334155"/>
                 </a:solidFill>
                 <a:latin typeface="Arial"/>
               </a:rPr>
@@ -3725,12 +3725,12 @@
               </a:defRPr>
             </a:pPr>
             <a:r>
-              <a:t>Streamlit Framework: </a:t>
+              <a:t>•  Streamlit Framework: </a:t>
             </a:r>
             <a:r>
               <a:rPr sz="1600" b="0">
                 <a:solidFill>
-                  <a:srgbClr val="CBD5E1"/>
+                  <a:srgbClr val="334155"/>
                 </a:solidFill>
                 <a:latin typeface="Arial"/>
               </a:rPr>
@@ -3750,16 +3750,16 @@
               </a:defRPr>
             </a:pPr>
             <a:r>
-              <a:t>Google Gemini API (gemini-2.5-flash): </a:t>
+              <a:t>•  Google Gemini API (gemini-2.5-flash): </a:t>
             </a:r>
             <a:r>
               <a:rPr sz="1600" b="0">
                 <a:solidFill>
-                  <a:srgbClr val="CBD5E1"/>
+                  <a:srgbClr val="334155"/>
                 </a:solidFill>
                 <a:latin typeface="Arial"/>
               </a:rPr>
-              <a:t>Serverless AI model utilized for semantic structure refactoring (CTEs, Joins) configured with low temperature (0.1) and few-shot examples.</a:t>
+              <a:t>Serverless AI model utilized for semantic query refactoring (CTEs, Joins) configured with low temperature (0.1) and few-shot examples.</a:t>
             </a:r>
           </a:p>
           <a:p>
@@ -3775,12 +3775,12 @@
               </a:defRPr>
             </a:pPr>
             <a:r>
-              <a:t>sqlglot Parser: </a:t>
+              <a:t>•  sqlglot Parser: </a:t>
             </a:r>
             <a:r>
               <a:rPr sz="1600" b="0">
                 <a:solidFill>
-                  <a:srgbClr val="CBD5E1"/>
+                  <a:srgbClr val="334155"/>
                 </a:solidFill>
                 <a:latin typeface="Arial"/>
               </a:rPr>
@@ -3800,12 +3800,12 @@
               </a:defRPr>
             </a:pPr>
             <a:r>
-              <a:t>difflib: </a:t>
+              <a:t>•  difflib: </a:t>
             </a:r>
             <a:r>
               <a:rPr sz="1600" b="0">
                 <a:solidFill>
-                  <a:srgbClr val="CBD5E1"/>
+                  <a:srgbClr val="334155"/>
                 </a:solidFill>
                 <a:latin typeface="Arial"/>
               </a:rPr>
@@ -3828,7 +3828,7 @@
     <p:bg>
       <p:bgPr>
         <a:solidFill>
-          <a:srgbClr val="0F172A"/>
+          <a:srgbClr val="F8FAFC"/>
         </a:solidFill>
         <a:effectLst/>
       </p:bgPr>
@@ -3865,7 +3865,7 @@
             <a:pPr>
               <a:defRPr sz="3600" b="1">
                 <a:solidFill>
-                  <a:srgbClr val="F1F5F9"/>
+                  <a:srgbClr val="1E1B4B"/>
                 </a:solidFill>
                 <a:latin typeface="Arial"/>
               </a:defRPr>
@@ -3904,7 +3904,7 @@
               </a:spcAft>
               <a:defRPr sz="1800" b="1">
                 <a:solidFill>
-                  <a:srgbClr val="F1F5F9"/>
+                  <a:srgbClr val="1E1B4B"/>
                 </a:solidFill>
                 <a:latin typeface="Arial"/>
               </a:defRPr>
@@ -3920,7 +3920,7 @@
               </a:spcAft>
               <a:defRPr sz="1400">
                 <a:solidFill>
-                  <a:srgbClr val="CBD5E1"/>
+                  <a:srgbClr val="334155"/>
                 </a:solidFill>
                 <a:latin typeface="Arial"/>
               </a:defRPr>
@@ -3936,7 +3936,7 @@
               </a:spcAft>
               <a:defRPr sz="1400">
                 <a:solidFill>
-                  <a:srgbClr val="CBD5E1"/>
+                  <a:srgbClr val="334155"/>
                 </a:solidFill>
                 <a:latin typeface="Arial"/>
               </a:defRPr>
@@ -3952,7 +3952,7 @@
               </a:spcAft>
               <a:defRPr sz="1400">
                 <a:solidFill>
-                  <a:srgbClr val="CBD5E1"/>
+                  <a:srgbClr val="334155"/>
                 </a:solidFill>
                 <a:latin typeface="Arial"/>
               </a:defRPr>
@@ -3968,7 +3968,7 @@
               </a:spcAft>
               <a:defRPr sz="1400">
                 <a:solidFill>
-                  <a:srgbClr val="CBD5E1"/>
+                  <a:srgbClr val="334155"/>
                 </a:solidFill>
                 <a:latin typeface="Arial"/>
               </a:defRPr>
@@ -3984,7 +3984,7 @@
               </a:spcAft>
               <a:defRPr sz="1400">
                 <a:solidFill>
-                  <a:srgbClr val="CBD5E1"/>
+                  <a:srgbClr val="334155"/>
                 </a:solidFill>
                 <a:latin typeface="Arial"/>
               </a:defRPr>
@@ -4000,7 +4000,7 @@
               </a:spcAft>
               <a:defRPr sz="1400">
                 <a:solidFill>
-                  <a:srgbClr val="CBD5E1"/>
+                  <a:srgbClr val="334155"/>
                 </a:solidFill>
                 <a:latin typeface="Arial"/>
               </a:defRPr>
@@ -4025,7 +4025,7 @@
     <p:bg>
       <p:bgPr>
         <a:solidFill>
-          <a:srgbClr val="0F172A"/>
+          <a:srgbClr val="F8FAFC"/>
         </a:solidFill>
         <a:effectLst/>
       </p:bgPr>
@@ -4062,7 +4062,7 @@
             <a:pPr>
               <a:defRPr sz="3600" b="1">
                 <a:solidFill>
-                  <a:srgbClr val="F1F5F9"/>
+                  <a:srgbClr val="1E1B4B"/>
                 </a:solidFill>
                 <a:latin typeface="Arial"/>
               </a:defRPr>
@@ -4107,12 +4107,12 @@
               </a:defRPr>
             </a:pPr>
             <a:r>
-              <a:t>&amp;bull;  Sanitization &amp; Cleaning Module: </a:t>
+              <a:t>•  Sanitization &amp; Cleaning Module: </a:t>
             </a:r>
             <a:r>
               <a:rPr sz="1500" b="0">
                 <a:solidFill>
-                  <a:srgbClr val="CBD5E1"/>
+                  <a:srgbClr val="334155"/>
                 </a:solidFill>
                 <a:latin typeface="Arial"/>
               </a:rPr>
@@ -4132,12 +4132,12 @@
               </a:defRPr>
             </a:pPr>
             <a:r>
-              <a:t>&amp;bull;  Phase 1: Local Linter Module: </a:t>
+              <a:t>•  Phase 1: Local Linter Module: </a:t>
             </a:r>
             <a:r>
               <a:rPr sz="1500" b="0">
                 <a:solidFill>
-                  <a:srgbClr val="CBD5E1"/>
+                  <a:srgbClr val="334155"/>
                 </a:solidFill>
                 <a:latin typeface="Arial"/>
               </a:rPr>
@@ -4157,12 +4157,12 @@
               </a:defRPr>
             </a:pPr>
             <a:r>
-              <a:t>&amp;bull;  Phase 2: AI Refactoring Module: </a:t>
+              <a:t>•  Phase 2: AI Refactoring Module: </a:t>
             </a:r>
             <a:r>
               <a:rPr sz="1500" b="0">
                 <a:solidFill>
-                  <a:srgbClr val="CBD5E1"/>
+                  <a:srgbClr val="334155"/>
                 </a:solidFill>
                 <a:latin typeface="Arial"/>
               </a:rPr>
@@ -4182,12 +4182,12 @@
               </a:defRPr>
             </a:pPr>
             <a:r>
-              <a:t>&amp;bull;  Validation &amp; Critic Module: </a:t>
+              <a:t>•  Validation &amp; Critic Module: </a:t>
             </a:r>
             <a:r>
               <a:rPr sz="1500" b="0">
                 <a:solidFill>
-                  <a:srgbClr val="CBD5E1"/>
+                  <a:srgbClr val="334155"/>
                 </a:solidFill>
                 <a:latin typeface="Arial"/>
               </a:rPr>
@@ -4207,12 +4207,12 @@
               </a:defRPr>
             </a:pPr>
             <a:r>
-              <a:t>&amp;bull;  Interface &amp; Download Module: </a:t>
+              <a:t>•  Interface &amp; Download Module: </a:t>
             </a:r>
             <a:r>
               <a:rPr sz="1500" b="0">
                 <a:solidFill>
-                  <a:srgbClr val="CBD5E1"/>
+                  <a:srgbClr val="334155"/>
                 </a:solidFill>
                 <a:latin typeface="Arial"/>
               </a:rPr>
@@ -4235,7 +4235,7 @@
     <p:bg>
       <p:bgPr>
         <a:solidFill>
-          <a:srgbClr val="0F172A"/>
+          <a:srgbClr val="F8FAFC"/>
         </a:solidFill>
         <a:effectLst/>
       </p:bgPr>
@@ -4272,7 +4272,7 @@
             <a:pPr>
               <a:defRPr sz="3600" b="1">
                 <a:solidFill>
-                  <a:srgbClr val="F1F5F9"/>
+                  <a:srgbClr val="1E1B4B"/>
                 </a:solidFill>
                 <a:latin typeface="Arial"/>
               </a:defRPr>
@@ -4317,12 +4317,12 @@
               </a:defRPr>
             </a:pPr>
             <a:r>
-              <a:t>Cost-Efficiency: </a:t>
+              <a:t>•  Cost-Efficiency: </a:t>
             </a:r>
             <a:r>
               <a:rPr sz="1600" b="0">
                 <a:solidFill>
-                  <a:srgbClr val="CBD5E1"/>
+                  <a:srgbClr val="334155"/>
                 </a:solidFill>
                 <a:latin typeface="Arial"/>
               </a:rPr>
@@ -4342,12 +4342,12 @@
               </a:defRPr>
             </a:pPr>
             <a:r>
-              <a:t>Syntax Security: </a:t>
+              <a:t>•  Syntax Security: </a:t>
             </a:r>
             <a:r>
               <a:rPr sz="1600" b="0">
                 <a:solidFill>
-                  <a:srgbClr val="CBD5E1"/>
+                  <a:srgbClr val="334155"/>
                 </a:solidFill>
                 <a:latin typeface="Arial"/>
               </a:rPr>
@@ -4367,12 +4367,12 @@
               </a:defRPr>
             </a:pPr>
             <a:r>
-              <a:t>Cloud Deployability: </a:t>
+              <a:t>•  Cloud Deployability: </a:t>
             </a:r>
             <a:r>
               <a:rPr sz="1600" b="0">
                 <a:solidFill>
-                  <a:srgbClr val="CBD5E1"/>
+                  <a:srgbClr val="334155"/>
                 </a:solidFill>
                 <a:latin typeface="Arial"/>
               </a:rPr>
@@ -4392,12 +4392,12 @@
               </a:defRPr>
             </a:pPr>
             <a:r>
-              <a:t>Pipeline Integration: </a:t>
+              <a:t>•  Pipeline Integration: </a:t>
             </a:r>
             <a:r>
               <a:rPr sz="1600" b="0">
                 <a:solidFill>
-                  <a:srgbClr val="CBD5E1"/>
+                  <a:srgbClr val="334155"/>
                 </a:solidFill>
                 <a:latin typeface="Arial"/>
               </a:rPr>
@@ -4420,7 +4420,7 @@
     <p:bg>
       <p:bgPr>
         <a:solidFill>
-          <a:srgbClr val="0F172A"/>
+          <a:srgbClr val="F8FAFC"/>
         </a:solidFill>
         <a:effectLst/>
       </p:bgPr>
@@ -4457,7 +4457,7 @@
             <a:pPr>
               <a:defRPr sz="3600" b="1">
                 <a:solidFill>
-                  <a:srgbClr val="F1F5F9"/>
+                  <a:srgbClr val="1E1B4B"/>
                 </a:solidFill>
                 <a:latin typeface="Arial"/>
               </a:defRPr>
@@ -4496,7 +4496,7 @@
               </a:spcAft>
               <a:defRPr sz="2000">
                 <a:solidFill>
-                  <a:srgbClr val="F1F5F9"/>
+                  <a:srgbClr val="1E1B4B"/>
                 </a:solidFill>
                 <a:latin typeface="Arial"/>
               </a:defRPr>
@@ -4512,13 +4512,13 @@
               </a:spcBef>
               <a:defRPr sz="1600">
                 <a:solidFill>
-                  <a:srgbClr val="CBD5E1"/>
-                </a:solidFill>
-                <a:latin typeface="Arial"/>
-              </a:defRPr>
-            </a:pPr>
-            <a:r>
-              <a:t>&amp;bull;  Optimizes developer workflow speed and audit readiness for legacy SQL codebases.</a:t>
+                  <a:srgbClr val="334155"/>
+                </a:solidFill>
+                <a:latin typeface="Arial"/>
+              </a:defRPr>
+            </a:pPr>
+            <a:r>
+              <a:t>•  Optimizes developer workflow speed and audit readiness for legacy SQL codebases.</a:t>
             </a:r>
           </a:p>
           <a:p>
@@ -4528,13 +4528,13 @@
               </a:spcBef>
               <a:defRPr sz="1600">
                 <a:solidFill>
-                  <a:srgbClr val="CBD5E1"/>
-                </a:solidFill>
-                <a:latin typeface="Arial"/>
-              </a:defRPr>
-            </a:pPr>
-            <a:r>
-              <a:t>&amp;bull;  Guarantees compilation integrity through an AST validation loop architecture.</a:t>
+                  <a:srgbClr val="334155"/>
+                </a:solidFill>
+                <a:latin typeface="Arial"/>
+              </a:defRPr>
+            </a:pPr>
+            <a:r>
+              <a:t>•  Guarantees compilation integrity through an AST validation loop architecture.</a:t>
             </a:r>
           </a:p>
           <a:p>
@@ -4544,13 +4544,13 @@
               </a:spcBef>
               <a:defRPr sz="1600">
                 <a:solidFill>
-                  <a:srgbClr val="CBD5E1"/>
-                </a:solidFill>
-                <a:latin typeface="Arial"/>
-              </a:defRPr>
-            </a:pPr>
-            <a:r>
-              <a:t>&amp;bull;  Reduces database runtime search complexity by converting nested subqueries to CTEs and implicit comma-joins to explicit joins.</a:t>
+                  <a:srgbClr val="334155"/>
+                </a:solidFill>
+                <a:latin typeface="Arial"/>
+              </a:defRPr>
+            </a:pPr>
+            <a:r>
+              <a:t>•  Reduces database runtime search complexity by converting nested subqueries to CTEs and implicit comma-joins to explicit joins.</a:t>
             </a:r>
           </a:p>
           <a:p>
@@ -4560,13 +4560,13 @@
               </a:spcBef>
               <a:defRPr sz="1600">
                 <a:solidFill>
-                  <a:srgbClr val="CBD5E1"/>
-                </a:solidFill>
-                <a:latin typeface="Arial"/>
-              </a:defRPr>
-            </a:pPr>
-            <a:r>
-              <a:t>&amp;bull;  Provides a cloud-deployable dashboard and automated CLI script to accommodate any integration pipeline environment.</a:t>
+                  <a:srgbClr val="334155"/>
+                </a:solidFill>
+                <a:latin typeface="Arial"/>
+              </a:defRPr>
+            </a:pPr>
+            <a:r>
+              <a:t>•  Provides a cloud-deployable dashboard and automated CLI script to accommodate any integration pipeline environment.</a:t>
             </a:r>
           </a:p>
         </p:txBody>

</xml_diff>

<commit_message>
Update presentation Presentation.pptx with modern dark cyber theme
</commit_message>
<xml_diff>
--- a/Presentation.pptx
+++ b/Presentation.pptx
@@ -3091,7 +3091,7 @@
     <p:bg>
       <p:bgPr>
         <a:solidFill>
-          <a:srgbClr val="F8FAFC"/>
+          <a:srgbClr val="0B1324"/>
         </a:solidFill>
         <a:effectLst/>
       </p:bgPr>
@@ -3105,13 +3105,56 @@
       <p:grpSpPr/>
       <p:sp>
         <p:nvSpPr>
-          <p:cNvPr id="2" name="TextBox 1"/>
+          <p:cNvPr id="2" name="Rectangle 1"/>
+          <p:cNvSpPr/>
+          <p:nvPr/>
+        </p:nvSpPr>
+        <p:spPr>
+          <a:xfrm>
+            <a:off x="0" y="0"/>
+            <a:ext cx="12188952" cy="91440"/>
+          </a:xfrm>
+          <a:prstGeom prst="rect">
+            <a:avLst/>
+          </a:prstGeom>
+          <a:solidFill>
+            <a:srgbClr val="22D3EE"/>
+          </a:solidFill>
+          <a:ln>
+            <a:noFill/>
+          </a:ln>
+        </p:spPr>
+        <p:style>
+          <a:lnRef idx="1">
+            <a:schemeClr val="accent1"/>
+          </a:lnRef>
+          <a:fillRef idx="3">
+            <a:schemeClr val="accent1"/>
+          </a:fillRef>
+          <a:effectRef idx="2">
+            <a:schemeClr val="accent1"/>
+          </a:effectRef>
+          <a:fontRef idx="minor">
+            <a:schemeClr val="lt1"/>
+          </a:fontRef>
+        </p:style>
+        <p:txBody>
+          <a:bodyPr rtlCol="0" anchor="ctr"/>
+          <a:lstStyle/>
+          <a:p>
+            <a:pPr algn="ctr"/>
+          </a:p>
+        </p:txBody>
+      </p:sp>
+      <p:sp>
+        <p:nvSpPr>
+          <p:cNvPr id="3" name="TextBox 2"/>
           <p:cNvSpPr txBox="1"/>
           <p:nvPr/>
         </p:nvSpPr>
         <p:spPr>
           <a:xfrm>
-            <a:off x="685800" y="1645920"/>
+            <a:off x="685800" y="1371600"/>
             <a:ext cx="10817352" cy="2011680"/>
           </a:xfrm>
           <a:prstGeom prst="rect">
@@ -3120,17 +3163,17 @@
           <a:noFill/>
         </p:spPr>
         <p:txBody>
-          <a:bodyPr wrap="square">
+          <a:bodyPr wrap="square" lIns="0" tIns="0" rIns="0" bIns="0">
             <a:spAutoFit/>
           </a:bodyPr>
           <a:lstStyle/>
           <a:p>
-            <a:pPr algn="l">
-              <a:defRPr sz="5400" b="1">
-                <a:solidFill>
-                  <a:srgbClr val="1E1B4B"/>
-                </a:solidFill>
-                <a:latin typeface="Arial"/>
+            <a:pPr>
+              <a:defRPr sz="5000" b="1">
+                <a:solidFill>
+                  <a:srgbClr val="F8FAFC"/>
+                </a:solidFill>
+                <a:latin typeface="Segoe UI"/>
               </a:defRPr>
             </a:pPr>
             <a:r>
@@ -3138,15 +3181,15 @@
             </a:r>
           </a:p>
           <a:p>
-            <a:pPr algn="l">
+            <a:pPr>
               <a:spcBef>
                 <a:spcPts val="1200"/>
               </a:spcBef>
-              <a:defRPr sz="2200">
-                <a:solidFill>
-                  <a:srgbClr val="0D9488"/>
-                </a:solidFill>
-                <a:latin typeface="Arial"/>
+              <a:defRPr sz="2200" b="1">
+                <a:solidFill>
+                  <a:srgbClr val="22D3EE"/>
+                </a:solidFill>
+                <a:latin typeface="Segoe UI"/>
               </a:defRPr>
             </a:pPr>
             <a:r>
@@ -3157,14 +3200,57 @@
       </p:sp>
       <p:sp>
         <p:nvSpPr>
-          <p:cNvPr id="3" name="TextBox 2"/>
+          <p:cNvPr id="4" name="Rectangle 3"/>
+          <p:cNvSpPr/>
+          <p:nvPr/>
+        </p:nvSpPr>
+        <p:spPr>
+          <a:xfrm>
+            <a:off x="685800" y="3657600"/>
+            <a:ext cx="10817352" cy="18288"/>
+          </a:xfrm>
+          <a:prstGeom prst="rect">
+            <a:avLst/>
+          </a:prstGeom>
+          <a:solidFill>
+            <a:srgbClr val="64748B"/>
+          </a:solidFill>
+          <a:ln>
+            <a:noFill/>
+          </a:ln>
+        </p:spPr>
+        <p:style>
+          <a:lnRef idx="1">
+            <a:schemeClr val="accent1"/>
+          </a:lnRef>
+          <a:fillRef idx="3">
+            <a:schemeClr val="accent1"/>
+          </a:fillRef>
+          <a:effectRef idx="2">
+            <a:schemeClr val="accent1"/>
+          </a:effectRef>
+          <a:fontRef idx="minor">
+            <a:schemeClr val="lt1"/>
+          </a:fontRef>
+        </p:style>
+        <p:txBody>
+          <a:bodyPr rtlCol="0" anchor="ctr"/>
+          <a:lstStyle/>
+          <a:p>
+            <a:pPr algn="ctr"/>
+          </a:p>
+        </p:txBody>
+      </p:sp>
+      <p:sp>
+        <p:nvSpPr>
+          <p:cNvPr id="5" name="TextBox 4"/>
           <p:cNvSpPr txBox="1"/>
           <p:nvPr/>
         </p:nvSpPr>
         <p:spPr>
           <a:xfrm>
-            <a:off x="685800" y="4114800"/>
-            <a:ext cx="9144000" cy="2011680"/>
+            <a:off x="685800" y="3931920"/>
+            <a:ext cx="10817352" cy="2286000"/>
           </a:xfrm>
           <a:prstGeom prst="rect">
             <a:avLst/>
@@ -3172,20 +3258,20 @@
           <a:noFill/>
         </p:spPr>
         <p:txBody>
-          <a:bodyPr wrap="square">
+          <a:bodyPr wrap="square" lIns="0" tIns="0" rIns="0" bIns="0">
             <a:spAutoFit/>
           </a:bodyPr>
           <a:lstStyle/>
           <a:p>
             <a:pPr>
               <a:spcAft>
-                <a:spcPts val="600"/>
+                <a:spcPts val="800"/>
               </a:spcAft>
-              <a:defRPr sz="1400" b="1">
-                <a:solidFill>
-                  <a:srgbClr val="64748B"/>
-                </a:solidFill>
-                <a:latin typeface="Arial"/>
+              <a:defRPr sz="1300" b="1">
+                <a:solidFill>
+                  <a:srgbClr val="22D3EE"/>
+                </a:solidFill>
+                <a:latin typeface="Segoe UI"/>
               </a:defRPr>
             </a:pPr>
             <a:r>
@@ -3195,13 +3281,13 @@
           <a:p>
             <a:pPr>
               <a:spcBef>
-                <a:spcPts val="200"/>
+                <a:spcPts val="300"/>
               </a:spcBef>
-              <a:defRPr sz="1200">
-                <a:solidFill>
-                  <a:srgbClr val="334155"/>
-                </a:solidFill>
-                <a:latin typeface="Arial"/>
+              <a:defRPr sz="1250">
+                <a:solidFill>
+                  <a:srgbClr val="CBD5E1"/>
+                </a:solidFill>
+                <a:latin typeface="Segoe UI"/>
               </a:defRPr>
             </a:pPr>
             <a:r>
@@ -3211,13 +3297,13 @@
           <a:p>
             <a:pPr>
               <a:spcBef>
-                <a:spcPts val="200"/>
+                <a:spcPts val="300"/>
               </a:spcBef>
-              <a:defRPr sz="1200">
-                <a:solidFill>
-                  <a:srgbClr val="334155"/>
-                </a:solidFill>
-                <a:latin typeface="Arial"/>
+              <a:defRPr sz="1250">
+                <a:solidFill>
+                  <a:srgbClr val="CBD5E1"/>
+                </a:solidFill>
+                <a:latin typeface="Segoe UI"/>
               </a:defRPr>
             </a:pPr>
             <a:r>
@@ -3227,13 +3313,13 @@
           <a:p>
             <a:pPr>
               <a:spcBef>
-                <a:spcPts val="200"/>
+                <a:spcPts val="300"/>
               </a:spcBef>
-              <a:defRPr sz="1200">
-                <a:solidFill>
-                  <a:srgbClr val="334155"/>
-                </a:solidFill>
-                <a:latin typeface="Arial"/>
+              <a:defRPr sz="1250">
+                <a:solidFill>
+                  <a:srgbClr val="CBD5E1"/>
+                </a:solidFill>
+                <a:latin typeface="Segoe UI"/>
               </a:defRPr>
             </a:pPr>
             <a:r>
@@ -3243,13 +3329,13 @@
           <a:p>
             <a:pPr>
               <a:spcBef>
-                <a:spcPts val="200"/>
+                <a:spcPts val="300"/>
               </a:spcBef>
-              <a:defRPr sz="1200">
-                <a:solidFill>
-                  <a:srgbClr val="334155"/>
-                </a:solidFill>
-                <a:latin typeface="Arial"/>
+              <a:defRPr sz="1250">
+                <a:solidFill>
+                  <a:srgbClr val="CBD5E1"/>
+                </a:solidFill>
+                <a:latin typeface="Segoe UI"/>
               </a:defRPr>
             </a:pPr>
             <a:r>
@@ -3272,7 +3358,7 @@
     <p:bg>
       <p:bgPr>
         <a:solidFill>
-          <a:srgbClr val="F8FAFC"/>
+          <a:srgbClr val="0B1324"/>
         </a:solidFill>
         <a:effectLst/>
       </p:bgPr>
@@ -3307,11 +3393,11 @@
           <a:lstStyle/>
           <a:p>
             <a:pPr>
-              <a:defRPr sz="3600" b="1">
-                <a:solidFill>
-                  <a:srgbClr val="1E1B4B"/>
-                </a:solidFill>
-                <a:latin typeface="Arial"/>
+              <a:defRPr sz="3200" b="1">
+                <a:solidFill>
+                  <a:srgbClr val="F8FAFC"/>
+                </a:solidFill>
+                <a:latin typeface="Segoe UI"/>
               </a:defRPr>
             </a:pPr>
             <a:r>
@@ -3322,7 +3408,86 @@
       </p:sp>
       <p:sp>
         <p:nvSpPr>
-          <p:cNvPr id="3" name="TextBox 2"/>
+          <p:cNvPr id="3" name="Rectangle 2"/>
+          <p:cNvSpPr/>
+          <p:nvPr/>
+        </p:nvSpPr>
+        <p:spPr>
+          <a:xfrm>
+            <a:off x="685800" y="1188720"/>
+            <a:ext cx="10817352" cy="27432"/>
+          </a:xfrm>
+          <a:prstGeom prst="rect">
+            <a:avLst/>
+          </a:prstGeom>
+          <a:solidFill>
+            <a:srgbClr val="22D3EE"/>
+          </a:solidFill>
+          <a:ln>
+            <a:noFill/>
+          </a:ln>
+        </p:spPr>
+        <p:style>
+          <a:lnRef idx="1">
+            <a:schemeClr val="accent1"/>
+          </a:lnRef>
+          <a:fillRef idx="3">
+            <a:schemeClr val="accent1"/>
+          </a:fillRef>
+          <a:effectRef idx="2">
+            <a:schemeClr val="accent1"/>
+          </a:effectRef>
+          <a:fontRef idx="minor">
+            <a:schemeClr val="lt1"/>
+          </a:fontRef>
+        </p:style>
+        <p:txBody>
+          <a:bodyPr rtlCol="0" anchor="ctr"/>
+          <a:lstStyle/>
+          <a:p>
+            <a:pPr algn="ctr"/>
+          </a:p>
+        </p:txBody>
+      </p:sp>
+      <p:sp>
+        <p:nvSpPr>
+          <p:cNvPr id="4" name="TextBox 3"/>
+          <p:cNvSpPr txBox="1"/>
+          <p:nvPr/>
+        </p:nvSpPr>
+        <p:spPr>
+          <a:xfrm>
+            <a:off x="685800" y="6309360"/>
+            <a:ext cx="10817352" cy="274320"/>
+          </a:xfrm>
+          <a:prstGeom prst="rect">
+            <a:avLst/>
+          </a:prstGeom>
+          <a:noFill/>
+        </p:spPr>
+        <p:txBody>
+          <a:bodyPr wrap="square" lIns="0" tIns="0" rIns="0" bIns="0">
+            <a:spAutoFit/>
+          </a:bodyPr>
+          <a:lstStyle/>
+          <a:p>
+            <a:pPr algn="l">
+              <a:defRPr sz="1000">
+                <a:solidFill>
+                  <a:srgbClr val="64748B"/>
+                </a:solidFill>
+                <a:latin typeface="Segoe UI"/>
+              </a:defRPr>
+            </a:pPr>
+            <a:r>
+              <a:t>SQL Query Linter &amp; Style Fixer  |  Developed by Team 20</a:t>
+            </a:r>
+          </a:p>
+        </p:txBody>
+      </p:sp>
+      <p:sp>
+        <p:nvSpPr>
+          <p:cNvPr id="5" name="TextBox 4"/>
           <p:cNvSpPr txBox="1"/>
           <p:nvPr/>
         </p:nvSpPr>
@@ -3337,20 +3502,20 @@
           <a:noFill/>
         </p:spPr>
         <p:txBody>
-          <a:bodyPr wrap="square">
+          <a:bodyPr wrap="square" lIns="0" tIns="0" rIns="0" bIns="0">
             <a:spAutoFit/>
           </a:bodyPr>
           <a:lstStyle/>
           <a:p>
             <a:pPr>
               <a:spcAft>
-                <a:spcPts val="2400"/>
+                <a:spcPts val="2000"/>
               </a:spcAft>
-              <a:defRPr sz="2000">
-                <a:solidFill>
-                  <a:srgbClr val="334155"/>
-                </a:solidFill>
-                <a:latin typeface="Arial"/>
+              <a:defRPr sz="1900">
+                <a:solidFill>
+                  <a:srgbClr val="CBD5E1"/>
+                </a:solidFill>
+                <a:latin typeface="Segoe UI"/>
               </a:defRPr>
             </a:pPr>
             <a:r>
@@ -3362,11 +3527,11 @@
               <a:spcBef>
                 <a:spcPts val="800"/>
               </a:spcBef>
-              <a:defRPr sz="1600">
-                <a:solidFill>
-                  <a:srgbClr val="334155"/>
-                </a:solidFill>
-                <a:latin typeface="Arial"/>
+              <a:defRPr sz="1500">
+                <a:solidFill>
+                  <a:srgbClr val="CBD5E1"/>
+                </a:solidFill>
+                <a:latin typeface="Segoe UI"/>
               </a:defRPr>
             </a:pPr>
             <a:r>
@@ -3378,11 +3543,11 @@
               <a:spcBef>
                 <a:spcPts val="800"/>
               </a:spcBef>
-              <a:defRPr sz="1600">
-                <a:solidFill>
-                  <a:srgbClr val="334155"/>
-                </a:solidFill>
-                <a:latin typeface="Arial"/>
+              <a:defRPr sz="1500">
+                <a:solidFill>
+                  <a:srgbClr val="CBD5E1"/>
+                </a:solidFill>
+                <a:latin typeface="Segoe UI"/>
               </a:defRPr>
             </a:pPr>
             <a:r>
@@ -3394,11 +3559,11 @@
               <a:spcBef>
                 <a:spcPts val="800"/>
               </a:spcBef>
-              <a:defRPr sz="1600">
-                <a:solidFill>
-                  <a:srgbClr val="334155"/>
-                </a:solidFill>
-                <a:latin typeface="Arial"/>
+              <a:defRPr sz="1500">
+                <a:solidFill>
+                  <a:srgbClr val="CBD5E1"/>
+                </a:solidFill>
+                <a:latin typeface="Segoe UI"/>
               </a:defRPr>
             </a:pPr>
             <a:r>
@@ -3410,11 +3575,11 @@
               <a:spcBef>
                 <a:spcPts val="800"/>
               </a:spcBef>
-              <a:defRPr sz="1600">
-                <a:solidFill>
-                  <a:srgbClr val="334155"/>
-                </a:solidFill>
-                <a:latin typeface="Arial"/>
+              <a:defRPr sz="1500">
+                <a:solidFill>
+                  <a:srgbClr val="CBD5E1"/>
+                </a:solidFill>
+                <a:latin typeface="Segoe UI"/>
               </a:defRPr>
             </a:pPr>
             <a:r>
@@ -3426,11 +3591,11 @@
               <a:spcBef>
                 <a:spcPts val="800"/>
               </a:spcBef>
-              <a:defRPr sz="1600">
-                <a:solidFill>
-                  <a:srgbClr val="334155"/>
-                </a:solidFill>
-                <a:latin typeface="Arial"/>
+              <a:defRPr sz="1500">
+                <a:solidFill>
+                  <a:srgbClr val="CBD5E1"/>
+                </a:solidFill>
+                <a:latin typeface="Segoe UI"/>
               </a:defRPr>
             </a:pPr>
             <a:r>
@@ -3453,7 +3618,7 @@
     <p:bg>
       <p:bgPr>
         <a:solidFill>
-          <a:srgbClr val="F8FAFC"/>
+          <a:srgbClr val="0B1324"/>
         </a:solidFill>
         <a:effectLst/>
       </p:bgPr>
@@ -3488,11 +3653,11 @@
           <a:lstStyle/>
           <a:p>
             <a:pPr>
-              <a:defRPr sz="3600" b="1">
-                <a:solidFill>
-                  <a:srgbClr val="1E1B4B"/>
-                </a:solidFill>
-                <a:latin typeface="Arial"/>
+              <a:defRPr sz="3200" b="1">
+                <a:solidFill>
+                  <a:srgbClr val="F8FAFC"/>
+                </a:solidFill>
+                <a:latin typeface="Segoe UI"/>
               </a:defRPr>
             </a:pPr>
             <a:r>
@@ -3503,7 +3668,86 @@
       </p:sp>
       <p:sp>
         <p:nvSpPr>
-          <p:cNvPr id="3" name="TextBox 2"/>
+          <p:cNvPr id="3" name="Rectangle 2"/>
+          <p:cNvSpPr/>
+          <p:nvPr/>
+        </p:nvSpPr>
+        <p:spPr>
+          <a:xfrm>
+            <a:off x="685800" y="1188720"/>
+            <a:ext cx="10817352" cy="27432"/>
+          </a:xfrm>
+          <a:prstGeom prst="rect">
+            <a:avLst/>
+          </a:prstGeom>
+          <a:solidFill>
+            <a:srgbClr val="22D3EE"/>
+          </a:solidFill>
+          <a:ln>
+            <a:noFill/>
+          </a:ln>
+        </p:spPr>
+        <p:style>
+          <a:lnRef idx="1">
+            <a:schemeClr val="accent1"/>
+          </a:lnRef>
+          <a:fillRef idx="3">
+            <a:schemeClr val="accent1"/>
+          </a:fillRef>
+          <a:effectRef idx="2">
+            <a:schemeClr val="accent1"/>
+          </a:effectRef>
+          <a:fontRef idx="minor">
+            <a:schemeClr val="lt1"/>
+          </a:fontRef>
+        </p:style>
+        <p:txBody>
+          <a:bodyPr rtlCol="0" anchor="ctr"/>
+          <a:lstStyle/>
+          <a:p>
+            <a:pPr algn="ctr"/>
+          </a:p>
+        </p:txBody>
+      </p:sp>
+      <p:sp>
+        <p:nvSpPr>
+          <p:cNvPr id="4" name="TextBox 3"/>
+          <p:cNvSpPr txBox="1"/>
+          <p:nvPr/>
+        </p:nvSpPr>
+        <p:spPr>
+          <a:xfrm>
+            <a:off x="685800" y="6309360"/>
+            <a:ext cx="10817352" cy="274320"/>
+          </a:xfrm>
+          <a:prstGeom prst="rect">
+            <a:avLst/>
+          </a:prstGeom>
+          <a:noFill/>
+        </p:spPr>
+        <p:txBody>
+          <a:bodyPr wrap="square" lIns="0" tIns="0" rIns="0" bIns="0">
+            <a:spAutoFit/>
+          </a:bodyPr>
+          <a:lstStyle/>
+          <a:p>
+            <a:pPr algn="l">
+              <a:defRPr sz="1000">
+                <a:solidFill>
+                  <a:srgbClr val="64748B"/>
+                </a:solidFill>
+                <a:latin typeface="Segoe UI"/>
+              </a:defRPr>
+            </a:pPr>
+            <a:r>
+              <a:t>SQL Query Linter &amp; Style Fixer  |  Developed by Team 20</a:t>
+            </a:r>
+          </a:p>
+        </p:txBody>
+      </p:sp>
+      <p:sp>
+        <p:nvSpPr>
+          <p:cNvPr id="5" name="TextBox 4"/>
           <p:cNvSpPr txBox="1"/>
           <p:nvPr/>
         </p:nvSpPr>
@@ -3518,7 +3762,7 @@
           <a:noFill/>
         </p:spPr>
         <p:txBody>
-          <a:bodyPr wrap="square">
+          <a:bodyPr wrap="square" lIns="0" tIns="0" rIns="0" bIns="0">
             <a:spAutoFit/>
           </a:bodyPr>
           <a:lstStyle/>
@@ -3527,15 +3771,15 @@
               <a:spcAft>
                 <a:spcPts val="1200"/>
               </a:spcAft>
-              <a:defRPr sz="1600">
-                <a:solidFill>
-                  <a:srgbClr val="334155"/>
-                </a:solidFill>
-                <a:latin typeface="Arial"/>
-              </a:defRPr>
-            </a:pPr>
-            <a:r>
-              <a:t>•  Inconsistent Casing: Mixed naming structures (camelCase, PascalCase, lowercase) create style violations and audits complications.</a:t>
+              <a:defRPr sz="1550">
+                <a:solidFill>
+                  <a:srgbClr val="CBD5E1"/>
+                </a:solidFill>
+                <a:latin typeface="Segoe UI"/>
+              </a:defRPr>
+            </a:pPr>
+            <a:r>
+              <a:t>•  Inconsistent Casing: Mixed naming structures (camelCase, PascalCase, lowercase) create style violations and audit complications.</a:t>
             </a:r>
           </a:p>
           <a:p>
@@ -3543,15 +3787,15 @@
               <a:spcAft>
                 <a:spcPts val="1200"/>
               </a:spcAft>
-              <a:defRPr sz="1600">
-                <a:solidFill>
-                  <a:srgbClr val="334155"/>
-                </a:solidFill>
-                <a:latin typeface="Arial"/>
-              </a:defRPr>
-            </a:pPr>
-            <a:r>
-              <a:t>•  Legacy Join Syntax: Extensive usage of implicit comma-joins (e.g. FROM TableA, TableB WHERE A.id = B.id) obscures join pathways and increases maintenance overhead.</a:t>
+              <a:defRPr sz="1550">
+                <a:solidFill>
+                  <a:srgbClr val="CBD5E1"/>
+                </a:solidFill>
+                <a:latin typeface="Segoe UI"/>
+              </a:defRPr>
+            </a:pPr>
+            <a:r>
+              <a:t>•  Legacy Join Syntax: Extensive usage of implicit comma-joins (e.g., FROM TableA, TableB WHERE A.id = B.id) obscures join pathways and increases maintenance overhead.</a:t>
             </a:r>
           </a:p>
           <a:p>
@@ -3559,11 +3803,11 @@
               <a:spcAft>
                 <a:spcPts val="1200"/>
               </a:spcAft>
-              <a:defRPr sz="1600">
-                <a:solidFill>
-                  <a:srgbClr val="334155"/>
-                </a:solidFill>
-                <a:latin typeface="Arial"/>
+              <a:defRPr sz="1550">
+                <a:solidFill>
+                  <a:srgbClr val="CBD5E1"/>
+                </a:solidFill>
+                <a:latin typeface="Segoe UI"/>
               </a:defRPr>
             </a:pPr>
             <a:r>
@@ -3575,11 +3819,11 @@
               <a:spcAft>
                 <a:spcPts val="1200"/>
               </a:spcAft>
-              <a:defRPr sz="1600">
-                <a:solidFill>
-                  <a:srgbClr val="334155"/>
-                </a:solidFill>
-                <a:latin typeface="Arial"/>
+              <a:defRPr sz="1550">
+                <a:solidFill>
+                  <a:srgbClr val="CBD5E1"/>
+                </a:solidFill>
+                <a:latin typeface="Segoe UI"/>
               </a:defRPr>
             </a:pPr>
             <a:r>
@@ -3591,11 +3835,11 @@
               <a:spcAft>
                 <a:spcPts val="1200"/>
               </a:spcAft>
-              <a:defRPr sz="1600">
-                <a:solidFill>
-                  <a:srgbClr val="334155"/>
-                </a:solidFill>
-                <a:latin typeface="Arial"/>
+              <a:defRPr sz="1550">
+                <a:solidFill>
+                  <a:srgbClr val="CBD5E1"/>
+                </a:solidFill>
+                <a:latin typeface="Segoe UI"/>
               </a:defRPr>
             </a:pPr>
             <a:r>
@@ -3618,7 +3862,7 @@
     <p:bg>
       <p:bgPr>
         <a:solidFill>
-          <a:srgbClr val="F8FAFC"/>
+          <a:srgbClr val="0B1324"/>
         </a:solidFill>
         <a:effectLst/>
       </p:bgPr>
@@ -3653,11 +3897,11 @@
           <a:lstStyle/>
           <a:p>
             <a:pPr>
-              <a:defRPr sz="3600" b="1">
-                <a:solidFill>
-                  <a:srgbClr val="1E1B4B"/>
-                </a:solidFill>
-                <a:latin typeface="Arial"/>
+              <a:defRPr sz="3200" b="1">
+                <a:solidFill>
+                  <a:srgbClr val="F8FAFC"/>
+                </a:solidFill>
+                <a:latin typeface="Segoe UI"/>
               </a:defRPr>
             </a:pPr>
             <a:r>
@@ -3668,7 +3912,86 @@
       </p:sp>
       <p:sp>
         <p:nvSpPr>
-          <p:cNvPr id="3" name="TextBox 2"/>
+          <p:cNvPr id="3" name="Rectangle 2"/>
+          <p:cNvSpPr/>
+          <p:nvPr/>
+        </p:nvSpPr>
+        <p:spPr>
+          <a:xfrm>
+            <a:off x="685800" y="1188720"/>
+            <a:ext cx="10817352" cy="27432"/>
+          </a:xfrm>
+          <a:prstGeom prst="rect">
+            <a:avLst/>
+          </a:prstGeom>
+          <a:solidFill>
+            <a:srgbClr val="22D3EE"/>
+          </a:solidFill>
+          <a:ln>
+            <a:noFill/>
+          </a:ln>
+        </p:spPr>
+        <p:style>
+          <a:lnRef idx="1">
+            <a:schemeClr val="accent1"/>
+          </a:lnRef>
+          <a:fillRef idx="3">
+            <a:schemeClr val="accent1"/>
+          </a:fillRef>
+          <a:effectRef idx="2">
+            <a:schemeClr val="accent1"/>
+          </a:effectRef>
+          <a:fontRef idx="minor">
+            <a:schemeClr val="lt1"/>
+          </a:fontRef>
+        </p:style>
+        <p:txBody>
+          <a:bodyPr rtlCol="0" anchor="ctr"/>
+          <a:lstStyle/>
+          <a:p>
+            <a:pPr algn="ctr"/>
+          </a:p>
+        </p:txBody>
+      </p:sp>
+      <p:sp>
+        <p:nvSpPr>
+          <p:cNvPr id="4" name="TextBox 3"/>
+          <p:cNvSpPr txBox="1"/>
+          <p:nvPr/>
+        </p:nvSpPr>
+        <p:spPr>
+          <a:xfrm>
+            <a:off x="685800" y="6309360"/>
+            <a:ext cx="10817352" cy="274320"/>
+          </a:xfrm>
+          <a:prstGeom prst="rect">
+            <a:avLst/>
+          </a:prstGeom>
+          <a:noFill/>
+        </p:spPr>
+        <p:txBody>
+          <a:bodyPr wrap="square" lIns="0" tIns="0" rIns="0" bIns="0">
+            <a:spAutoFit/>
+          </a:bodyPr>
+          <a:lstStyle/>
+          <a:p>
+            <a:pPr algn="l">
+              <a:defRPr sz="1000">
+                <a:solidFill>
+                  <a:srgbClr val="64748B"/>
+                </a:solidFill>
+                <a:latin typeface="Segoe UI"/>
+              </a:defRPr>
+            </a:pPr>
+            <a:r>
+              <a:t>SQL Query Linter &amp; Style Fixer  |  Developed by Team 20</a:t>
+            </a:r>
+          </a:p>
+        </p:txBody>
+      </p:sp>
+      <p:sp>
+        <p:nvSpPr>
+          <p:cNvPr id="5" name="TextBox 4"/>
           <p:cNvSpPr txBox="1"/>
           <p:nvPr/>
         </p:nvSpPr>
@@ -3683,31 +4006,31 @@
           <a:noFill/>
         </p:spPr>
         <p:txBody>
-          <a:bodyPr wrap="square">
+          <a:bodyPr wrap="square" lIns="0" tIns="0" rIns="0" bIns="0">
             <a:spAutoFit/>
           </a:bodyPr>
           <a:lstStyle/>
           <a:p>
             <a:pPr>
               <a:spcAft>
-                <a:spcPts val="1200"/>
+                <a:spcPts val="1000"/>
               </a:spcAft>
-              <a:defRPr sz="1600" b="1">
-                <a:solidFill>
-                  <a:srgbClr val="0D9488"/>
-                </a:solidFill>
-                <a:latin typeface="Arial"/>
+              <a:defRPr sz="1550" b="1">
+                <a:solidFill>
+                  <a:srgbClr val="22D3EE"/>
+                </a:solidFill>
+                <a:latin typeface="Segoe UI"/>
               </a:defRPr>
             </a:pPr>
             <a:r>
               <a:t>•  Python: </a:t>
             </a:r>
             <a:r>
-              <a:rPr sz="1600" b="0">
-                <a:solidFill>
-                  <a:srgbClr val="334155"/>
-                </a:solidFill>
-                <a:latin typeface="Arial"/>
+              <a:rPr sz="1550" b="0">
+                <a:solidFill>
+                  <a:srgbClr val="CBD5E1"/>
+                </a:solidFill>
+                <a:latin typeface="Segoe UI"/>
               </a:rPr>
               <a:t>Core language for deterministic regex compilation, script execution, and API routing.</a:t>
             </a:r>
@@ -3715,24 +4038,24 @@
           <a:p>
             <a:pPr>
               <a:spcAft>
-                <a:spcPts val="1200"/>
+                <a:spcPts val="1000"/>
               </a:spcAft>
-              <a:defRPr sz="1600" b="1">
-                <a:solidFill>
-                  <a:srgbClr val="0D9488"/>
-                </a:solidFill>
-                <a:latin typeface="Arial"/>
+              <a:defRPr sz="1550" b="1">
+                <a:solidFill>
+                  <a:srgbClr val="22D3EE"/>
+                </a:solidFill>
+                <a:latin typeface="Segoe UI"/>
               </a:defRPr>
             </a:pPr>
             <a:r>
               <a:t>•  Streamlit Framework: </a:t>
             </a:r>
             <a:r>
-              <a:rPr sz="1600" b="0">
-                <a:solidFill>
-                  <a:srgbClr val="334155"/>
-                </a:solidFill>
-                <a:latin typeface="Arial"/>
+              <a:rPr sz="1550" b="0">
+                <a:solidFill>
+                  <a:srgbClr val="CBD5E1"/>
+                </a:solidFill>
+                <a:latin typeface="Segoe UI"/>
               </a:rPr>
               <a:t>For designing the user interface dashboard workspace, the batch file uploader, and in-memory downloads.</a:t>
             </a:r>
@@ -3740,24 +4063,24 @@
           <a:p>
             <a:pPr>
               <a:spcAft>
-                <a:spcPts val="1200"/>
+                <a:spcPts val="1000"/>
               </a:spcAft>
-              <a:defRPr sz="1600" b="1">
-                <a:solidFill>
-                  <a:srgbClr val="0D9488"/>
-                </a:solidFill>
-                <a:latin typeface="Arial"/>
+              <a:defRPr sz="1550" b="1">
+                <a:solidFill>
+                  <a:srgbClr val="22D3EE"/>
+                </a:solidFill>
+                <a:latin typeface="Segoe UI"/>
               </a:defRPr>
             </a:pPr>
             <a:r>
               <a:t>•  Google Gemini API (gemini-2.5-flash): </a:t>
             </a:r>
             <a:r>
-              <a:rPr sz="1600" b="0">
-                <a:solidFill>
-                  <a:srgbClr val="334155"/>
-                </a:solidFill>
-                <a:latin typeface="Arial"/>
+              <a:rPr sz="1550" b="0">
+                <a:solidFill>
+                  <a:srgbClr val="CBD5E1"/>
+                </a:solidFill>
+                <a:latin typeface="Segoe UI"/>
               </a:rPr>
               <a:t>Serverless AI model utilized for semantic query refactoring (CTEs, Joins) configured with low temperature (0.1) and few-shot examples.</a:t>
             </a:r>
@@ -3765,24 +4088,24 @@
           <a:p>
             <a:pPr>
               <a:spcAft>
-                <a:spcPts val="1200"/>
+                <a:spcPts val="1000"/>
               </a:spcAft>
-              <a:defRPr sz="1600" b="1">
-                <a:solidFill>
-                  <a:srgbClr val="0D9488"/>
-                </a:solidFill>
-                <a:latin typeface="Arial"/>
+              <a:defRPr sz="1550" b="1">
+                <a:solidFill>
+                  <a:srgbClr val="22D3EE"/>
+                </a:solidFill>
+                <a:latin typeface="Segoe UI"/>
               </a:defRPr>
             </a:pPr>
             <a:r>
               <a:t>•  sqlglot Parser: </a:t>
             </a:r>
             <a:r>
-              <a:rPr sz="1600" b="0">
-                <a:solidFill>
-                  <a:srgbClr val="334155"/>
-                </a:solidFill>
-                <a:latin typeface="Arial"/>
+              <a:rPr sz="1550" b="0">
+                <a:solidFill>
+                  <a:srgbClr val="CBD5E1"/>
+                </a:solidFill>
+                <a:latin typeface="Segoe UI"/>
               </a:rPr>
               <a:t>Local dialect-aware parser used to pretty-print statements and validate AST syntax inside the correction loop.</a:t>
             </a:r>
@@ -3790,24 +4113,24 @@
           <a:p>
             <a:pPr>
               <a:spcAft>
-                <a:spcPts val="1200"/>
+                <a:spcPts val="1000"/>
               </a:spcAft>
-              <a:defRPr sz="1600" b="1">
-                <a:solidFill>
-                  <a:srgbClr val="0D9488"/>
-                </a:solidFill>
-                <a:latin typeface="Arial"/>
+              <a:defRPr sz="1550" b="1">
+                <a:solidFill>
+                  <a:srgbClr val="22D3EE"/>
+                </a:solidFill>
+                <a:latin typeface="Segoe UI"/>
               </a:defRPr>
             </a:pPr>
             <a:r>
               <a:t>•  difflib: </a:t>
             </a:r>
             <a:r>
-              <a:rPr sz="1600" b="0">
-                <a:solidFill>
-                  <a:srgbClr val="334155"/>
-                </a:solidFill>
-                <a:latin typeface="Arial"/>
+              <a:rPr sz="1550" b="0">
+                <a:solidFill>
+                  <a:srgbClr val="CBD5E1"/>
+                </a:solidFill>
+                <a:latin typeface="Segoe UI"/>
               </a:rPr>
               <a:t>Native engine used to compile unified diff reports between raw query inputs and optimized outputs.</a:t>
             </a:r>
@@ -3828,7 +4151,7 @@
     <p:bg>
       <p:bgPr>
         <a:solidFill>
-          <a:srgbClr val="F8FAFC"/>
+          <a:srgbClr val="0B1324"/>
         </a:solidFill>
         <a:effectLst/>
       </p:bgPr>
@@ -3863,11 +4186,11 @@
           <a:lstStyle/>
           <a:p>
             <a:pPr>
-              <a:defRPr sz="3600" b="1">
-                <a:solidFill>
-                  <a:srgbClr val="1E1B4B"/>
-                </a:solidFill>
-                <a:latin typeface="Arial"/>
+              <a:defRPr sz="3200" b="1">
+                <a:solidFill>
+                  <a:srgbClr val="F8FAFC"/>
+                </a:solidFill>
+                <a:latin typeface="Segoe UI"/>
               </a:defRPr>
             </a:pPr>
             <a:r>
@@ -3878,7 +4201,86 @@
       </p:sp>
       <p:sp>
         <p:nvSpPr>
-          <p:cNvPr id="3" name="TextBox 2"/>
+          <p:cNvPr id="3" name="Rectangle 2"/>
+          <p:cNvSpPr/>
+          <p:nvPr/>
+        </p:nvSpPr>
+        <p:spPr>
+          <a:xfrm>
+            <a:off x="685800" y="1188720"/>
+            <a:ext cx="10817352" cy="27432"/>
+          </a:xfrm>
+          <a:prstGeom prst="rect">
+            <a:avLst/>
+          </a:prstGeom>
+          <a:solidFill>
+            <a:srgbClr val="22D3EE"/>
+          </a:solidFill>
+          <a:ln>
+            <a:noFill/>
+          </a:ln>
+        </p:spPr>
+        <p:style>
+          <a:lnRef idx="1">
+            <a:schemeClr val="accent1"/>
+          </a:lnRef>
+          <a:fillRef idx="3">
+            <a:schemeClr val="accent1"/>
+          </a:fillRef>
+          <a:effectRef idx="2">
+            <a:schemeClr val="accent1"/>
+          </a:effectRef>
+          <a:fontRef idx="minor">
+            <a:schemeClr val="lt1"/>
+          </a:fontRef>
+        </p:style>
+        <p:txBody>
+          <a:bodyPr rtlCol="0" anchor="ctr"/>
+          <a:lstStyle/>
+          <a:p>
+            <a:pPr algn="ctr"/>
+          </a:p>
+        </p:txBody>
+      </p:sp>
+      <p:sp>
+        <p:nvSpPr>
+          <p:cNvPr id="4" name="TextBox 3"/>
+          <p:cNvSpPr txBox="1"/>
+          <p:nvPr/>
+        </p:nvSpPr>
+        <p:spPr>
+          <a:xfrm>
+            <a:off x="685800" y="6309360"/>
+            <a:ext cx="10817352" cy="274320"/>
+          </a:xfrm>
+          <a:prstGeom prst="rect">
+            <a:avLst/>
+          </a:prstGeom>
+          <a:noFill/>
+        </p:spPr>
+        <p:txBody>
+          <a:bodyPr wrap="square" lIns="0" tIns="0" rIns="0" bIns="0">
+            <a:spAutoFit/>
+          </a:bodyPr>
+          <a:lstStyle/>
+          <a:p>
+            <a:pPr algn="l">
+              <a:defRPr sz="1000">
+                <a:solidFill>
+                  <a:srgbClr val="64748B"/>
+                </a:solidFill>
+                <a:latin typeface="Segoe UI"/>
+              </a:defRPr>
+            </a:pPr>
+            <a:r>
+              <a:t>SQL Query Linter &amp; Style Fixer  |  Developed by Team 20</a:t>
+            </a:r>
+          </a:p>
+        </p:txBody>
+      </p:sp>
+      <p:sp>
+        <p:nvSpPr>
+          <p:cNvPr id="5" name="TextBox 4"/>
           <p:cNvSpPr txBox="1"/>
           <p:nvPr/>
         </p:nvSpPr>
@@ -3893,7 +4295,7 @@
           <a:noFill/>
         </p:spPr>
         <p:txBody>
-          <a:bodyPr wrap="square">
+          <a:bodyPr wrap="square" lIns="0" tIns="0" rIns="0" bIns="0">
             <a:spAutoFit/>
           </a:bodyPr>
           <a:lstStyle/>
@@ -3902,11 +4304,11 @@
               <a:spcAft>
                 <a:spcPts val="1600"/>
               </a:spcAft>
-              <a:defRPr sz="1800" b="1">
-                <a:solidFill>
-                  <a:srgbClr val="1E1B4B"/>
-                </a:solidFill>
-                <a:latin typeface="Arial"/>
+              <a:defRPr sz="1700" b="1">
+                <a:solidFill>
+                  <a:srgbClr val="22D3EE"/>
+                </a:solidFill>
+                <a:latin typeface="Segoe UI"/>
               </a:defRPr>
             </a:pPr>
             <a:r>
@@ -3920,9 +4322,9 @@
               </a:spcAft>
               <a:defRPr sz="1400">
                 <a:solidFill>
-                  <a:srgbClr val="334155"/>
-                </a:solidFill>
-                <a:latin typeface="Arial"/>
+                  <a:srgbClr val="CBD5E1"/>
+                </a:solidFill>
+                <a:latin typeface="Segoe UI"/>
               </a:defRPr>
             </a:pPr>
             <a:r>
@@ -3936,9 +4338,9 @@
               </a:spcAft>
               <a:defRPr sz="1400">
                 <a:solidFill>
-                  <a:srgbClr val="334155"/>
-                </a:solidFill>
-                <a:latin typeface="Arial"/>
+                  <a:srgbClr val="CBD5E1"/>
+                </a:solidFill>
+                <a:latin typeface="Segoe UI"/>
               </a:defRPr>
             </a:pPr>
             <a:r>
@@ -3952,9 +4354,9 @@
               </a:spcAft>
               <a:defRPr sz="1400">
                 <a:solidFill>
-                  <a:srgbClr val="334155"/>
-                </a:solidFill>
-                <a:latin typeface="Arial"/>
+                  <a:srgbClr val="CBD5E1"/>
+                </a:solidFill>
+                <a:latin typeface="Segoe UI"/>
               </a:defRPr>
             </a:pPr>
             <a:r>
@@ -3968,9 +4370,9 @@
               </a:spcAft>
               <a:defRPr sz="1400">
                 <a:solidFill>
-                  <a:srgbClr val="334155"/>
-                </a:solidFill>
-                <a:latin typeface="Arial"/>
+                  <a:srgbClr val="CBD5E1"/>
+                </a:solidFill>
+                <a:latin typeface="Segoe UI"/>
               </a:defRPr>
             </a:pPr>
             <a:r>
@@ -3984,9 +4386,9 @@
               </a:spcAft>
               <a:defRPr sz="1400">
                 <a:solidFill>
-                  <a:srgbClr val="334155"/>
-                </a:solidFill>
-                <a:latin typeface="Arial"/>
+                  <a:srgbClr val="CBD5E1"/>
+                </a:solidFill>
+                <a:latin typeface="Segoe UI"/>
               </a:defRPr>
             </a:pPr>
             <a:r>
@@ -4000,9 +4402,9 @@
               </a:spcAft>
               <a:defRPr sz="1400">
                 <a:solidFill>
-                  <a:srgbClr val="334155"/>
-                </a:solidFill>
-                <a:latin typeface="Arial"/>
+                  <a:srgbClr val="CBD5E1"/>
+                </a:solidFill>
+                <a:latin typeface="Segoe UI"/>
               </a:defRPr>
             </a:pPr>
             <a:r>
@@ -4025,7 +4427,7 @@
     <p:bg>
       <p:bgPr>
         <a:solidFill>
-          <a:srgbClr val="F8FAFC"/>
+          <a:srgbClr val="0B1324"/>
         </a:solidFill>
         <a:effectLst/>
       </p:bgPr>
@@ -4060,11 +4462,11 @@
           <a:lstStyle/>
           <a:p>
             <a:pPr>
-              <a:defRPr sz="3600" b="1">
-                <a:solidFill>
-                  <a:srgbClr val="1E1B4B"/>
-                </a:solidFill>
-                <a:latin typeface="Arial"/>
+              <a:defRPr sz="3200" b="1">
+                <a:solidFill>
+                  <a:srgbClr val="F8FAFC"/>
+                </a:solidFill>
+                <a:latin typeface="Segoe UI"/>
               </a:defRPr>
             </a:pPr>
             <a:r>
@@ -4075,7 +4477,86 @@
       </p:sp>
       <p:sp>
         <p:nvSpPr>
-          <p:cNvPr id="3" name="TextBox 2"/>
+          <p:cNvPr id="3" name="Rectangle 2"/>
+          <p:cNvSpPr/>
+          <p:nvPr/>
+        </p:nvSpPr>
+        <p:spPr>
+          <a:xfrm>
+            <a:off x="685800" y="1188720"/>
+            <a:ext cx="10817352" cy="27432"/>
+          </a:xfrm>
+          <a:prstGeom prst="rect">
+            <a:avLst/>
+          </a:prstGeom>
+          <a:solidFill>
+            <a:srgbClr val="22D3EE"/>
+          </a:solidFill>
+          <a:ln>
+            <a:noFill/>
+          </a:ln>
+        </p:spPr>
+        <p:style>
+          <a:lnRef idx="1">
+            <a:schemeClr val="accent1"/>
+          </a:lnRef>
+          <a:fillRef idx="3">
+            <a:schemeClr val="accent1"/>
+          </a:fillRef>
+          <a:effectRef idx="2">
+            <a:schemeClr val="accent1"/>
+          </a:effectRef>
+          <a:fontRef idx="minor">
+            <a:schemeClr val="lt1"/>
+          </a:fontRef>
+        </p:style>
+        <p:txBody>
+          <a:bodyPr rtlCol="0" anchor="ctr"/>
+          <a:lstStyle/>
+          <a:p>
+            <a:pPr algn="ctr"/>
+          </a:p>
+        </p:txBody>
+      </p:sp>
+      <p:sp>
+        <p:nvSpPr>
+          <p:cNvPr id="4" name="TextBox 3"/>
+          <p:cNvSpPr txBox="1"/>
+          <p:nvPr/>
+        </p:nvSpPr>
+        <p:spPr>
+          <a:xfrm>
+            <a:off x="685800" y="6309360"/>
+            <a:ext cx="10817352" cy="274320"/>
+          </a:xfrm>
+          <a:prstGeom prst="rect">
+            <a:avLst/>
+          </a:prstGeom>
+          <a:noFill/>
+        </p:spPr>
+        <p:txBody>
+          <a:bodyPr wrap="square" lIns="0" tIns="0" rIns="0" bIns="0">
+            <a:spAutoFit/>
+          </a:bodyPr>
+          <a:lstStyle/>
+          <a:p>
+            <a:pPr algn="l">
+              <a:defRPr sz="1000">
+                <a:solidFill>
+                  <a:srgbClr val="64748B"/>
+                </a:solidFill>
+                <a:latin typeface="Segoe UI"/>
+              </a:defRPr>
+            </a:pPr>
+            <a:r>
+              <a:t>SQL Query Linter &amp; Style Fixer  |  Developed by Team 20</a:t>
+            </a:r>
+          </a:p>
+        </p:txBody>
+      </p:sp>
+      <p:sp>
+        <p:nvSpPr>
+          <p:cNvPr id="5" name="TextBox 4"/>
           <p:cNvSpPr txBox="1"/>
           <p:nvPr/>
         </p:nvSpPr>
@@ -4090,7 +4571,7 @@
           <a:noFill/>
         </p:spPr>
         <p:txBody>
-          <a:bodyPr wrap="square">
+          <a:bodyPr wrap="square" lIns="0" tIns="0" rIns="0" bIns="0">
             <a:spAutoFit/>
           </a:bodyPr>
           <a:lstStyle/>
@@ -4101,9 +4582,9 @@
               </a:spcAft>
               <a:defRPr sz="1500" b="1">
                 <a:solidFill>
-                  <a:srgbClr val="0D9488"/>
-                </a:solidFill>
-                <a:latin typeface="Arial"/>
+                  <a:srgbClr val="22D3EE"/>
+                </a:solidFill>
+                <a:latin typeface="Segoe UI"/>
               </a:defRPr>
             </a:pPr>
             <a:r>
@@ -4112,9 +4593,9 @@
             <a:r>
               <a:rPr sz="1500" b="0">
                 <a:solidFill>
-                  <a:srgbClr val="334155"/>
-                </a:solidFill>
-                <a:latin typeface="Arial"/>
+                  <a:srgbClr val="CBD5E1"/>
+                </a:solidFill>
+                <a:latin typeface="Segoe UI"/>
               </a:rPr>
               <a:t>Contains lookbehind/lookahead regular expressions that clean styling artifacts from incoming text without corrupting snake_case columns.</a:t>
             </a:r>
@@ -4126,9 +4607,9 @@
               </a:spcAft>
               <a:defRPr sz="1500" b="1">
                 <a:solidFill>
-                  <a:srgbClr val="0D9488"/>
-                </a:solidFill>
-                <a:latin typeface="Arial"/>
+                  <a:srgbClr val="22D3EE"/>
+                </a:solidFill>
+                <a:latin typeface="Segoe UI"/>
               </a:defRPr>
             </a:pPr>
             <a:r>
@@ -4137,9 +4618,9 @@
             <a:r>
               <a:rPr sz="1500" b="0">
                 <a:solidFill>
-                  <a:srgbClr val="334155"/>
-                </a:solidFill>
-                <a:latin typeface="Arial"/>
+                  <a:srgbClr val="CBD5E1"/>
+                </a:solidFill>
+                <a:latin typeface="Segoe UI"/>
               </a:rPr>
               <a:t>Zero-cost deterministic casing cleaner and capitalization compiler. Enforces standard keywords and casing conventions locally before network calls.</a:t>
             </a:r>
@@ -4151,9 +4632,9 @@
               </a:spcAft>
               <a:defRPr sz="1500" b="1">
                 <a:solidFill>
-                  <a:srgbClr val="0D9488"/>
-                </a:solidFill>
-                <a:latin typeface="Arial"/>
+                  <a:srgbClr val="22D3EE"/>
+                </a:solidFill>
+                <a:latin typeface="Segoe UI"/>
               </a:defRPr>
             </a:pPr>
             <a:r>
@@ -4162,9 +4643,9 @@
             <a:r>
               <a:rPr sz="1500" b="0">
                 <a:solidFill>
-                  <a:srgbClr val="334155"/>
-                </a:solidFill>
-                <a:latin typeface="Arial"/>
+                  <a:srgbClr val="CBD5E1"/>
+                </a:solidFill>
+                <a:latin typeface="Segoe UI"/>
               </a:rPr>
               <a:t>Leverages Gemini LLM with few-shot instructions to translate legacy comma-joins and extract subqueries into CTEs.</a:t>
             </a:r>
@@ -4176,9 +4657,9 @@
               </a:spcAft>
               <a:defRPr sz="1500" b="1">
                 <a:solidFill>
-                  <a:srgbClr val="0D9488"/>
-                </a:solidFill>
-                <a:latin typeface="Arial"/>
+                  <a:srgbClr val="22D3EE"/>
+                </a:solidFill>
+                <a:latin typeface="Segoe UI"/>
               </a:defRPr>
             </a:pPr>
             <a:r>
@@ -4187,9 +4668,9 @@
             <a:r>
               <a:rPr sz="1500" b="0">
                 <a:solidFill>
-                  <a:srgbClr val="334155"/>
-                </a:solidFill>
-                <a:latin typeface="Arial"/>
+                  <a:srgbClr val="CBD5E1"/>
+                </a:solidFill>
+                <a:latin typeface="Segoe UI"/>
               </a:rPr>
               <a:t>Compares LLM outputs against local syntax rules using sqlglot, orchestrating the self-correcting logic loop if discrepancies are found.</a:t>
             </a:r>
@@ -4201,9 +4682,9 @@
               </a:spcAft>
               <a:defRPr sz="1500" b="1">
                 <a:solidFill>
-                  <a:srgbClr val="0D9488"/>
-                </a:solidFill>
-                <a:latin typeface="Arial"/>
+                  <a:srgbClr val="22D3EE"/>
+                </a:solidFill>
+                <a:latin typeface="Segoe UI"/>
               </a:defRPr>
             </a:pPr>
             <a:r>
@@ -4212,9 +4693,9 @@
             <a:r>
               <a:rPr sz="1500" b="0">
                 <a:solidFill>
-                  <a:srgbClr val="334155"/>
-                </a:solidFill>
-                <a:latin typeface="Arial"/>
+                  <a:srgbClr val="CBD5E1"/>
+                </a:solidFill>
+                <a:latin typeface="Segoe UI"/>
               </a:rPr>
               <a:t>Manages dual Streamlit and CLI interfaces, in-memory uploads, diff blocks rendering, and download actions.</a:t>
             </a:r>
@@ -4235,7 +4716,7 @@
     <p:bg>
       <p:bgPr>
         <a:solidFill>
-          <a:srgbClr val="F8FAFC"/>
+          <a:srgbClr val="0B1324"/>
         </a:solidFill>
         <a:effectLst/>
       </p:bgPr>
@@ -4270,11 +4751,11 @@
           <a:lstStyle/>
           <a:p>
             <a:pPr>
-              <a:defRPr sz="3600" b="1">
-                <a:solidFill>
-                  <a:srgbClr val="1E1B4B"/>
-                </a:solidFill>
-                <a:latin typeface="Arial"/>
+              <a:defRPr sz="3200" b="1">
+                <a:solidFill>
+                  <a:srgbClr val="F8FAFC"/>
+                </a:solidFill>
+                <a:latin typeface="Segoe UI"/>
               </a:defRPr>
             </a:pPr>
             <a:r>
@@ -4285,7 +4766,86 @@
       </p:sp>
       <p:sp>
         <p:nvSpPr>
-          <p:cNvPr id="3" name="TextBox 2"/>
+          <p:cNvPr id="3" name="Rectangle 2"/>
+          <p:cNvSpPr/>
+          <p:nvPr/>
+        </p:nvSpPr>
+        <p:spPr>
+          <a:xfrm>
+            <a:off x="685800" y="1188720"/>
+            <a:ext cx="10817352" cy="27432"/>
+          </a:xfrm>
+          <a:prstGeom prst="rect">
+            <a:avLst/>
+          </a:prstGeom>
+          <a:solidFill>
+            <a:srgbClr val="22D3EE"/>
+          </a:solidFill>
+          <a:ln>
+            <a:noFill/>
+          </a:ln>
+        </p:spPr>
+        <p:style>
+          <a:lnRef idx="1">
+            <a:schemeClr val="accent1"/>
+          </a:lnRef>
+          <a:fillRef idx="3">
+            <a:schemeClr val="accent1"/>
+          </a:fillRef>
+          <a:effectRef idx="2">
+            <a:schemeClr val="accent1"/>
+          </a:effectRef>
+          <a:fontRef idx="minor">
+            <a:schemeClr val="lt1"/>
+          </a:fontRef>
+        </p:style>
+        <p:txBody>
+          <a:bodyPr rtlCol="0" anchor="ctr"/>
+          <a:lstStyle/>
+          <a:p>
+            <a:pPr algn="ctr"/>
+          </a:p>
+        </p:txBody>
+      </p:sp>
+      <p:sp>
+        <p:nvSpPr>
+          <p:cNvPr id="4" name="TextBox 3"/>
+          <p:cNvSpPr txBox="1"/>
+          <p:nvPr/>
+        </p:nvSpPr>
+        <p:spPr>
+          <a:xfrm>
+            <a:off x="685800" y="6309360"/>
+            <a:ext cx="10817352" cy="274320"/>
+          </a:xfrm>
+          <a:prstGeom prst="rect">
+            <a:avLst/>
+          </a:prstGeom>
+          <a:noFill/>
+        </p:spPr>
+        <p:txBody>
+          <a:bodyPr wrap="square" lIns="0" tIns="0" rIns="0" bIns="0">
+            <a:spAutoFit/>
+          </a:bodyPr>
+          <a:lstStyle/>
+          <a:p>
+            <a:pPr algn="l">
+              <a:defRPr sz="1000">
+                <a:solidFill>
+                  <a:srgbClr val="64748B"/>
+                </a:solidFill>
+                <a:latin typeface="Segoe UI"/>
+              </a:defRPr>
+            </a:pPr>
+            <a:r>
+              <a:t>SQL Query Linter &amp; Style Fixer  |  Developed by Team 20</a:t>
+            </a:r>
+          </a:p>
+        </p:txBody>
+      </p:sp>
+      <p:sp>
+        <p:nvSpPr>
+          <p:cNvPr id="5" name="TextBox 4"/>
           <p:cNvSpPr txBox="1"/>
           <p:nvPr/>
         </p:nvSpPr>
@@ -4300,7 +4860,7 @@
           <a:noFill/>
         </p:spPr>
         <p:txBody>
-          <a:bodyPr wrap="square">
+          <a:bodyPr wrap="square" lIns="0" tIns="0" rIns="0" bIns="0">
             <a:spAutoFit/>
           </a:bodyPr>
           <a:lstStyle/>
@@ -4309,22 +4869,22 @@
               <a:spcAft>
                 <a:spcPts val="1200"/>
               </a:spcAft>
-              <a:defRPr sz="1600" b="1">
-                <a:solidFill>
-                  <a:srgbClr val="0D9488"/>
-                </a:solidFill>
-                <a:latin typeface="Arial"/>
+              <a:defRPr sz="1550" b="1">
+                <a:solidFill>
+                  <a:srgbClr val="22D3EE"/>
+                </a:solidFill>
+                <a:latin typeface="Segoe UI"/>
               </a:defRPr>
             </a:pPr>
             <a:r>
               <a:t>•  Cost-Efficiency: </a:t>
             </a:r>
             <a:r>
-              <a:rPr sz="1600" b="0">
-                <a:solidFill>
-                  <a:srgbClr val="334155"/>
-                </a:solidFill>
-                <a:latin typeface="Arial"/>
+              <a:rPr sz="1550" b="0">
+                <a:solidFill>
+                  <a:srgbClr val="CBD5E1"/>
+                </a:solidFill>
+                <a:latin typeface="Segoe UI"/>
               </a:rPr>
               <a:t>Capitalization and casing rules run locally at zero token cost, conserving expensive LLM API bandwidth for semantic restructuring tasks.</a:t>
             </a:r>
@@ -4334,22 +4894,22 @@
               <a:spcAft>
                 <a:spcPts val="1200"/>
               </a:spcAft>
-              <a:defRPr sz="1600" b="1">
-                <a:solidFill>
-                  <a:srgbClr val="0D9488"/>
-                </a:solidFill>
-                <a:latin typeface="Arial"/>
+              <a:defRPr sz="1550" b="1">
+                <a:solidFill>
+                  <a:srgbClr val="22D3EE"/>
+                </a:solidFill>
+                <a:latin typeface="Segoe UI"/>
               </a:defRPr>
             </a:pPr>
             <a:r>
               <a:t>•  Syntax Security: </a:t>
             </a:r>
             <a:r>
-              <a:rPr sz="1600" b="0">
-                <a:solidFill>
-                  <a:srgbClr val="334155"/>
-                </a:solidFill>
-                <a:latin typeface="Arial"/>
+              <a:rPr sz="1550" b="0">
+                <a:solidFill>
+                  <a:srgbClr val="CBD5E1"/>
+                </a:solidFill>
+                <a:latin typeface="Segoe UI"/>
               </a:rPr>
               <a:t>The self-correcting validation loop acts as a compiler guard, preventing code hallucinations and ensuring the user only receives valid, executable SQL.</a:t>
             </a:r>
@@ -4359,22 +4919,22 @@
               <a:spcAft>
                 <a:spcPts val="1200"/>
               </a:spcAft>
-              <a:defRPr sz="1600" b="1">
-                <a:solidFill>
-                  <a:srgbClr val="0D9488"/>
-                </a:solidFill>
-                <a:latin typeface="Arial"/>
+              <a:defRPr sz="1550" b="1">
+                <a:solidFill>
+                  <a:srgbClr val="22D3EE"/>
+                </a:solidFill>
+                <a:latin typeface="Segoe UI"/>
               </a:defRPr>
             </a:pPr>
             <a:r>
               <a:t>•  Cloud Deployability: </a:t>
             </a:r>
             <a:r>
-              <a:rPr sz="1600" b="0">
-                <a:solidFill>
-                  <a:srgbClr val="334155"/>
-                </a:solidFill>
-                <a:latin typeface="Arial"/>
+              <a:rPr sz="1550" b="0">
+                <a:solidFill>
+                  <a:srgbClr val="CBD5E1"/>
+                </a:solidFill>
+                <a:latin typeface="Segoe UI"/>
               </a:rPr>
               <a:t>Supports in-memory batch file uploads, allowing the application to run smoothly on isolated cloud deployment servers like Streamlit Community Cloud.</a:t>
             </a:r>
@@ -4384,22 +4944,22 @@
               <a:spcAft>
                 <a:spcPts val="1200"/>
               </a:spcAft>
-              <a:defRPr sz="1600" b="1">
-                <a:solidFill>
-                  <a:srgbClr val="0D9488"/>
-                </a:solidFill>
-                <a:latin typeface="Arial"/>
+              <a:defRPr sz="1550" b="1">
+                <a:solidFill>
+                  <a:srgbClr val="22D3EE"/>
+                </a:solidFill>
+                <a:latin typeface="Segoe UI"/>
               </a:defRPr>
             </a:pPr>
             <a:r>
               <a:t>•  Pipeline Integration: </a:t>
             </a:r>
             <a:r>
-              <a:rPr sz="1600" b="0">
-                <a:solidFill>
-                  <a:srgbClr val="334155"/>
-                </a:solidFill>
-                <a:latin typeface="Arial"/>
+              <a:rPr sz="1550" b="0">
+                <a:solidFill>
+                  <a:srgbClr val="CBD5E1"/>
+                </a:solidFill>
+                <a:latin typeface="Segoe UI"/>
               </a:rPr>
               <a:t>Dual CLI and web dashboard structure allows the tool to fit seamlessly into single-query debugging sessions or automated Git pre-commit hooks.</a:t>
             </a:r>
@@ -4420,7 +4980,7 @@
     <p:bg>
       <p:bgPr>
         <a:solidFill>
-          <a:srgbClr val="F8FAFC"/>
+          <a:srgbClr val="0B1324"/>
         </a:solidFill>
         <a:effectLst/>
       </p:bgPr>
@@ -4455,11 +5015,11 @@
           <a:lstStyle/>
           <a:p>
             <a:pPr>
-              <a:defRPr sz="3600" b="1">
-                <a:solidFill>
-                  <a:srgbClr val="1E1B4B"/>
-                </a:solidFill>
-                <a:latin typeface="Arial"/>
+              <a:defRPr sz="3200" b="1">
+                <a:solidFill>
+                  <a:srgbClr val="F8FAFC"/>
+                </a:solidFill>
+                <a:latin typeface="Segoe UI"/>
               </a:defRPr>
             </a:pPr>
             <a:r>
@@ -4470,7 +5030,86 @@
       </p:sp>
       <p:sp>
         <p:nvSpPr>
-          <p:cNvPr id="3" name="TextBox 2"/>
+          <p:cNvPr id="3" name="Rectangle 2"/>
+          <p:cNvSpPr/>
+          <p:nvPr/>
+        </p:nvSpPr>
+        <p:spPr>
+          <a:xfrm>
+            <a:off x="685800" y="1188720"/>
+            <a:ext cx="10817352" cy="27432"/>
+          </a:xfrm>
+          <a:prstGeom prst="rect">
+            <a:avLst/>
+          </a:prstGeom>
+          <a:solidFill>
+            <a:srgbClr val="22D3EE"/>
+          </a:solidFill>
+          <a:ln>
+            <a:noFill/>
+          </a:ln>
+        </p:spPr>
+        <p:style>
+          <a:lnRef idx="1">
+            <a:schemeClr val="accent1"/>
+          </a:lnRef>
+          <a:fillRef idx="3">
+            <a:schemeClr val="accent1"/>
+          </a:fillRef>
+          <a:effectRef idx="2">
+            <a:schemeClr val="accent1"/>
+          </a:effectRef>
+          <a:fontRef idx="minor">
+            <a:schemeClr val="lt1"/>
+          </a:fontRef>
+        </p:style>
+        <p:txBody>
+          <a:bodyPr rtlCol="0" anchor="ctr"/>
+          <a:lstStyle/>
+          <a:p>
+            <a:pPr algn="ctr"/>
+          </a:p>
+        </p:txBody>
+      </p:sp>
+      <p:sp>
+        <p:nvSpPr>
+          <p:cNvPr id="4" name="TextBox 3"/>
+          <p:cNvSpPr txBox="1"/>
+          <p:nvPr/>
+        </p:nvSpPr>
+        <p:spPr>
+          <a:xfrm>
+            <a:off x="685800" y="6309360"/>
+            <a:ext cx="10817352" cy="274320"/>
+          </a:xfrm>
+          <a:prstGeom prst="rect">
+            <a:avLst/>
+          </a:prstGeom>
+          <a:noFill/>
+        </p:spPr>
+        <p:txBody>
+          <a:bodyPr wrap="square" lIns="0" tIns="0" rIns="0" bIns="0">
+            <a:spAutoFit/>
+          </a:bodyPr>
+          <a:lstStyle/>
+          <a:p>
+            <a:pPr algn="l">
+              <a:defRPr sz="1000">
+                <a:solidFill>
+                  <a:srgbClr val="64748B"/>
+                </a:solidFill>
+                <a:latin typeface="Segoe UI"/>
+              </a:defRPr>
+            </a:pPr>
+            <a:r>
+              <a:t>SQL Query Linter &amp; Style Fixer  |  Developed by Team 20</a:t>
+            </a:r>
+          </a:p>
+        </p:txBody>
+      </p:sp>
+      <p:sp>
+        <p:nvSpPr>
+          <p:cNvPr id="5" name="TextBox 4"/>
           <p:cNvSpPr txBox="1"/>
           <p:nvPr/>
         </p:nvSpPr>
@@ -4485,7 +5124,7 @@
           <a:noFill/>
         </p:spPr>
         <p:txBody>
-          <a:bodyPr wrap="square">
+          <a:bodyPr wrap="square" lIns="0" tIns="0" rIns="0" bIns="0">
             <a:spAutoFit/>
           </a:bodyPr>
           <a:lstStyle/>
@@ -4494,15 +5133,15 @@
               <a:spcAft>
                 <a:spcPts val="2000"/>
               </a:spcAft>
-              <a:defRPr sz="2000">
-                <a:solidFill>
-                  <a:srgbClr val="1E1B4B"/>
-                </a:solidFill>
-                <a:latin typeface="Arial"/>
-              </a:defRPr>
-            </a:pPr>
-            <a:r>
-              <a:t>The **SQL Query Linter &amp; Style Fixer** successfully bridges the gap between rule-based style cleaners and AI-driven semantic query model refactoring.</a:t>
+              <a:defRPr sz="1900" b="1">
+                <a:solidFill>
+                  <a:srgbClr val="22D3EE"/>
+                </a:solidFill>
+                <a:latin typeface="Segoe UI"/>
+              </a:defRPr>
+            </a:pPr>
+            <a:r>
+              <a:t>The SQL Query Linter &amp; Style Fixer successfully bridges the gap between rule-based style cleaners and AI-driven semantic query model refactoring.</a:t>
             </a:r>
           </a:p>
           <a:p>
@@ -4510,11 +5149,11 @@
               <a:spcBef>
                 <a:spcPts val="800"/>
               </a:spcBef>
-              <a:defRPr sz="1600">
-                <a:solidFill>
-                  <a:srgbClr val="334155"/>
-                </a:solidFill>
-                <a:latin typeface="Arial"/>
+              <a:defRPr sz="1500">
+                <a:solidFill>
+                  <a:srgbClr val="CBD5E1"/>
+                </a:solidFill>
+                <a:latin typeface="Segoe UI"/>
               </a:defRPr>
             </a:pPr>
             <a:r>
@@ -4526,11 +5165,11 @@
               <a:spcBef>
                 <a:spcPts val="800"/>
               </a:spcBef>
-              <a:defRPr sz="1600">
-                <a:solidFill>
-                  <a:srgbClr val="334155"/>
-                </a:solidFill>
-                <a:latin typeface="Arial"/>
+              <a:defRPr sz="1500">
+                <a:solidFill>
+                  <a:srgbClr val="CBD5E1"/>
+                </a:solidFill>
+                <a:latin typeface="Segoe UI"/>
               </a:defRPr>
             </a:pPr>
             <a:r>
@@ -4542,11 +5181,11 @@
               <a:spcBef>
                 <a:spcPts val="800"/>
               </a:spcBef>
-              <a:defRPr sz="1600">
-                <a:solidFill>
-                  <a:srgbClr val="334155"/>
-                </a:solidFill>
-                <a:latin typeface="Arial"/>
+              <a:defRPr sz="1500">
+                <a:solidFill>
+                  <a:srgbClr val="CBD5E1"/>
+                </a:solidFill>
+                <a:latin typeface="Segoe UI"/>
               </a:defRPr>
             </a:pPr>
             <a:r>
@@ -4558,11 +5197,11 @@
               <a:spcBef>
                 <a:spcPts val="800"/>
               </a:spcBef>
-              <a:defRPr sz="1600">
-                <a:solidFill>
-                  <a:srgbClr val="334155"/>
-                </a:solidFill>
-                <a:latin typeface="Arial"/>
+              <a:defRPr sz="1500">
+                <a:solidFill>
+                  <a:srgbClr val="CBD5E1"/>
+                </a:solidFill>
+                <a:latin typeface="Segoe UI"/>
               </a:defRPr>
             </a:pPr>
             <a:r>

</xml_diff>

<commit_message>
Update presentation Presentation.pptx with modern indigo/violet theme and card layouts
</commit_message>
<xml_diff>
--- a/Presentation.pptx
+++ b/Presentation.pptx
@@ -3091,7 +3091,7 @@
     <p:bg>
       <p:bgPr>
         <a:solidFill>
-          <a:srgbClr val="0B1324"/>
+          <a:srgbClr val="F8FAFC"/>
         </a:solidFill>
         <a:effectLst/>
       </p:bgPr>
@@ -3112,13 +3112,13 @@
         <p:spPr>
           <a:xfrm>
             <a:off x="0" y="0"/>
-            <a:ext cx="12188952" cy="91440"/>
+            <a:ext cx="12188952" cy="109728"/>
           </a:xfrm>
           <a:prstGeom prst="rect">
             <a:avLst/>
           </a:prstGeom>
           <a:solidFill>
-            <a:srgbClr val="22D3EE"/>
+            <a:srgbClr val="4F46E5"/>
           </a:solidFill>
           <a:ln>
             <a:noFill/>
@@ -3154,7 +3154,7 @@
         </p:nvSpPr>
         <p:spPr>
           <a:xfrm>
-            <a:off x="685800" y="1371600"/>
+            <a:off x="685800" y="1188720"/>
             <a:ext cx="10817352" cy="2011680"/>
           </a:xfrm>
           <a:prstGeom prst="rect">
@@ -3169,9 +3169,9 @@
           <a:lstStyle/>
           <a:p>
             <a:pPr>
-              <a:defRPr sz="5000" b="1">
-                <a:solidFill>
-                  <a:srgbClr val="F8FAFC"/>
+              <a:defRPr sz="4800" b="1">
+                <a:solidFill>
+                  <a:srgbClr val="0F172A"/>
                 </a:solidFill>
                 <a:latin typeface="Segoe UI"/>
               </a:defRPr>
@@ -3183,11 +3183,11 @@
           <a:p>
             <a:pPr>
               <a:spcBef>
-                <a:spcPts val="1200"/>
+                <a:spcPts val="1000"/>
               </a:spcBef>
               <a:defRPr sz="2200" b="1">
                 <a:solidFill>
-                  <a:srgbClr val="22D3EE"/>
+                  <a:srgbClr val="4F46E5"/>
                 </a:solidFill>
                 <a:latin typeface="Segoe UI"/>
               </a:defRPr>
@@ -3200,23 +3200,25 @@
       </p:sp>
       <p:sp>
         <p:nvSpPr>
-          <p:cNvPr id="4" name="Rectangle 3"/>
+          <p:cNvPr id="4" name="Rounded Rectangle 3"/>
           <p:cNvSpPr/>
           <p:nvPr/>
         </p:nvSpPr>
         <p:spPr>
           <a:xfrm>
-            <a:off x="685800" y="3657600"/>
-            <a:ext cx="10817352" cy="18288"/>
-          </a:xfrm>
-          <a:prstGeom prst="rect">
+            <a:off x="685800" y="3566160"/>
+            <a:ext cx="10817352" cy="2468880"/>
+          </a:xfrm>
+          <a:prstGeom prst="roundRect">
             <a:avLst/>
           </a:prstGeom>
           <a:solidFill>
-            <a:srgbClr val="64748B"/>
+            <a:srgbClr val="FFFFFF"/>
           </a:solidFill>
-          <a:ln>
-            <a:noFill/>
+          <a:ln w="19050">
+            <a:solidFill>
+              <a:srgbClr val="E0E7FF"/>
+            </a:solidFill>
           </a:ln>
         </p:spPr>
         <p:style>
@@ -3243,14 +3245,57 @@
       </p:sp>
       <p:sp>
         <p:nvSpPr>
-          <p:cNvPr id="5" name="TextBox 4"/>
+          <p:cNvPr id="5" name="Rectangle 4"/>
+          <p:cNvSpPr/>
+          <p:nvPr/>
+        </p:nvSpPr>
+        <p:spPr>
+          <a:xfrm>
+            <a:off x="685800" y="3566160"/>
+            <a:ext cx="109728" cy="2468880"/>
+          </a:xfrm>
+          <a:prstGeom prst="rect">
+            <a:avLst/>
+          </a:prstGeom>
+          <a:solidFill>
+            <a:srgbClr val="DB2777"/>
+          </a:solidFill>
+          <a:ln>
+            <a:noFill/>
+          </a:ln>
+        </p:spPr>
+        <p:style>
+          <a:lnRef idx="1">
+            <a:schemeClr val="accent1"/>
+          </a:lnRef>
+          <a:fillRef idx="3">
+            <a:schemeClr val="accent1"/>
+          </a:fillRef>
+          <a:effectRef idx="2">
+            <a:schemeClr val="accent1"/>
+          </a:effectRef>
+          <a:fontRef idx="minor">
+            <a:schemeClr val="lt1"/>
+          </a:fontRef>
+        </p:style>
+        <p:txBody>
+          <a:bodyPr rtlCol="0" anchor="ctr"/>
+          <a:lstStyle/>
+          <a:p>
+            <a:pPr algn="ctr"/>
+          </a:p>
+        </p:txBody>
+      </p:sp>
+      <p:sp>
+        <p:nvSpPr>
+          <p:cNvPr id="6" name="TextBox 5"/>
           <p:cNvSpPr txBox="1"/>
           <p:nvPr/>
         </p:nvSpPr>
         <p:spPr>
           <a:xfrm>
-            <a:off x="685800" y="3931920"/>
-            <a:ext cx="10817352" cy="2286000"/>
+            <a:off x="1051560" y="3749039"/>
+            <a:ext cx="10268712" cy="2103120"/>
           </a:xfrm>
           <a:prstGeom prst="rect">
             <a:avLst/>
@@ -3265,11 +3310,11 @@
           <a:p>
             <a:pPr>
               <a:spcAft>
-                <a:spcPts val="800"/>
+                <a:spcPts val="600"/>
               </a:spcAft>
               <a:defRPr sz="1300" b="1">
                 <a:solidFill>
-                  <a:srgbClr val="22D3EE"/>
+                  <a:srgbClr val="DB2777"/>
                 </a:solidFill>
                 <a:latin typeface="Segoe UI"/>
               </a:defRPr>
@@ -3283,9 +3328,9 @@
               <a:spcBef>
                 <a:spcPts val="300"/>
               </a:spcBef>
-              <a:defRPr sz="1250">
-                <a:solidFill>
-                  <a:srgbClr val="CBD5E1"/>
+              <a:defRPr sz="1300">
+                <a:solidFill>
+                  <a:srgbClr val="334155"/>
                 </a:solidFill>
                 <a:latin typeface="Segoe UI"/>
               </a:defRPr>
@@ -3299,9 +3344,9 @@
               <a:spcBef>
                 <a:spcPts val="300"/>
               </a:spcBef>
-              <a:defRPr sz="1250">
-                <a:solidFill>
-                  <a:srgbClr val="CBD5E1"/>
+              <a:defRPr sz="1300">
+                <a:solidFill>
+                  <a:srgbClr val="334155"/>
                 </a:solidFill>
                 <a:latin typeface="Segoe UI"/>
               </a:defRPr>
@@ -3315,9 +3360,9 @@
               <a:spcBef>
                 <a:spcPts val="300"/>
               </a:spcBef>
-              <a:defRPr sz="1250">
-                <a:solidFill>
-                  <a:srgbClr val="CBD5E1"/>
+              <a:defRPr sz="1300">
+                <a:solidFill>
+                  <a:srgbClr val="334155"/>
                 </a:solidFill>
                 <a:latin typeface="Segoe UI"/>
               </a:defRPr>
@@ -3331,9 +3376,9 @@
               <a:spcBef>
                 <a:spcPts val="300"/>
               </a:spcBef>
-              <a:defRPr sz="1250">
-                <a:solidFill>
-                  <a:srgbClr val="CBD5E1"/>
+              <a:defRPr sz="1300">
+                <a:solidFill>
+                  <a:srgbClr val="334155"/>
                 </a:solidFill>
                 <a:latin typeface="Segoe UI"/>
               </a:defRPr>
@@ -3358,7 +3403,7 @@
     <p:bg>
       <p:bgPr>
         <a:solidFill>
-          <a:srgbClr val="0B1324"/>
+          <a:srgbClr val="F8FAFC"/>
         </a:solidFill>
         <a:effectLst/>
       </p:bgPr>
@@ -3395,7 +3440,7 @@
             <a:pPr>
               <a:defRPr sz="3200" b="1">
                 <a:solidFill>
-                  <a:srgbClr val="F8FAFC"/>
+                  <a:srgbClr val="0F172A"/>
                 </a:solidFill>
                 <a:latin typeface="Segoe UI"/>
               </a:defRPr>
@@ -3415,13 +3460,13 @@
         <p:spPr>
           <a:xfrm>
             <a:off x="685800" y="1188720"/>
-            <a:ext cx="10817352" cy="27432"/>
+            <a:ext cx="10817352" cy="36576"/>
           </a:xfrm>
           <a:prstGeom prst="rect">
             <a:avLst/>
           </a:prstGeom>
           <a:solidFill>
-            <a:srgbClr val="22D3EE"/>
+            <a:srgbClr val="4F46E5"/>
           </a:solidFill>
           <a:ln>
             <a:noFill/>
@@ -3457,7 +3502,7 @@
         </p:nvSpPr>
         <p:spPr>
           <a:xfrm>
-            <a:off x="685800" y="6309360"/>
+            <a:off x="685800" y="6355080"/>
             <a:ext cx="10817352" cy="274320"/>
           </a:xfrm>
           <a:prstGeom prst="rect">
@@ -3487,14 +3532,102 @@
       </p:sp>
       <p:sp>
         <p:nvSpPr>
-          <p:cNvPr id="5" name="TextBox 4"/>
+          <p:cNvPr id="5" name="Rounded Rectangle 4"/>
+          <p:cNvSpPr/>
+          <p:nvPr/>
+        </p:nvSpPr>
+        <p:spPr>
+          <a:xfrm>
+            <a:off x="685800" y="1645920"/>
+            <a:ext cx="4754880" cy="4297680"/>
+          </a:xfrm>
+          <a:prstGeom prst="roundRect">
+            <a:avLst/>
+          </a:prstGeom>
+          <a:solidFill>
+            <a:srgbClr val="F0F2FE"/>
+          </a:solidFill>
+          <a:ln w="19050">
+            <a:solidFill>
+              <a:srgbClr val="E0E7FF"/>
+            </a:solidFill>
+          </a:ln>
+        </p:spPr>
+        <p:style>
+          <a:lnRef idx="1">
+            <a:schemeClr val="accent1"/>
+          </a:lnRef>
+          <a:fillRef idx="3">
+            <a:schemeClr val="accent1"/>
+          </a:fillRef>
+          <a:effectRef idx="2">
+            <a:schemeClr val="accent1"/>
+          </a:effectRef>
+          <a:fontRef idx="minor">
+            <a:schemeClr val="lt1"/>
+          </a:fontRef>
+        </p:style>
+        <p:txBody>
+          <a:bodyPr rtlCol="0" anchor="ctr"/>
+          <a:lstStyle/>
+          <a:p>
+            <a:pPr algn="ctr"/>
+          </a:p>
+        </p:txBody>
+      </p:sp>
+      <p:sp>
+        <p:nvSpPr>
+          <p:cNvPr id="6" name="Rectangle 5"/>
+          <p:cNvSpPr/>
+          <p:nvPr/>
+        </p:nvSpPr>
+        <p:spPr>
+          <a:xfrm>
+            <a:off x="685800" y="1645920"/>
+            <a:ext cx="109728" cy="4297680"/>
+          </a:xfrm>
+          <a:prstGeom prst="rect">
+            <a:avLst/>
+          </a:prstGeom>
+          <a:solidFill>
+            <a:srgbClr val="4F46E5"/>
+          </a:solidFill>
+          <a:ln>
+            <a:noFill/>
+          </a:ln>
+        </p:spPr>
+        <p:style>
+          <a:lnRef idx="1">
+            <a:schemeClr val="accent1"/>
+          </a:lnRef>
+          <a:fillRef idx="3">
+            <a:schemeClr val="accent1"/>
+          </a:fillRef>
+          <a:effectRef idx="2">
+            <a:schemeClr val="accent1"/>
+          </a:effectRef>
+          <a:fontRef idx="minor">
+            <a:schemeClr val="lt1"/>
+          </a:fontRef>
+        </p:style>
+        <p:txBody>
+          <a:bodyPr rtlCol="0" anchor="ctr"/>
+          <a:lstStyle/>
+          <a:p>
+            <a:pPr algn="ctr"/>
+          </a:p>
+        </p:txBody>
+      </p:sp>
+      <p:sp>
+        <p:nvSpPr>
+          <p:cNvPr id="7" name="TextBox 6"/>
           <p:cNvSpPr txBox="1"/>
           <p:nvPr/>
         </p:nvSpPr>
         <p:spPr>
           <a:xfrm>
-            <a:off x="685800" y="1645920"/>
-            <a:ext cx="10817352" cy="4389120"/>
+            <a:off x="1051560" y="2011680"/>
+            <a:ext cx="4114800" cy="3566160"/>
           </a:xfrm>
           <a:prstGeom prst="rect">
             <a:avLst/>
@@ -3508,12 +3641,12 @@
           <a:lstStyle/>
           <a:p>
             <a:pPr>
-              <a:spcAft>
-                <a:spcPts val="2000"/>
-              </a:spcAft>
-              <a:defRPr sz="1900">
-                <a:solidFill>
-                  <a:srgbClr val="CBD5E1"/>
+              <a:lnSpc>
+                <a:spcPct val="130000"/>
+              </a:lnSpc>
+              <a:defRPr sz="1900" b="1">
+                <a:solidFill>
+                  <a:srgbClr val="4F46E5"/>
                 </a:solidFill>
                 <a:latin typeface="Segoe UI"/>
               </a:defRPr>
@@ -3522,14 +3655,40 @@
               <a:t>To build a robust database utility that automates layout formatting, syntax cleansing, and structural optimization for database development teams by merging client-side deterministic parsers with serverless Large Language Models.</a:t>
             </a:r>
           </a:p>
+        </p:txBody>
+      </p:sp>
+      <p:sp>
+        <p:nvSpPr>
+          <p:cNvPr id="8" name="TextBox 7"/>
+          <p:cNvSpPr txBox="1"/>
+          <p:nvPr/>
+        </p:nvSpPr>
+        <p:spPr>
+          <a:xfrm>
+            <a:off x="5897880" y="1645920"/>
+            <a:ext cx="5605272" cy="4297680"/>
+          </a:xfrm>
+          <a:prstGeom prst="rect">
+            <a:avLst/>
+          </a:prstGeom>
+          <a:noFill/>
+        </p:spPr>
+        <p:txBody>
+          <a:bodyPr wrap="square" lIns="0" tIns="0" rIns="0" bIns="0">
+            <a:spAutoFit/>
+          </a:bodyPr>
+          <a:lstStyle/>
           <a:p>
             <a:pPr>
+              <a:lnSpc>
+                <a:spcPct val="120000"/>
+              </a:lnSpc>
               <a:spcBef>
-                <a:spcPts val="800"/>
+                <a:spcPts val="1000"/>
               </a:spcBef>
               <a:defRPr sz="1500">
                 <a:solidFill>
-                  <a:srgbClr val="CBD5E1"/>
+                  <a:srgbClr val="334155"/>
                 </a:solidFill>
                 <a:latin typeface="Segoe UI"/>
               </a:defRPr>
@@ -3540,12 +3699,15 @@
           </a:p>
           <a:p>
             <a:pPr>
+              <a:lnSpc>
+                <a:spcPct val="120000"/>
+              </a:lnSpc>
               <a:spcBef>
-                <a:spcPts val="800"/>
+                <a:spcPts val="1000"/>
               </a:spcBef>
               <a:defRPr sz="1500">
                 <a:solidFill>
-                  <a:srgbClr val="CBD5E1"/>
+                  <a:srgbClr val="334155"/>
                 </a:solidFill>
                 <a:latin typeface="Segoe UI"/>
               </a:defRPr>
@@ -3556,12 +3718,15 @@
           </a:p>
           <a:p>
             <a:pPr>
+              <a:lnSpc>
+                <a:spcPct val="120000"/>
+              </a:lnSpc>
               <a:spcBef>
-                <a:spcPts val="800"/>
+                <a:spcPts val="1000"/>
               </a:spcBef>
               <a:defRPr sz="1500">
                 <a:solidFill>
-                  <a:srgbClr val="CBD5E1"/>
+                  <a:srgbClr val="334155"/>
                 </a:solidFill>
                 <a:latin typeface="Segoe UI"/>
               </a:defRPr>
@@ -3572,12 +3737,15 @@
           </a:p>
           <a:p>
             <a:pPr>
+              <a:lnSpc>
+                <a:spcPct val="120000"/>
+              </a:lnSpc>
               <a:spcBef>
-                <a:spcPts val="800"/>
+                <a:spcPts val="1000"/>
               </a:spcBef>
               <a:defRPr sz="1500">
                 <a:solidFill>
-                  <a:srgbClr val="CBD5E1"/>
+                  <a:srgbClr val="334155"/>
                 </a:solidFill>
                 <a:latin typeface="Segoe UI"/>
               </a:defRPr>
@@ -3588,12 +3756,15 @@
           </a:p>
           <a:p>
             <a:pPr>
+              <a:lnSpc>
+                <a:spcPct val="120000"/>
+              </a:lnSpc>
               <a:spcBef>
-                <a:spcPts val="800"/>
+                <a:spcPts val="1000"/>
               </a:spcBef>
               <a:defRPr sz="1500">
                 <a:solidFill>
-                  <a:srgbClr val="CBD5E1"/>
+                  <a:srgbClr val="334155"/>
                 </a:solidFill>
                 <a:latin typeface="Segoe UI"/>
               </a:defRPr>
@@ -3618,7 +3789,7 @@
     <p:bg>
       <p:bgPr>
         <a:solidFill>
-          <a:srgbClr val="0B1324"/>
+          <a:srgbClr val="F8FAFC"/>
         </a:solidFill>
         <a:effectLst/>
       </p:bgPr>
@@ -3655,7 +3826,7 @@
             <a:pPr>
               <a:defRPr sz="3200" b="1">
                 <a:solidFill>
-                  <a:srgbClr val="F8FAFC"/>
+                  <a:srgbClr val="0F172A"/>
                 </a:solidFill>
                 <a:latin typeface="Segoe UI"/>
               </a:defRPr>
@@ -3675,13 +3846,13 @@
         <p:spPr>
           <a:xfrm>
             <a:off x="685800" y="1188720"/>
-            <a:ext cx="10817352" cy="27432"/>
+            <a:ext cx="10817352" cy="36576"/>
           </a:xfrm>
           <a:prstGeom prst="rect">
             <a:avLst/>
           </a:prstGeom>
           <a:solidFill>
-            <a:srgbClr val="22D3EE"/>
+            <a:srgbClr val="4F46E5"/>
           </a:solidFill>
           <a:ln>
             <a:noFill/>
@@ -3717,7 +3888,7 @@
         </p:nvSpPr>
         <p:spPr>
           <a:xfrm>
-            <a:off x="685800" y="6309360"/>
+            <a:off x="685800" y="6355080"/>
             <a:ext cx="10817352" cy="274320"/>
           </a:xfrm>
           <a:prstGeom prst="rect">
@@ -3747,14 +3918,102 @@
       </p:sp>
       <p:sp>
         <p:nvSpPr>
-          <p:cNvPr id="5" name="TextBox 4"/>
+          <p:cNvPr id="5" name="Rounded Rectangle 4"/>
+          <p:cNvSpPr/>
+          <p:nvPr/>
+        </p:nvSpPr>
+        <p:spPr>
+          <a:xfrm>
+            <a:off x="685800" y="1645920"/>
+            <a:ext cx="10817352" cy="777240"/>
+          </a:xfrm>
+          <a:prstGeom prst="roundRect">
+            <a:avLst/>
+          </a:prstGeom>
+          <a:solidFill>
+            <a:srgbClr val="FFFFFF"/>
+          </a:solidFill>
+          <a:ln w="19050">
+            <a:solidFill>
+              <a:srgbClr val="E0E7FF"/>
+            </a:solidFill>
+          </a:ln>
+        </p:spPr>
+        <p:style>
+          <a:lnRef idx="1">
+            <a:schemeClr val="accent1"/>
+          </a:lnRef>
+          <a:fillRef idx="3">
+            <a:schemeClr val="accent1"/>
+          </a:fillRef>
+          <a:effectRef idx="2">
+            <a:schemeClr val="accent1"/>
+          </a:effectRef>
+          <a:fontRef idx="minor">
+            <a:schemeClr val="lt1"/>
+          </a:fontRef>
+        </p:style>
+        <p:txBody>
+          <a:bodyPr rtlCol="0" anchor="ctr"/>
+          <a:lstStyle/>
+          <a:p>
+            <a:pPr algn="ctr"/>
+          </a:p>
+        </p:txBody>
+      </p:sp>
+      <p:sp>
+        <p:nvSpPr>
+          <p:cNvPr id="6" name="Rectangle 5"/>
+          <p:cNvSpPr/>
+          <p:nvPr/>
+        </p:nvSpPr>
+        <p:spPr>
+          <a:xfrm>
+            <a:off x="685800" y="1645920"/>
+            <a:ext cx="109728" cy="777240"/>
+          </a:xfrm>
+          <a:prstGeom prst="rect">
+            <a:avLst/>
+          </a:prstGeom>
+          <a:solidFill>
+            <a:srgbClr val="EF4444"/>
+          </a:solidFill>
+          <a:ln>
+            <a:noFill/>
+          </a:ln>
+        </p:spPr>
+        <p:style>
+          <a:lnRef idx="1">
+            <a:schemeClr val="accent1"/>
+          </a:lnRef>
+          <a:fillRef idx="3">
+            <a:schemeClr val="accent1"/>
+          </a:fillRef>
+          <a:effectRef idx="2">
+            <a:schemeClr val="accent1"/>
+          </a:effectRef>
+          <a:fontRef idx="minor">
+            <a:schemeClr val="lt1"/>
+          </a:fontRef>
+        </p:style>
+        <p:txBody>
+          <a:bodyPr rtlCol="0" anchor="ctr"/>
+          <a:lstStyle/>
+          <a:p>
+            <a:pPr algn="ctr"/>
+          </a:p>
+        </p:txBody>
+      </p:sp>
+      <p:sp>
+        <p:nvSpPr>
+          <p:cNvPr id="7" name="TextBox 6"/>
           <p:cNvSpPr txBox="1"/>
           <p:nvPr/>
         </p:nvSpPr>
         <p:spPr>
           <a:xfrm>
-            <a:off x="685800" y="1645920"/>
-            <a:ext cx="10817352" cy="4389120"/>
+            <a:off x="1005840" y="1719072"/>
+            <a:ext cx="10314432" cy="630936"/>
           </a:xfrm>
           <a:prstGeom prst="rect">
             <a:avLst/>
@@ -3768,82 +4027,556 @@
           <a:lstStyle/>
           <a:p>
             <a:pPr>
-              <a:spcAft>
-                <a:spcPts val="1200"/>
-              </a:spcAft>
-              <a:defRPr sz="1550">
-                <a:solidFill>
-                  <a:srgbClr val="CBD5E1"/>
+              <a:defRPr sz="1350" b="1">
+                <a:solidFill>
+                  <a:srgbClr val="0F172A"/>
                 </a:solidFill>
                 <a:latin typeface="Segoe UI"/>
               </a:defRPr>
             </a:pPr>
             <a:r>
-              <a:t>•  Inconsistent Casing: Mixed naming structures (camelCase, PascalCase, lowercase) create style violations and audit complications.</a:t>
-            </a:r>
-          </a:p>
+              <a:t>Inconsistent Casing: </a:t>
+            </a:r>
+            <a:r>
+              <a:rPr sz="1300" b="0">
+                <a:solidFill>
+                  <a:srgbClr val="334155"/>
+                </a:solidFill>
+                <a:latin typeface="Segoe UI"/>
+              </a:rPr>
+              <a:t>Mixed naming structures (camelCase, PascalCase, lowercase) create style violations and audit complications.</a:t>
+            </a:r>
+          </a:p>
+        </p:txBody>
+      </p:sp>
+      <p:sp>
+        <p:nvSpPr>
+          <p:cNvPr id="8" name="Rounded Rectangle 7"/>
+          <p:cNvSpPr/>
+          <p:nvPr/>
+        </p:nvSpPr>
+        <p:spPr>
+          <a:xfrm>
+            <a:off x="685800" y="2514600"/>
+            <a:ext cx="10817352" cy="777240"/>
+          </a:xfrm>
+          <a:prstGeom prst="roundRect">
+            <a:avLst/>
+          </a:prstGeom>
+          <a:solidFill>
+            <a:srgbClr val="FFFFFF"/>
+          </a:solidFill>
+          <a:ln w="19050">
+            <a:solidFill>
+              <a:srgbClr val="E0E7FF"/>
+            </a:solidFill>
+          </a:ln>
+        </p:spPr>
+        <p:style>
+          <a:lnRef idx="1">
+            <a:schemeClr val="accent1"/>
+          </a:lnRef>
+          <a:fillRef idx="3">
+            <a:schemeClr val="accent1"/>
+          </a:fillRef>
+          <a:effectRef idx="2">
+            <a:schemeClr val="accent1"/>
+          </a:effectRef>
+          <a:fontRef idx="minor">
+            <a:schemeClr val="lt1"/>
+          </a:fontRef>
+        </p:style>
+        <p:txBody>
+          <a:bodyPr rtlCol="0" anchor="ctr"/>
+          <a:lstStyle/>
+          <a:p>
+            <a:pPr algn="ctr"/>
+          </a:p>
+        </p:txBody>
+      </p:sp>
+      <p:sp>
+        <p:nvSpPr>
+          <p:cNvPr id="9" name="Rectangle 8"/>
+          <p:cNvSpPr/>
+          <p:nvPr/>
+        </p:nvSpPr>
+        <p:spPr>
+          <a:xfrm>
+            <a:off x="685800" y="2514600"/>
+            <a:ext cx="109728" cy="777240"/>
+          </a:xfrm>
+          <a:prstGeom prst="rect">
+            <a:avLst/>
+          </a:prstGeom>
+          <a:solidFill>
+            <a:srgbClr val="EF4444"/>
+          </a:solidFill>
+          <a:ln>
+            <a:noFill/>
+          </a:ln>
+        </p:spPr>
+        <p:style>
+          <a:lnRef idx="1">
+            <a:schemeClr val="accent1"/>
+          </a:lnRef>
+          <a:fillRef idx="3">
+            <a:schemeClr val="accent1"/>
+          </a:fillRef>
+          <a:effectRef idx="2">
+            <a:schemeClr val="accent1"/>
+          </a:effectRef>
+          <a:fontRef idx="minor">
+            <a:schemeClr val="lt1"/>
+          </a:fontRef>
+        </p:style>
+        <p:txBody>
+          <a:bodyPr rtlCol="0" anchor="ctr"/>
+          <a:lstStyle/>
+          <a:p>
+            <a:pPr algn="ctr"/>
+          </a:p>
+        </p:txBody>
+      </p:sp>
+      <p:sp>
+        <p:nvSpPr>
+          <p:cNvPr id="10" name="TextBox 9"/>
+          <p:cNvSpPr txBox="1"/>
+          <p:nvPr/>
+        </p:nvSpPr>
+        <p:spPr>
+          <a:xfrm>
+            <a:off x="1005840" y="2587752"/>
+            <a:ext cx="10314432" cy="630936"/>
+          </a:xfrm>
+          <a:prstGeom prst="rect">
+            <a:avLst/>
+          </a:prstGeom>
+          <a:noFill/>
+        </p:spPr>
+        <p:txBody>
+          <a:bodyPr wrap="square" lIns="0" tIns="0" rIns="0" bIns="0">
+            <a:spAutoFit/>
+          </a:bodyPr>
+          <a:lstStyle/>
           <a:p>
             <a:pPr>
-              <a:spcAft>
-                <a:spcPts val="1200"/>
-              </a:spcAft>
-              <a:defRPr sz="1550">
-                <a:solidFill>
-                  <a:srgbClr val="CBD5E1"/>
+              <a:defRPr sz="1350" b="1">
+                <a:solidFill>
+                  <a:srgbClr val="0F172A"/>
                 </a:solidFill>
                 <a:latin typeface="Segoe UI"/>
               </a:defRPr>
             </a:pPr>
             <a:r>
-              <a:t>•  Legacy Join Syntax: Extensive usage of implicit comma-joins (e.g., FROM TableA, TableB WHERE A.id = B.id) obscures join pathways and increases maintenance overhead.</a:t>
-            </a:r>
-          </a:p>
+              <a:t>Legacy Join Syntax: </a:t>
+            </a:r>
+            <a:r>
+              <a:rPr sz="1300" b="0">
+                <a:solidFill>
+                  <a:srgbClr val="334155"/>
+                </a:solidFill>
+                <a:latin typeface="Segoe UI"/>
+              </a:rPr>
+              <a:t>Extensive usage of implicit comma-joins (e.g., FROM TableA, TableB WHERE A.id = B.id) obscures join pathways and increases maintenance overhead.</a:t>
+            </a:r>
+          </a:p>
+        </p:txBody>
+      </p:sp>
+      <p:sp>
+        <p:nvSpPr>
+          <p:cNvPr id="11" name="Rounded Rectangle 10"/>
+          <p:cNvSpPr/>
+          <p:nvPr/>
+        </p:nvSpPr>
+        <p:spPr>
+          <a:xfrm>
+            <a:off x="685800" y="3383280"/>
+            <a:ext cx="10817352" cy="777240"/>
+          </a:xfrm>
+          <a:prstGeom prst="roundRect">
+            <a:avLst/>
+          </a:prstGeom>
+          <a:solidFill>
+            <a:srgbClr val="FFFFFF"/>
+          </a:solidFill>
+          <a:ln w="19050">
+            <a:solidFill>
+              <a:srgbClr val="E0E7FF"/>
+            </a:solidFill>
+          </a:ln>
+        </p:spPr>
+        <p:style>
+          <a:lnRef idx="1">
+            <a:schemeClr val="accent1"/>
+          </a:lnRef>
+          <a:fillRef idx="3">
+            <a:schemeClr val="accent1"/>
+          </a:fillRef>
+          <a:effectRef idx="2">
+            <a:schemeClr val="accent1"/>
+          </a:effectRef>
+          <a:fontRef idx="minor">
+            <a:schemeClr val="lt1"/>
+          </a:fontRef>
+        </p:style>
+        <p:txBody>
+          <a:bodyPr rtlCol="0" anchor="ctr"/>
+          <a:lstStyle/>
+          <a:p>
+            <a:pPr algn="ctr"/>
+          </a:p>
+        </p:txBody>
+      </p:sp>
+      <p:sp>
+        <p:nvSpPr>
+          <p:cNvPr id="12" name="Rectangle 11"/>
+          <p:cNvSpPr/>
+          <p:nvPr/>
+        </p:nvSpPr>
+        <p:spPr>
+          <a:xfrm>
+            <a:off x="685800" y="3383280"/>
+            <a:ext cx="109728" cy="777240"/>
+          </a:xfrm>
+          <a:prstGeom prst="rect">
+            <a:avLst/>
+          </a:prstGeom>
+          <a:solidFill>
+            <a:srgbClr val="EF4444"/>
+          </a:solidFill>
+          <a:ln>
+            <a:noFill/>
+          </a:ln>
+        </p:spPr>
+        <p:style>
+          <a:lnRef idx="1">
+            <a:schemeClr val="accent1"/>
+          </a:lnRef>
+          <a:fillRef idx="3">
+            <a:schemeClr val="accent1"/>
+          </a:fillRef>
+          <a:effectRef idx="2">
+            <a:schemeClr val="accent1"/>
+          </a:effectRef>
+          <a:fontRef idx="minor">
+            <a:schemeClr val="lt1"/>
+          </a:fontRef>
+        </p:style>
+        <p:txBody>
+          <a:bodyPr rtlCol="0" anchor="ctr"/>
+          <a:lstStyle/>
+          <a:p>
+            <a:pPr algn="ctr"/>
+          </a:p>
+        </p:txBody>
+      </p:sp>
+      <p:sp>
+        <p:nvSpPr>
+          <p:cNvPr id="13" name="TextBox 12"/>
+          <p:cNvSpPr txBox="1"/>
+          <p:nvPr/>
+        </p:nvSpPr>
+        <p:spPr>
+          <a:xfrm>
+            <a:off x="1005840" y="3456432"/>
+            <a:ext cx="10314432" cy="630936"/>
+          </a:xfrm>
+          <a:prstGeom prst="rect">
+            <a:avLst/>
+          </a:prstGeom>
+          <a:noFill/>
+        </p:spPr>
+        <p:txBody>
+          <a:bodyPr wrap="square" lIns="0" tIns="0" rIns="0" bIns="0">
+            <a:spAutoFit/>
+          </a:bodyPr>
+          <a:lstStyle/>
           <a:p>
             <a:pPr>
-              <a:spcAft>
-                <a:spcPts val="1200"/>
-              </a:spcAft>
-              <a:defRPr sz="1550">
-                <a:solidFill>
-                  <a:srgbClr val="CBD5E1"/>
+              <a:defRPr sz="1350" b="1">
+                <a:solidFill>
+                  <a:srgbClr val="0F172A"/>
                 </a:solidFill>
                 <a:latin typeface="Segoe UI"/>
               </a:defRPr>
             </a:pPr>
             <a:r>
-              <a:t>•  Complex Subquery Nesting: Deeply nested SELECT projections decrease readability and limit database optimizer index lookup performance.</a:t>
-            </a:r>
-          </a:p>
+              <a:t>Complex Subquery Nesting: </a:t>
+            </a:r>
+            <a:r>
+              <a:rPr sz="1300" b="0">
+                <a:solidFill>
+                  <a:srgbClr val="334155"/>
+                </a:solidFill>
+                <a:latin typeface="Segoe UI"/>
+              </a:rPr>
+              <a:t>Deeply nested SELECT projections decrease readability and limit database optimizer index lookup performance.</a:t>
+            </a:r>
+          </a:p>
+        </p:txBody>
+      </p:sp>
+      <p:sp>
+        <p:nvSpPr>
+          <p:cNvPr id="14" name="Rounded Rectangle 13"/>
+          <p:cNvSpPr/>
+          <p:nvPr/>
+        </p:nvSpPr>
+        <p:spPr>
+          <a:xfrm>
+            <a:off x="685800" y="4251960"/>
+            <a:ext cx="10817352" cy="777240"/>
+          </a:xfrm>
+          <a:prstGeom prst="roundRect">
+            <a:avLst/>
+          </a:prstGeom>
+          <a:solidFill>
+            <a:srgbClr val="FFFFFF"/>
+          </a:solidFill>
+          <a:ln w="19050">
+            <a:solidFill>
+              <a:srgbClr val="E0E7FF"/>
+            </a:solidFill>
+          </a:ln>
+        </p:spPr>
+        <p:style>
+          <a:lnRef idx="1">
+            <a:schemeClr val="accent1"/>
+          </a:lnRef>
+          <a:fillRef idx="3">
+            <a:schemeClr val="accent1"/>
+          </a:fillRef>
+          <a:effectRef idx="2">
+            <a:schemeClr val="accent1"/>
+          </a:effectRef>
+          <a:fontRef idx="minor">
+            <a:schemeClr val="lt1"/>
+          </a:fontRef>
+        </p:style>
+        <p:txBody>
+          <a:bodyPr rtlCol="0" anchor="ctr"/>
+          <a:lstStyle/>
+          <a:p>
+            <a:pPr algn="ctr"/>
+          </a:p>
+        </p:txBody>
+      </p:sp>
+      <p:sp>
+        <p:nvSpPr>
+          <p:cNvPr id="15" name="Rectangle 14"/>
+          <p:cNvSpPr/>
+          <p:nvPr/>
+        </p:nvSpPr>
+        <p:spPr>
+          <a:xfrm>
+            <a:off x="685800" y="4251960"/>
+            <a:ext cx="109728" cy="777240"/>
+          </a:xfrm>
+          <a:prstGeom prst="rect">
+            <a:avLst/>
+          </a:prstGeom>
+          <a:solidFill>
+            <a:srgbClr val="EF4444"/>
+          </a:solidFill>
+          <a:ln>
+            <a:noFill/>
+          </a:ln>
+        </p:spPr>
+        <p:style>
+          <a:lnRef idx="1">
+            <a:schemeClr val="accent1"/>
+          </a:lnRef>
+          <a:fillRef idx="3">
+            <a:schemeClr val="accent1"/>
+          </a:fillRef>
+          <a:effectRef idx="2">
+            <a:schemeClr val="accent1"/>
+          </a:effectRef>
+          <a:fontRef idx="minor">
+            <a:schemeClr val="lt1"/>
+          </a:fontRef>
+        </p:style>
+        <p:txBody>
+          <a:bodyPr rtlCol="0" anchor="ctr"/>
+          <a:lstStyle/>
+          <a:p>
+            <a:pPr algn="ctr"/>
+          </a:p>
+        </p:txBody>
+      </p:sp>
+      <p:sp>
+        <p:nvSpPr>
+          <p:cNvPr id="16" name="TextBox 15"/>
+          <p:cNvSpPr txBox="1"/>
+          <p:nvPr/>
+        </p:nvSpPr>
+        <p:spPr>
+          <a:xfrm>
+            <a:off x="1005840" y="4325112"/>
+            <a:ext cx="10314432" cy="630936"/>
+          </a:xfrm>
+          <a:prstGeom prst="rect">
+            <a:avLst/>
+          </a:prstGeom>
+          <a:noFill/>
+        </p:spPr>
+        <p:txBody>
+          <a:bodyPr wrap="square" lIns="0" tIns="0" rIns="0" bIns="0">
+            <a:spAutoFit/>
+          </a:bodyPr>
+          <a:lstStyle/>
           <a:p>
             <a:pPr>
-              <a:spcAft>
-                <a:spcPts val="1200"/>
-              </a:spcAft>
-              <a:defRPr sz="1550">
-                <a:solidFill>
-                  <a:srgbClr val="CBD5E1"/>
+              <a:defRPr sz="1350" b="1">
+                <a:solidFill>
+                  <a:srgbClr val="0F172A"/>
                 </a:solidFill>
                 <a:latin typeface="Segoe UI"/>
               </a:defRPr>
             </a:pPr>
             <a:r>
-              <a:t>•  Cost Inflation: Unrestricted use of SELECT * drives up cloud data processing costs under pay-per-query models.</a:t>
-            </a:r>
-          </a:p>
+              <a:t>Cost Inflation: </a:t>
+            </a:r>
+            <a:r>
+              <a:rPr sz="1300" b="0">
+                <a:solidFill>
+                  <a:srgbClr val="334155"/>
+                </a:solidFill>
+                <a:latin typeface="Segoe UI"/>
+              </a:rPr>
+              <a:t>Unrestricted use of SELECT * drives up cloud data processing costs under pay-per-query models.</a:t>
+            </a:r>
+          </a:p>
+        </p:txBody>
+      </p:sp>
+      <p:sp>
+        <p:nvSpPr>
+          <p:cNvPr id="17" name="Rounded Rectangle 16"/>
+          <p:cNvSpPr/>
+          <p:nvPr/>
+        </p:nvSpPr>
+        <p:spPr>
+          <a:xfrm>
+            <a:off x="685800" y="5120640"/>
+            <a:ext cx="10817352" cy="777240"/>
+          </a:xfrm>
+          <a:prstGeom prst="roundRect">
+            <a:avLst/>
+          </a:prstGeom>
+          <a:solidFill>
+            <a:srgbClr val="FFFFFF"/>
+          </a:solidFill>
+          <a:ln w="19050">
+            <a:solidFill>
+              <a:srgbClr val="E0E7FF"/>
+            </a:solidFill>
+          </a:ln>
+        </p:spPr>
+        <p:style>
+          <a:lnRef idx="1">
+            <a:schemeClr val="accent1"/>
+          </a:lnRef>
+          <a:fillRef idx="3">
+            <a:schemeClr val="accent1"/>
+          </a:fillRef>
+          <a:effectRef idx="2">
+            <a:schemeClr val="accent1"/>
+          </a:effectRef>
+          <a:fontRef idx="minor">
+            <a:schemeClr val="lt1"/>
+          </a:fontRef>
+        </p:style>
+        <p:txBody>
+          <a:bodyPr rtlCol="0" anchor="ctr"/>
+          <a:lstStyle/>
+          <a:p>
+            <a:pPr algn="ctr"/>
+          </a:p>
+        </p:txBody>
+      </p:sp>
+      <p:sp>
+        <p:nvSpPr>
+          <p:cNvPr id="18" name="Rectangle 17"/>
+          <p:cNvSpPr/>
+          <p:nvPr/>
+        </p:nvSpPr>
+        <p:spPr>
+          <a:xfrm>
+            <a:off x="685800" y="5120640"/>
+            <a:ext cx="109728" cy="777240"/>
+          </a:xfrm>
+          <a:prstGeom prst="rect">
+            <a:avLst/>
+          </a:prstGeom>
+          <a:solidFill>
+            <a:srgbClr val="EF4444"/>
+          </a:solidFill>
+          <a:ln>
+            <a:noFill/>
+          </a:ln>
+        </p:spPr>
+        <p:style>
+          <a:lnRef idx="1">
+            <a:schemeClr val="accent1"/>
+          </a:lnRef>
+          <a:fillRef idx="3">
+            <a:schemeClr val="accent1"/>
+          </a:fillRef>
+          <a:effectRef idx="2">
+            <a:schemeClr val="accent1"/>
+          </a:effectRef>
+          <a:fontRef idx="minor">
+            <a:schemeClr val="lt1"/>
+          </a:fontRef>
+        </p:style>
+        <p:txBody>
+          <a:bodyPr rtlCol="0" anchor="ctr"/>
+          <a:lstStyle/>
+          <a:p>
+            <a:pPr algn="ctr"/>
+          </a:p>
+        </p:txBody>
+      </p:sp>
+      <p:sp>
+        <p:nvSpPr>
+          <p:cNvPr id="19" name="TextBox 18"/>
+          <p:cNvSpPr txBox="1"/>
+          <p:nvPr/>
+        </p:nvSpPr>
+        <p:spPr>
+          <a:xfrm>
+            <a:off x="1005840" y="5193792"/>
+            <a:ext cx="10314432" cy="630936"/>
+          </a:xfrm>
+          <a:prstGeom prst="rect">
+            <a:avLst/>
+          </a:prstGeom>
+          <a:noFill/>
+        </p:spPr>
+        <p:txBody>
+          <a:bodyPr wrap="square" lIns="0" tIns="0" rIns="0" bIns="0">
+            <a:spAutoFit/>
+          </a:bodyPr>
+          <a:lstStyle/>
           <a:p>
             <a:pPr>
-              <a:spcAft>
-                <a:spcPts val="1200"/>
-              </a:spcAft>
-              <a:defRPr sz="1550">
-                <a:solidFill>
-                  <a:srgbClr val="CBD5E1"/>
+              <a:defRPr sz="1350" b="1">
+                <a:solidFill>
+                  <a:srgbClr val="0F172A"/>
                 </a:solidFill>
                 <a:latin typeface="Segoe UI"/>
               </a:defRPr>
             </a:pPr>
             <a:r>
-              <a:t>•  Validation Vulnerability: Rule-based linters only clean basic whitespace, whereas raw LLM optimization agents can hallucinate and generate syntactically broken SQL queries.</a:t>
+              <a:t>Validation Vulnerability: </a:t>
+            </a:r>
+            <a:r>
+              <a:rPr sz="1300" b="0">
+                <a:solidFill>
+                  <a:srgbClr val="334155"/>
+                </a:solidFill>
+                <a:latin typeface="Segoe UI"/>
+              </a:rPr>
+              <a:t>Rule-based linters only clean basic whitespace, whereas raw LLM optimization agents can hallucinate and generate syntactically broken SQL queries.</a:t>
             </a:r>
           </a:p>
         </p:txBody>
@@ -3862,7 +4595,7 @@
     <p:bg>
       <p:bgPr>
         <a:solidFill>
-          <a:srgbClr val="0B1324"/>
+          <a:srgbClr val="F8FAFC"/>
         </a:solidFill>
         <a:effectLst/>
       </p:bgPr>
@@ -3899,7 +4632,7 @@
             <a:pPr>
               <a:defRPr sz="3200" b="1">
                 <a:solidFill>
-                  <a:srgbClr val="F8FAFC"/>
+                  <a:srgbClr val="0F172A"/>
                 </a:solidFill>
                 <a:latin typeface="Segoe UI"/>
               </a:defRPr>
@@ -3919,13 +4652,13 @@
         <p:spPr>
           <a:xfrm>
             <a:off x="685800" y="1188720"/>
-            <a:ext cx="10817352" cy="27432"/>
+            <a:ext cx="10817352" cy="36576"/>
           </a:xfrm>
           <a:prstGeom prst="rect">
             <a:avLst/>
           </a:prstGeom>
           <a:solidFill>
-            <a:srgbClr val="22D3EE"/>
+            <a:srgbClr val="4F46E5"/>
           </a:solidFill>
           <a:ln>
             <a:noFill/>
@@ -3961,7 +4694,7 @@
         </p:nvSpPr>
         <p:spPr>
           <a:xfrm>
-            <a:off x="685800" y="6309360"/>
+            <a:off x="685800" y="6355080"/>
             <a:ext cx="10817352" cy="274320"/>
           </a:xfrm>
           <a:prstGeom prst="rect">
@@ -3991,14 +4724,102 @@
       </p:sp>
       <p:sp>
         <p:nvSpPr>
-          <p:cNvPr id="5" name="TextBox 4"/>
+          <p:cNvPr id="5" name="Rounded Rectangle 4"/>
+          <p:cNvSpPr/>
+          <p:nvPr/>
+        </p:nvSpPr>
+        <p:spPr>
+          <a:xfrm>
+            <a:off x="685800" y="1645920"/>
+            <a:ext cx="10817352" cy="777240"/>
+          </a:xfrm>
+          <a:prstGeom prst="roundRect">
+            <a:avLst/>
+          </a:prstGeom>
+          <a:solidFill>
+            <a:srgbClr val="FFFFFF"/>
+          </a:solidFill>
+          <a:ln w="19050">
+            <a:solidFill>
+              <a:srgbClr val="E0E7FF"/>
+            </a:solidFill>
+          </a:ln>
+        </p:spPr>
+        <p:style>
+          <a:lnRef idx="1">
+            <a:schemeClr val="accent1"/>
+          </a:lnRef>
+          <a:fillRef idx="3">
+            <a:schemeClr val="accent1"/>
+          </a:fillRef>
+          <a:effectRef idx="2">
+            <a:schemeClr val="accent1"/>
+          </a:effectRef>
+          <a:fontRef idx="minor">
+            <a:schemeClr val="lt1"/>
+          </a:fontRef>
+        </p:style>
+        <p:txBody>
+          <a:bodyPr rtlCol="0" anchor="ctr"/>
+          <a:lstStyle/>
+          <a:p>
+            <a:pPr algn="ctr"/>
+          </a:p>
+        </p:txBody>
+      </p:sp>
+      <p:sp>
+        <p:nvSpPr>
+          <p:cNvPr id="6" name="Rectangle 5"/>
+          <p:cNvSpPr/>
+          <p:nvPr/>
+        </p:nvSpPr>
+        <p:spPr>
+          <a:xfrm>
+            <a:off x="685800" y="1645920"/>
+            <a:ext cx="109728" cy="777240"/>
+          </a:xfrm>
+          <a:prstGeom prst="rect">
+            <a:avLst/>
+          </a:prstGeom>
+          <a:solidFill>
+            <a:srgbClr val="4F46E5"/>
+          </a:solidFill>
+          <a:ln>
+            <a:noFill/>
+          </a:ln>
+        </p:spPr>
+        <p:style>
+          <a:lnRef idx="1">
+            <a:schemeClr val="accent1"/>
+          </a:lnRef>
+          <a:fillRef idx="3">
+            <a:schemeClr val="accent1"/>
+          </a:fillRef>
+          <a:effectRef idx="2">
+            <a:schemeClr val="accent1"/>
+          </a:effectRef>
+          <a:fontRef idx="minor">
+            <a:schemeClr val="lt1"/>
+          </a:fontRef>
+        </p:style>
+        <p:txBody>
+          <a:bodyPr rtlCol="0" anchor="ctr"/>
+          <a:lstStyle/>
+          <a:p>
+            <a:pPr algn="ctr"/>
+          </a:p>
+        </p:txBody>
+      </p:sp>
+      <p:sp>
+        <p:nvSpPr>
+          <p:cNvPr id="7" name="TextBox 6"/>
           <p:cNvSpPr txBox="1"/>
           <p:nvPr/>
         </p:nvSpPr>
         <p:spPr>
           <a:xfrm>
-            <a:off x="685800" y="1645920"/>
-            <a:ext cx="10817352" cy="4389120"/>
+            <a:off x="1005840" y="1719072"/>
+            <a:ext cx="10314432" cy="630936"/>
           </a:xfrm>
           <a:prstGeom prst="rect">
             <a:avLst/>
@@ -4012,123 +4833,552 @@
           <a:lstStyle/>
           <a:p>
             <a:pPr>
-              <a:spcAft>
-                <a:spcPts val="1000"/>
-              </a:spcAft>
-              <a:defRPr sz="1550" b="1">
-                <a:solidFill>
-                  <a:srgbClr val="22D3EE"/>
+              <a:defRPr sz="1350" b="1">
+                <a:solidFill>
+                  <a:srgbClr val="0F172A"/>
                 </a:solidFill>
                 <a:latin typeface="Segoe UI"/>
               </a:defRPr>
             </a:pPr>
             <a:r>
-              <a:t>•  Python: </a:t>
-            </a:r>
-            <a:r>
-              <a:rPr sz="1550" b="0">
-                <a:solidFill>
-                  <a:srgbClr val="CBD5E1"/>
+              <a:t>Python: </a:t>
+            </a:r>
+            <a:r>
+              <a:rPr sz="1300" b="0">
+                <a:solidFill>
+                  <a:srgbClr val="334155"/>
                 </a:solidFill>
                 <a:latin typeface="Segoe UI"/>
               </a:rPr>
               <a:t>Core language for deterministic regex compilation, script execution, and API routing.</a:t>
             </a:r>
           </a:p>
+        </p:txBody>
+      </p:sp>
+      <p:sp>
+        <p:nvSpPr>
+          <p:cNvPr id="8" name="Rounded Rectangle 7"/>
+          <p:cNvSpPr/>
+          <p:nvPr/>
+        </p:nvSpPr>
+        <p:spPr>
+          <a:xfrm>
+            <a:off x="685800" y="2514600"/>
+            <a:ext cx="10817352" cy="777240"/>
+          </a:xfrm>
+          <a:prstGeom prst="roundRect">
+            <a:avLst/>
+          </a:prstGeom>
+          <a:solidFill>
+            <a:srgbClr val="FFFFFF"/>
+          </a:solidFill>
+          <a:ln w="19050">
+            <a:solidFill>
+              <a:srgbClr val="E0E7FF"/>
+            </a:solidFill>
+          </a:ln>
+        </p:spPr>
+        <p:style>
+          <a:lnRef idx="1">
+            <a:schemeClr val="accent1"/>
+          </a:lnRef>
+          <a:fillRef idx="3">
+            <a:schemeClr val="accent1"/>
+          </a:fillRef>
+          <a:effectRef idx="2">
+            <a:schemeClr val="accent1"/>
+          </a:effectRef>
+          <a:fontRef idx="minor">
+            <a:schemeClr val="lt1"/>
+          </a:fontRef>
+        </p:style>
+        <p:txBody>
+          <a:bodyPr rtlCol="0" anchor="ctr"/>
+          <a:lstStyle/>
+          <a:p>
+            <a:pPr algn="ctr"/>
+          </a:p>
+        </p:txBody>
+      </p:sp>
+      <p:sp>
+        <p:nvSpPr>
+          <p:cNvPr id="9" name="Rectangle 8"/>
+          <p:cNvSpPr/>
+          <p:nvPr/>
+        </p:nvSpPr>
+        <p:spPr>
+          <a:xfrm>
+            <a:off x="685800" y="2514600"/>
+            <a:ext cx="109728" cy="777240"/>
+          </a:xfrm>
+          <a:prstGeom prst="rect">
+            <a:avLst/>
+          </a:prstGeom>
+          <a:solidFill>
+            <a:srgbClr val="4F46E5"/>
+          </a:solidFill>
+          <a:ln>
+            <a:noFill/>
+          </a:ln>
+        </p:spPr>
+        <p:style>
+          <a:lnRef idx="1">
+            <a:schemeClr val="accent1"/>
+          </a:lnRef>
+          <a:fillRef idx="3">
+            <a:schemeClr val="accent1"/>
+          </a:fillRef>
+          <a:effectRef idx="2">
+            <a:schemeClr val="accent1"/>
+          </a:effectRef>
+          <a:fontRef idx="minor">
+            <a:schemeClr val="lt1"/>
+          </a:fontRef>
+        </p:style>
+        <p:txBody>
+          <a:bodyPr rtlCol="0" anchor="ctr"/>
+          <a:lstStyle/>
+          <a:p>
+            <a:pPr algn="ctr"/>
+          </a:p>
+        </p:txBody>
+      </p:sp>
+      <p:sp>
+        <p:nvSpPr>
+          <p:cNvPr id="10" name="TextBox 9"/>
+          <p:cNvSpPr txBox="1"/>
+          <p:nvPr/>
+        </p:nvSpPr>
+        <p:spPr>
+          <a:xfrm>
+            <a:off x="1005840" y="2587752"/>
+            <a:ext cx="10314432" cy="630936"/>
+          </a:xfrm>
+          <a:prstGeom prst="rect">
+            <a:avLst/>
+          </a:prstGeom>
+          <a:noFill/>
+        </p:spPr>
+        <p:txBody>
+          <a:bodyPr wrap="square" lIns="0" tIns="0" rIns="0" bIns="0">
+            <a:spAutoFit/>
+          </a:bodyPr>
+          <a:lstStyle/>
           <a:p>
             <a:pPr>
-              <a:spcAft>
-                <a:spcPts val="1000"/>
-              </a:spcAft>
-              <a:defRPr sz="1550" b="1">
-                <a:solidFill>
-                  <a:srgbClr val="22D3EE"/>
+              <a:defRPr sz="1350" b="1">
+                <a:solidFill>
+                  <a:srgbClr val="0F172A"/>
                 </a:solidFill>
                 <a:latin typeface="Segoe UI"/>
               </a:defRPr>
             </a:pPr>
             <a:r>
-              <a:t>•  Streamlit Framework: </a:t>
-            </a:r>
-            <a:r>
-              <a:rPr sz="1550" b="0">
-                <a:solidFill>
-                  <a:srgbClr val="CBD5E1"/>
+              <a:t>Streamlit Framework: </a:t>
+            </a:r>
+            <a:r>
+              <a:rPr sz="1300" b="0">
+                <a:solidFill>
+                  <a:srgbClr val="334155"/>
                 </a:solidFill>
                 <a:latin typeface="Segoe UI"/>
               </a:rPr>
               <a:t>For designing the user interface dashboard workspace, the batch file uploader, and in-memory downloads.</a:t>
             </a:r>
           </a:p>
+        </p:txBody>
+      </p:sp>
+      <p:sp>
+        <p:nvSpPr>
+          <p:cNvPr id="11" name="Rounded Rectangle 10"/>
+          <p:cNvSpPr/>
+          <p:nvPr/>
+        </p:nvSpPr>
+        <p:spPr>
+          <a:xfrm>
+            <a:off x="685800" y="3383280"/>
+            <a:ext cx="10817352" cy="777240"/>
+          </a:xfrm>
+          <a:prstGeom prst="roundRect">
+            <a:avLst/>
+          </a:prstGeom>
+          <a:solidFill>
+            <a:srgbClr val="FFFFFF"/>
+          </a:solidFill>
+          <a:ln w="19050">
+            <a:solidFill>
+              <a:srgbClr val="E0E7FF"/>
+            </a:solidFill>
+          </a:ln>
+        </p:spPr>
+        <p:style>
+          <a:lnRef idx="1">
+            <a:schemeClr val="accent1"/>
+          </a:lnRef>
+          <a:fillRef idx="3">
+            <a:schemeClr val="accent1"/>
+          </a:fillRef>
+          <a:effectRef idx="2">
+            <a:schemeClr val="accent1"/>
+          </a:effectRef>
+          <a:fontRef idx="minor">
+            <a:schemeClr val="lt1"/>
+          </a:fontRef>
+        </p:style>
+        <p:txBody>
+          <a:bodyPr rtlCol="0" anchor="ctr"/>
+          <a:lstStyle/>
+          <a:p>
+            <a:pPr algn="ctr"/>
+          </a:p>
+        </p:txBody>
+      </p:sp>
+      <p:sp>
+        <p:nvSpPr>
+          <p:cNvPr id="12" name="Rectangle 11"/>
+          <p:cNvSpPr/>
+          <p:nvPr/>
+        </p:nvSpPr>
+        <p:spPr>
+          <a:xfrm>
+            <a:off x="685800" y="3383280"/>
+            <a:ext cx="109728" cy="777240"/>
+          </a:xfrm>
+          <a:prstGeom prst="rect">
+            <a:avLst/>
+          </a:prstGeom>
+          <a:solidFill>
+            <a:srgbClr val="4F46E5"/>
+          </a:solidFill>
+          <a:ln>
+            <a:noFill/>
+          </a:ln>
+        </p:spPr>
+        <p:style>
+          <a:lnRef idx="1">
+            <a:schemeClr val="accent1"/>
+          </a:lnRef>
+          <a:fillRef idx="3">
+            <a:schemeClr val="accent1"/>
+          </a:fillRef>
+          <a:effectRef idx="2">
+            <a:schemeClr val="accent1"/>
+          </a:effectRef>
+          <a:fontRef idx="minor">
+            <a:schemeClr val="lt1"/>
+          </a:fontRef>
+        </p:style>
+        <p:txBody>
+          <a:bodyPr rtlCol="0" anchor="ctr"/>
+          <a:lstStyle/>
+          <a:p>
+            <a:pPr algn="ctr"/>
+          </a:p>
+        </p:txBody>
+      </p:sp>
+      <p:sp>
+        <p:nvSpPr>
+          <p:cNvPr id="13" name="TextBox 12"/>
+          <p:cNvSpPr txBox="1"/>
+          <p:nvPr/>
+        </p:nvSpPr>
+        <p:spPr>
+          <a:xfrm>
+            <a:off x="1005840" y="3456432"/>
+            <a:ext cx="10314432" cy="630936"/>
+          </a:xfrm>
+          <a:prstGeom prst="rect">
+            <a:avLst/>
+          </a:prstGeom>
+          <a:noFill/>
+        </p:spPr>
+        <p:txBody>
+          <a:bodyPr wrap="square" lIns="0" tIns="0" rIns="0" bIns="0">
+            <a:spAutoFit/>
+          </a:bodyPr>
+          <a:lstStyle/>
           <a:p>
             <a:pPr>
-              <a:spcAft>
-                <a:spcPts val="1000"/>
-              </a:spcAft>
-              <a:defRPr sz="1550" b="1">
-                <a:solidFill>
-                  <a:srgbClr val="22D3EE"/>
+              <a:defRPr sz="1350" b="1">
+                <a:solidFill>
+                  <a:srgbClr val="0F172A"/>
                 </a:solidFill>
                 <a:latin typeface="Segoe UI"/>
               </a:defRPr>
             </a:pPr>
             <a:r>
-              <a:t>•  Google Gemini API (gemini-2.5-flash): </a:t>
-            </a:r>
-            <a:r>
-              <a:rPr sz="1550" b="0">
-                <a:solidFill>
-                  <a:srgbClr val="CBD5E1"/>
+              <a:t>Google Gemini API (gemini-2.5-flash): </a:t>
+            </a:r>
+            <a:r>
+              <a:rPr sz="1300" b="0">
+                <a:solidFill>
+                  <a:srgbClr val="334155"/>
                 </a:solidFill>
                 <a:latin typeface="Segoe UI"/>
               </a:rPr>
               <a:t>Serverless AI model utilized for semantic query refactoring (CTEs, Joins) configured with low temperature (0.1) and few-shot examples.</a:t>
             </a:r>
           </a:p>
+        </p:txBody>
+      </p:sp>
+      <p:sp>
+        <p:nvSpPr>
+          <p:cNvPr id="14" name="Rounded Rectangle 13"/>
+          <p:cNvSpPr/>
+          <p:nvPr/>
+        </p:nvSpPr>
+        <p:spPr>
+          <a:xfrm>
+            <a:off x="685800" y="4251960"/>
+            <a:ext cx="10817352" cy="777240"/>
+          </a:xfrm>
+          <a:prstGeom prst="roundRect">
+            <a:avLst/>
+          </a:prstGeom>
+          <a:solidFill>
+            <a:srgbClr val="FFFFFF"/>
+          </a:solidFill>
+          <a:ln w="19050">
+            <a:solidFill>
+              <a:srgbClr val="E0E7FF"/>
+            </a:solidFill>
+          </a:ln>
+        </p:spPr>
+        <p:style>
+          <a:lnRef idx="1">
+            <a:schemeClr val="accent1"/>
+          </a:lnRef>
+          <a:fillRef idx="3">
+            <a:schemeClr val="accent1"/>
+          </a:fillRef>
+          <a:effectRef idx="2">
+            <a:schemeClr val="accent1"/>
+          </a:effectRef>
+          <a:fontRef idx="minor">
+            <a:schemeClr val="lt1"/>
+          </a:fontRef>
+        </p:style>
+        <p:txBody>
+          <a:bodyPr rtlCol="0" anchor="ctr"/>
+          <a:lstStyle/>
+          <a:p>
+            <a:pPr algn="ctr"/>
+          </a:p>
+        </p:txBody>
+      </p:sp>
+      <p:sp>
+        <p:nvSpPr>
+          <p:cNvPr id="15" name="Rectangle 14"/>
+          <p:cNvSpPr/>
+          <p:nvPr/>
+        </p:nvSpPr>
+        <p:spPr>
+          <a:xfrm>
+            <a:off x="685800" y="4251960"/>
+            <a:ext cx="109728" cy="777240"/>
+          </a:xfrm>
+          <a:prstGeom prst="rect">
+            <a:avLst/>
+          </a:prstGeom>
+          <a:solidFill>
+            <a:srgbClr val="4F46E5"/>
+          </a:solidFill>
+          <a:ln>
+            <a:noFill/>
+          </a:ln>
+        </p:spPr>
+        <p:style>
+          <a:lnRef idx="1">
+            <a:schemeClr val="accent1"/>
+          </a:lnRef>
+          <a:fillRef idx="3">
+            <a:schemeClr val="accent1"/>
+          </a:fillRef>
+          <a:effectRef idx="2">
+            <a:schemeClr val="accent1"/>
+          </a:effectRef>
+          <a:fontRef idx="minor">
+            <a:schemeClr val="lt1"/>
+          </a:fontRef>
+        </p:style>
+        <p:txBody>
+          <a:bodyPr rtlCol="0" anchor="ctr"/>
+          <a:lstStyle/>
+          <a:p>
+            <a:pPr algn="ctr"/>
+          </a:p>
+        </p:txBody>
+      </p:sp>
+      <p:sp>
+        <p:nvSpPr>
+          <p:cNvPr id="16" name="TextBox 15"/>
+          <p:cNvSpPr txBox="1"/>
+          <p:nvPr/>
+        </p:nvSpPr>
+        <p:spPr>
+          <a:xfrm>
+            <a:off x="1005840" y="4325112"/>
+            <a:ext cx="10314432" cy="630936"/>
+          </a:xfrm>
+          <a:prstGeom prst="rect">
+            <a:avLst/>
+          </a:prstGeom>
+          <a:noFill/>
+        </p:spPr>
+        <p:txBody>
+          <a:bodyPr wrap="square" lIns="0" tIns="0" rIns="0" bIns="0">
+            <a:spAutoFit/>
+          </a:bodyPr>
+          <a:lstStyle/>
           <a:p>
             <a:pPr>
-              <a:spcAft>
-                <a:spcPts val="1000"/>
-              </a:spcAft>
-              <a:defRPr sz="1550" b="1">
-                <a:solidFill>
-                  <a:srgbClr val="22D3EE"/>
+              <a:defRPr sz="1350" b="1">
+                <a:solidFill>
+                  <a:srgbClr val="0F172A"/>
                 </a:solidFill>
                 <a:latin typeface="Segoe UI"/>
               </a:defRPr>
             </a:pPr>
             <a:r>
-              <a:t>•  sqlglot Parser: </a:t>
-            </a:r>
-            <a:r>
-              <a:rPr sz="1550" b="0">
-                <a:solidFill>
-                  <a:srgbClr val="CBD5E1"/>
+              <a:t>sqlglot Parser: </a:t>
+            </a:r>
+            <a:r>
+              <a:rPr sz="1300" b="0">
+                <a:solidFill>
+                  <a:srgbClr val="334155"/>
                 </a:solidFill>
                 <a:latin typeface="Segoe UI"/>
               </a:rPr>
               <a:t>Local dialect-aware parser used to pretty-print statements and validate AST syntax inside the correction loop.</a:t>
             </a:r>
           </a:p>
+        </p:txBody>
+      </p:sp>
+      <p:sp>
+        <p:nvSpPr>
+          <p:cNvPr id="17" name="Rounded Rectangle 16"/>
+          <p:cNvSpPr/>
+          <p:nvPr/>
+        </p:nvSpPr>
+        <p:spPr>
+          <a:xfrm>
+            <a:off x="685800" y="5120640"/>
+            <a:ext cx="10817352" cy="777240"/>
+          </a:xfrm>
+          <a:prstGeom prst="roundRect">
+            <a:avLst/>
+          </a:prstGeom>
+          <a:solidFill>
+            <a:srgbClr val="FFFFFF"/>
+          </a:solidFill>
+          <a:ln w="19050">
+            <a:solidFill>
+              <a:srgbClr val="E0E7FF"/>
+            </a:solidFill>
+          </a:ln>
+        </p:spPr>
+        <p:style>
+          <a:lnRef idx="1">
+            <a:schemeClr val="accent1"/>
+          </a:lnRef>
+          <a:fillRef idx="3">
+            <a:schemeClr val="accent1"/>
+          </a:fillRef>
+          <a:effectRef idx="2">
+            <a:schemeClr val="accent1"/>
+          </a:effectRef>
+          <a:fontRef idx="minor">
+            <a:schemeClr val="lt1"/>
+          </a:fontRef>
+        </p:style>
+        <p:txBody>
+          <a:bodyPr rtlCol="0" anchor="ctr"/>
+          <a:lstStyle/>
+          <a:p>
+            <a:pPr algn="ctr"/>
+          </a:p>
+        </p:txBody>
+      </p:sp>
+      <p:sp>
+        <p:nvSpPr>
+          <p:cNvPr id="18" name="Rectangle 17"/>
+          <p:cNvSpPr/>
+          <p:nvPr/>
+        </p:nvSpPr>
+        <p:spPr>
+          <a:xfrm>
+            <a:off x="685800" y="5120640"/>
+            <a:ext cx="109728" cy="777240"/>
+          </a:xfrm>
+          <a:prstGeom prst="rect">
+            <a:avLst/>
+          </a:prstGeom>
+          <a:solidFill>
+            <a:srgbClr val="4F46E5"/>
+          </a:solidFill>
+          <a:ln>
+            <a:noFill/>
+          </a:ln>
+        </p:spPr>
+        <p:style>
+          <a:lnRef idx="1">
+            <a:schemeClr val="accent1"/>
+          </a:lnRef>
+          <a:fillRef idx="3">
+            <a:schemeClr val="accent1"/>
+          </a:fillRef>
+          <a:effectRef idx="2">
+            <a:schemeClr val="accent1"/>
+          </a:effectRef>
+          <a:fontRef idx="minor">
+            <a:schemeClr val="lt1"/>
+          </a:fontRef>
+        </p:style>
+        <p:txBody>
+          <a:bodyPr rtlCol="0" anchor="ctr"/>
+          <a:lstStyle/>
+          <a:p>
+            <a:pPr algn="ctr"/>
+          </a:p>
+        </p:txBody>
+      </p:sp>
+      <p:sp>
+        <p:nvSpPr>
+          <p:cNvPr id="19" name="TextBox 18"/>
+          <p:cNvSpPr txBox="1"/>
+          <p:nvPr/>
+        </p:nvSpPr>
+        <p:spPr>
+          <a:xfrm>
+            <a:off x="1005840" y="5193792"/>
+            <a:ext cx="10314432" cy="630936"/>
+          </a:xfrm>
+          <a:prstGeom prst="rect">
+            <a:avLst/>
+          </a:prstGeom>
+          <a:noFill/>
+        </p:spPr>
+        <p:txBody>
+          <a:bodyPr wrap="square" lIns="0" tIns="0" rIns="0" bIns="0">
+            <a:spAutoFit/>
+          </a:bodyPr>
+          <a:lstStyle/>
           <a:p>
             <a:pPr>
-              <a:spcAft>
-                <a:spcPts val="1000"/>
-              </a:spcAft>
-              <a:defRPr sz="1550" b="1">
-                <a:solidFill>
-                  <a:srgbClr val="22D3EE"/>
+              <a:defRPr sz="1350" b="1">
+                <a:solidFill>
+                  <a:srgbClr val="0F172A"/>
                 </a:solidFill>
                 <a:latin typeface="Segoe UI"/>
               </a:defRPr>
             </a:pPr>
             <a:r>
-              <a:t>•  difflib: </a:t>
-            </a:r>
-            <a:r>
-              <a:rPr sz="1550" b="0">
-                <a:solidFill>
-                  <a:srgbClr val="CBD5E1"/>
+              <a:t>difflib: </a:t>
+            </a:r>
+            <a:r>
+              <a:rPr sz="1300" b="0">
+                <a:solidFill>
+                  <a:srgbClr val="334155"/>
                 </a:solidFill>
                 <a:latin typeface="Segoe UI"/>
               </a:rPr>
@@ -4151,7 +5401,7 @@
     <p:bg>
       <p:bgPr>
         <a:solidFill>
-          <a:srgbClr val="0B1324"/>
+          <a:srgbClr val="F8FAFC"/>
         </a:solidFill>
         <a:effectLst/>
       </p:bgPr>
@@ -4188,7 +5438,7 @@
             <a:pPr>
               <a:defRPr sz="3200" b="1">
                 <a:solidFill>
-                  <a:srgbClr val="F8FAFC"/>
+                  <a:srgbClr val="0F172A"/>
                 </a:solidFill>
                 <a:latin typeface="Segoe UI"/>
               </a:defRPr>
@@ -4208,13 +5458,13 @@
         <p:spPr>
           <a:xfrm>
             <a:off x="685800" y="1188720"/>
-            <a:ext cx="10817352" cy="27432"/>
+            <a:ext cx="10817352" cy="36576"/>
           </a:xfrm>
           <a:prstGeom prst="rect">
             <a:avLst/>
           </a:prstGeom>
           <a:solidFill>
-            <a:srgbClr val="22D3EE"/>
+            <a:srgbClr val="4F46E5"/>
           </a:solidFill>
           <a:ln>
             <a:noFill/>
@@ -4250,7 +5500,7 @@
         </p:nvSpPr>
         <p:spPr>
           <a:xfrm>
-            <a:off x="685800" y="6309360"/>
+            <a:off x="685800" y="6355080"/>
             <a:ext cx="10817352" cy="274320"/>
           </a:xfrm>
           <a:prstGeom prst="rect">
@@ -4280,14 +5530,102 @@
       </p:sp>
       <p:sp>
         <p:nvSpPr>
-          <p:cNvPr id="5" name="TextBox 4"/>
+          <p:cNvPr id="5" name="Rounded Rectangle 4"/>
+          <p:cNvSpPr/>
+          <p:nvPr/>
+        </p:nvSpPr>
+        <p:spPr>
+          <a:xfrm>
+            <a:off x="685800" y="1645920"/>
+            <a:ext cx="10817352" cy="640080"/>
+          </a:xfrm>
+          <a:prstGeom prst="roundRect">
+            <a:avLst/>
+          </a:prstGeom>
+          <a:solidFill>
+            <a:srgbClr val="FFFFFF"/>
+          </a:solidFill>
+          <a:ln w="19050">
+            <a:solidFill>
+              <a:srgbClr val="E0E7FF"/>
+            </a:solidFill>
+          </a:ln>
+        </p:spPr>
+        <p:style>
+          <a:lnRef idx="1">
+            <a:schemeClr val="accent1"/>
+          </a:lnRef>
+          <a:fillRef idx="3">
+            <a:schemeClr val="accent1"/>
+          </a:fillRef>
+          <a:effectRef idx="2">
+            <a:schemeClr val="accent1"/>
+          </a:effectRef>
+          <a:fontRef idx="minor">
+            <a:schemeClr val="lt1"/>
+          </a:fontRef>
+        </p:style>
+        <p:txBody>
+          <a:bodyPr rtlCol="0" anchor="ctr"/>
+          <a:lstStyle/>
+          <a:p>
+            <a:pPr algn="ctr"/>
+          </a:p>
+        </p:txBody>
+      </p:sp>
+      <p:sp>
+        <p:nvSpPr>
+          <p:cNvPr id="6" name="Rectangle 5"/>
+          <p:cNvSpPr/>
+          <p:nvPr/>
+        </p:nvSpPr>
+        <p:spPr>
+          <a:xfrm>
+            <a:off x="685800" y="1645920"/>
+            <a:ext cx="109728" cy="640080"/>
+          </a:xfrm>
+          <a:prstGeom prst="rect">
+            <a:avLst/>
+          </a:prstGeom>
+          <a:solidFill>
+            <a:srgbClr val="4F46E5"/>
+          </a:solidFill>
+          <a:ln>
+            <a:noFill/>
+          </a:ln>
+        </p:spPr>
+        <p:style>
+          <a:lnRef idx="1">
+            <a:schemeClr val="accent1"/>
+          </a:lnRef>
+          <a:fillRef idx="3">
+            <a:schemeClr val="accent1"/>
+          </a:fillRef>
+          <a:effectRef idx="2">
+            <a:schemeClr val="accent1"/>
+          </a:effectRef>
+          <a:fontRef idx="minor">
+            <a:schemeClr val="lt1"/>
+          </a:fontRef>
+        </p:style>
+        <p:txBody>
+          <a:bodyPr rtlCol="0" anchor="ctr"/>
+          <a:lstStyle/>
+          <a:p>
+            <a:pPr algn="ctr"/>
+          </a:p>
+        </p:txBody>
+      </p:sp>
+      <p:sp>
+        <p:nvSpPr>
+          <p:cNvPr id="7" name="TextBox 6"/>
           <p:cNvSpPr txBox="1"/>
           <p:nvPr/>
         </p:nvSpPr>
         <p:spPr>
           <a:xfrm>
-            <a:off x="685800" y="1645920"/>
-            <a:ext cx="10817352" cy="4389120"/>
+            <a:off x="960120" y="1746504"/>
+            <a:ext cx="731520" cy="438912"/>
           </a:xfrm>
           <a:prstGeom prst="rect">
             <a:avLst/>
@@ -4301,114 +5639,851 @@
           <a:lstStyle/>
           <a:p>
             <a:pPr>
-              <a:spcAft>
-                <a:spcPts val="1600"/>
-              </a:spcAft>
               <a:defRPr sz="1700" b="1">
                 <a:solidFill>
-                  <a:srgbClr val="22D3EE"/>
+                  <a:srgbClr val="4F46E5"/>
                 </a:solidFill>
                 <a:latin typeface="Segoe UI"/>
               </a:defRPr>
             </a:pPr>
             <a:r>
-              <a:t>Sequential Processing Pipeline Layout</a:t>
-            </a:r>
-          </a:p>
+              <a:t>01</a:t>
+            </a:r>
+          </a:p>
+        </p:txBody>
+      </p:sp>
+      <p:sp>
+        <p:nvSpPr>
+          <p:cNvPr id="8" name="TextBox 7"/>
+          <p:cNvSpPr txBox="1"/>
+          <p:nvPr/>
+        </p:nvSpPr>
+        <p:spPr>
+          <a:xfrm>
+            <a:off x="1600200" y="1746504"/>
+            <a:ext cx="9765792" cy="438912"/>
+          </a:xfrm>
+          <a:prstGeom prst="rect">
+            <a:avLst/>
+          </a:prstGeom>
+          <a:noFill/>
+        </p:spPr>
+        <p:txBody>
+          <a:bodyPr wrap="square" lIns="0" tIns="0" rIns="0" bIns="0">
+            <a:spAutoFit/>
+          </a:bodyPr>
+          <a:lstStyle/>
           <a:p>
             <a:pPr>
-              <a:spcAft>
-                <a:spcPts val="800"/>
-              </a:spcAft>
-              <a:defRPr sz="1400">
-                <a:solidFill>
-                  <a:srgbClr val="CBD5E1"/>
+              <a:defRPr sz="1300">
+                <a:solidFill>
+                  <a:srgbClr val="334155"/>
                 </a:solidFill>
                 <a:latin typeface="Segoe UI"/>
               </a:defRPr>
             </a:pPr>
             <a:r>
-              <a:t>1. Query Input -&gt; Sandbox Area, File Uploader, or CLI batch scanner reads statement.</a:t>
-            </a:r>
-          </a:p>
+              <a:t>Query Input -&gt; Sandbox Area, File Uploader, or CLI batch scanner reads statement.</a:t>
+            </a:r>
+          </a:p>
+        </p:txBody>
+      </p:sp>
+      <p:sp>
+        <p:nvSpPr>
+          <p:cNvPr id="9" name="Rounded Rectangle 8"/>
+          <p:cNvSpPr/>
+          <p:nvPr/>
+        </p:nvSpPr>
+        <p:spPr>
+          <a:xfrm>
+            <a:off x="685800" y="2377440"/>
+            <a:ext cx="10817352" cy="640080"/>
+          </a:xfrm>
+          <a:prstGeom prst="roundRect">
+            <a:avLst/>
+          </a:prstGeom>
+          <a:solidFill>
+            <a:srgbClr val="FFFFFF"/>
+          </a:solidFill>
+          <a:ln w="19050">
+            <a:solidFill>
+              <a:srgbClr val="E0E7FF"/>
+            </a:solidFill>
+          </a:ln>
+        </p:spPr>
+        <p:style>
+          <a:lnRef idx="1">
+            <a:schemeClr val="accent1"/>
+          </a:lnRef>
+          <a:fillRef idx="3">
+            <a:schemeClr val="accent1"/>
+          </a:fillRef>
+          <a:effectRef idx="2">
+            <a:schemeClr val="accent1"/>
+          </a:effectRef>
+          <a:fontRef idx="minor">
+            <a:schemeClr val="lt1"/>
+          </a:fontRef>
+        </p:style>
+        <p:txBody>
+          <a:bodyPr rtlCol="0" anchor="ctr"/>
+          <a:lstStyle/>
+          <a:p>
+            <a:pPr algn="ctr"/>
+          </a:p>
+        </p:txBody>
+      </p:sp>
+      <p:sp>
+        <p:nvSpPr>
+          <p:cNvPr id="10" name="Rectangle 9"/>
+          <p:cNvSpPr/>
+          <p:nvPr/>
+        </p:nvSpPr>
+        <p:spPr>
+          <a:xfrm>
+            <a:off x="685800" y="2377440"/>
+            <a:ext cx="109728" cy="640080"/>
+          </a:xfrm>
+          <a:prstGeom prst="rect">
+            <a:avLst/>
+          </a:prstGeom>
+          <a:solidFill>
+            <a:srgbClr val="4F46E5"/>
+          </a:solidFill>
+          <a:ln>
+            <a:noFill/>
+          </a:ln>
+        </p:spPr>
+        <p:style>
+          <a:lnRef idx="1">
+            <a:schemeClr val="accent1"/>
+          </a:lnRef>
+          <a:fillRef idx="3">
+            <a:schemeClr val="accent1"/>
+          </a:fillRef>
+          <a:effectRef idx="2">
+            <a:schemeClr val="accent1"/>
+          </a:effectRef>
+          <a:fontRef idx="minor">
+            <a:schemeClr val="lt1"/>
+          </a:fontRef>
+        </p:style>
+        <p:txBody>
+          <a:bodyPr rtlCol="0" anchor="ctr"/>
+          <a:lstStyle/>
+          <a:p>
+            <a:pPr algn="ctr"/>
+          </a:p>
+        </p:txBody>
+      </p:sp>
+      <p:sp>
+        <p:nvSpPr>
+          <p:cNvPr id="11" name="TextBox 10"/>
+          <p:cNvSpPr txBox="1"/>
+          <p:nvPr/>
+        </p:nvSpPr>
+        <p:spPr>
+          <a:xfrm>
+            <a:off x="960120" y="2478024"/>
+            <a:ext cx="731520" cy="438912"/>
+          </a:xfrm>
+          <a:prstGeom prst="rect">
+            <a:avLst/>
+          </a:prstGeom>
+          <a:noFill/>
+        </p:spPr>
+        <p:txBody>
+          <a:bodyPr wrap="square" lIns="0" tIns="0" rIns="0" bIns="0">
+            <a:spAutoFit/>
+          </a:bodyPr>
+          <a:lstStyle/>
           <a:p>
             <a:pPr>
-              <a:spcAft>
-                <a:spcPts val="800"/>
-              </a:spcAft>
-              <a:defRPr sz="1400">
-                <a:solidFill>
-                  <a:srgbClr val="CBD5E1"/>
+              <a:defRPr sz="1700" b="1">
+                <a:solidFill>
+                  <a:srgbClr val="4F46E5"/>
                 </a:solidFill>
                 <a:latin typeface="Segoe UI"/>
               </a:defRPr>
             </a:pPr>
             <a:r>
-              <a:t>2. Input Sanitization -&gt; strip_markdown_artifacts() strips code blocks, bold asterisks, and italic underscores safely.</a:t>
-            </a:r>
-          </a:p>
+              <a:t>02</a:t>
+            </a:r>
+          </a:p>
+        </p:txBody>
+      </p:sp>
+      <p:sp>
+        <p:nvSpPr>
+          <p:cNvPr id="12" name="TextBox 11"/>
+          <p:cNvSpPr txBox="1"/>
+          <p:nvPr/>
+        </p:nvSpPr>
+        <p:spPr>
+          <a:xfrm>
+            <a:off x="1600200" y="2478024"/>
+            <a:ext cx="9765792" cy="438912"/>
+          </a:xfrm>
+          <a:prstGeom prst="rect">
+            <a:avLst/>
+          </a:prstGeom>
+          <a:noFill/>
+        </p:spPr>
+        <p:txBody>
+          <a:bodyPr wrap="square" lIns="0" tIns="0" rIns="0" bIns="0">
+            <a:spAutoFit/>
+          </a:bodyPr>
+          <a:lstStyle/>
           <a:p>
             <a:pPr>
-              <a:spcAft>
-                <a:spcPts val="800"/>
-              </a:spcAft>
-              <a:defRPr sz="1400">
-                <a:solidFill>
-                  <a:srgbClr val="CBD5E1"/>
+              <a:defRPr sz="1300">
+                <a:solidFill>
+                  <a:srgbClr val="334155"/>
                 </a:solidFill>
                 <a:latin typeface="Segoe UI"/>
               </a:defRPr>
             </a:pPr>
             <a:r>
-              <a:t>3. Phase 1 Linter -&gt; Deterministic capitalization of standard keywords, regex-based conversion of camelCase to snake_case, and SELECT * diagnostic checks.</a:t>
-            </a:r>
-          </a:p>
+              <a:t>Input Sanitization -&gt; strip_markdown_artifacts() strips code blocks, bold asterisks, and italic underscores safely.</a:t>
+            </a:r>
+          </a:p>
+        </p:txBody>
+      </p:sp>
+      <p:sp>
+        <p:nvSpPr>
+          <p:cNvPr id="13" name="Rounded Rectangle 12"/>
+          <p:cNvSpPr/>
+          <p:nvPr/>
+        </p:nvSpPr>
+        <p:spPr>
+          <a:xfrm>
+            <a:off x="685800" y="3108960"/>
+            <a:ext cx="10817352" cy="640080"/>
+          </a:xfrm>
+          <a:prstGeom prst="roundRect">
+            <a:avLst/>
+          </a:prstGeom>
+          <a:solidFill>
+            <a:srgbClr val="FFFFFF"/>
+          </a:solidFill>
+          <a:ln w="19050">
+            <a:solidFill>
+              <a:srgbClr val="E0E7FF"/>
+            </a:solidFill>
+          </a:ln>
+        </p:spPr>
+        <p:style>
+          <a:lnRef idx="1">
+            <a:schemeClr val="accent1"/>
+          </a:lnRef>
+          <a:fillRef idx="3">
+            <a:schemeClr val="accent1"/>
+          </a:fillRef>
+          <a:effectRef idx="2">
+            <a:schemeClr val="accent1"/>
+          </a:effectRef>
+          <a:fontRef idx="minor">
+            <a:schemeClr val="lt1"/>
+          </a:fontRef>
+        </p:style>
+        <p:txBody>
+          <a:bodyPr rtlCol="0" anchor="ctr"/>
+          <a:lstStyle/>
+          <a:p>
+            <a:pPr algn="ctr"/>
+          </a:p>
+        </p:txBody>
+      </p:sp>
+      <p:sp>
+        <p:nvSpPr>
+          <p:cNvPr id="14" name="Rectangle 13"/>
+          <p:cNvSpPr/>
+          <p:nvPr/>
+        </p:nvSpPr>
+        <p:spPr>
+          <a:xfrm>
+            <a:off x="685800" y="3108960"/>
+            <a:ext cx="109728" cy="640080"/>
+          </a:xfrm>
+          <a:prstGeom prst="rect">
+            <a:avLst/>
+          </a:prstGeom>
+          <a:solidFill>
+            <a:srgbClr val="4F46E5"/>
+          </a:solidFill>
+          <a:ln>
+            <a:noFill/>
+          </a:ln>
+        </p:spPr>
+        <p:style>
+          <a:lnRef idx="1">
+            <a:schemeClr val="accent1"/>
+          </a:lnRef>
+          <a:fillRef idx="3">
+            <a:schemeClr val="accent1"/>
+          </a:fillRef>
+          <a:effectRef idx="2">
+            <a:schemeClr val="accent1"/>
+          </a:effectRef>
+          <a:fontRef idx="minor">
+            <a:schemeClr val="lt1"/>
+          </a:fontRef>
+        </p:style>
+        <p:txBody>
+          <a:bodyPr rtlCol="0" anchor="ctr"/>
+          <a:lstStyle/>
+          <a:p>
+            <a:pPr algn="ctr"/>
+          </a:p>
+        </p:txBody>
+      </p:sp>
+      <p:sp>
+        <p:nvSpPr>
+          <p:cNvPr id="15" name="TextBox 14"/>
+          <p:cNvSpPr txBox="1"/>
+          <p:nvPr/>
+        </p:nvSpPr>
+        <p:spPr>
+          <a:xfrm>
+            <a:off x="960120" y="3209544"/>
+            <a:ext cx="731520" cy="438912"/>
+          </a:xfrm>
+          <a:prstGeom prst="rect">
+            <a:avLst/>
+          </a:prstGeom>
+          <a:noFill/>
+        </p:spPr>
+        <p:txBody>
+          <a:bodyPr wrap="square" lIns="0" tIns="0" rIns="0" bIns="0">
+            <a:spAutoFit/>
+          </a:bodyPr>
+          <a:lstStyle/>
           <a:p>
             <a:pPr>
-              <a:spcAft>
-                <a:spcPts val="800"/>
-              </a:spcAft>
-              <a:defRPr sz="1400">
-                <a:solidFill>
-                  <a:srgbClr val="CBD5E1"/>
+              <a:defRPr sz="1700" b="1">
+                <a:solidFill>
+                  <a:srgbClr val="4F46E5"/>
                 </a:solidFill>
                 <a:latin typeface="Segoe UI"/>
               </a:defRPr>
             </a:pPr>
             <a:r>
-              <a:t>4. Phase 2 Refactor -&gt; gemini-2.5-flash receives baseline formatting and optimizes syntax structures (implicit joins to explicit joins, subqueries to CTEs).</a:t>
-            </a:r>
-          </a:p>
+              <a:t>03</a:t>
+            </a:r>
+          </a:p>
+        </p:txBody>
+      </p:sp>
+      <p:sp>
+        <p:nvSpPr>
+          <p:cNvPr id="16" name="TextBox 15"/>
+          <p:cNvSpPr txBox="1"/>
+          <p:nvPr/>
+        </p:nvSpPr>
+        <p:spPr>
+          <a:xfrm>
+            <a:off x="1600200" y="3209544"/>
+            <a:ext cx="9765792" cy="438912"/>
+          </a:xfrm>
+          <a:prstGeom prst="rect">
+            <a:avLst/>
+          </a:prstGeom>
+          <a:noFill/>
+        </p:spPr>
+        <p:txBody>
+          <a:bodyPr wrap="square" lIns="0" tIns="0" rIns="0" bIns="0">
+            <a:spAutoFit/>
+          </a:bodyPr>
+          <a:lstStyle/>
           <a:p>
             <a:pPr>
-              <a:spcAft>
-                <a:spcPts val="800"/>
-              </a:spcAft>
-              <a:defRPr sz="1400">
-                <a:solidFill>
-                  <a:srgbClr val="CBD5E1"/>
+              <a:defRPr sz="1300">
+                <a:solidFill>
+                  <a:srgbClr val="334155"/>
                 </a:solidFill>
                 <a:latin typeface="Segoe UI"/>
               </a:defRPr>
             </a:pPr>
             <a:r>
-              <a:t>5. Self-Correction Loop -&gt; Output SQL is evaluated by local parser. If syntax errors occur, the traceback is fed back to the LLM to self-heal (up to 3 iterations).</a:t>
-            </a:r>
-          </a:p>
+              <a:t>Phase 1 Linter -&gt; Deterministic capitalization of standard keywords, regex-based conversion of camelCase to snake_case, and SELECT * diagnostic checks.</a:t>
+            </a:r>
+          </a:p>
+        </p:txBody>
+      </p:sp>
+      <p:sp>
+        <p:nvSpPr>
+          <p:cNvPr id="17" name="Rounded Rectangle 16"/>
+          <p:cNvSpPr/>
+          <p:nvPr/>
+        </p:nvSpPr>
+        <p:spPr>
+          <a:xfrm>
+            <a:off x="685800" y="3840480"/>
+            <a:ext cx="10817352" cy="640080"/>
+          </a:xfrm>
+          <a:prstGeom prst="roundRect">
+            <a:avLst/>
+          </a:prstGeom>
+          <a:solidFill>
+            <a:srgbClr val="FFFFFF"/>
+          </a:solidFill>
+          <a:ln w="19050">
+            <a:solidFill>
+              <a:srgbClr val="E0E7FF"/>
+            </a:solidFill>
+          </a:ln>
+        </p:spPr>
+        <p:style>
+          <a:lnRef idx="1">
+            <a:schemeClr val="accent1"/>
+          </a:lnRef>
+          <a:fillRef idx="3">
+            <a:schemeClr val="accent1"/>
+          </a:fillRef>
+          <a:effectRef idx="2">
+            <a:schemeClr val="accent1"/>
+          </a:effectRef>
+          <a:fontRef idx="minor">
+            <a:schemeClr val="lt1"/>
+          </a:fontRef>
+        </p:style>
+        <p:txBody>
+          <a:bodyPr rtlCol="0" anchor="ctr"/>
+          <a:lstStyle/>
+          <a:p>
+            <a:pPr algn="ctr"/>
+          </a:p>
+        </p:txBody>
+      </p:sp>
+      <p:sp>
+        <p:nvSpPr>
+          <p:cNvPr id="18" name="Rectangle 17"/>
+          <p:cNvSpPr/>
+          <p:nvPr/>
+        </p:nvSpPr>
+        <p:spPr>
+          <a:xfrm>
+            <a:off x="685800" y="3840480"/>
+            <a:ext cx="109728" cy="640080"/>
+          </a:xfrm>
+          <a:prstGeom prst="rect">
+            <a:avLst/>
+          </a:prstGeom>
+          <a:solidFill>
+            <a:srgbClr val="4F46E5"/>
+          </a:solidFill>
+          <a:ln>
+            <a:noFill/>
+          </a:ln>
+        </p:spPr>
+        <p:style>
+          <a:lnRef idx="1">
+            <a:schemeClr val="accent1"/>
+          </a:lnRef>
+          <a:fillRef idx="3">
+            <a:schemeClr val="accent1"/>
+          </a:fillRef>
+          <a:effectRef idx="2">
+            <a:schemeClr val="accent1"/>
+          </a:effectRef>
+          <a:fontRef idx="minor">
+            <a:schemeClr val="lt1"/>
+          </a:fontRef>
+        </p:style>
+        <p:txBody>
+          <a:bodyPr rtlCol="0" anchor="ctr"/>
+          <a:lstStyle/>
+          <a:p>
+            <a:pPr algn="ctr"/>
+          </a:p>
+        </p:txBody>
+      </p:sp>
+      <p:sp>
+        <p:nvSpPr>
+          <p:cNvPr id="19" name="TextBox 18"/>
+          <p:cNvSpPr txBox="1"/>
+          <p:nvPr/>
+        </p:nvSpPr>
+        <p:spPr>
+          <a:xfrm>
+            <a:off x="960120" y="3941064"/>
+            <a:ext cx="731520" cy="438912"/>
+          </a:xfrm>
+          <a:prstGeom prst="rect">
+            <a:avLst/>
+          </a:prstGeom>
+          <a:noFill/>
+        </p:spPr>
+        <p:txBody>
+          <a:bodyPr wrap="square" lIns="0" tIns="0" rIns="0" bIns="0">
+            <a:spAutoFit/>
+          </a:bodyPr>
+          <a:lstStyle/>
           <a:p>
             <a:pPr>
-              <a:spcAft>
-                <a:spcPts val="800"/>
-              </a:spcAft>
-              <a:defRPr sz="1400">
-                <a:solidFill>
-                  <a:srgbClr val="CBD5E1"/>
+              <a:defRPr sz="1700" b="1">
+                <a:solidFill>
+                  <a:srgbClr val="4F46E5"/>
                 </a:solidFill>
                 <a:latin typeface="Segoe UI"/>
               </a:defRPr>
             </a:pPr>
             <a:r>
-              <a:t>6. Finalization -&gt; Renders refactored SQL inside copyable st.code frames and outputs colored diff blocks.</a:t>
+              <a:t>04</a:t>
+            </a:r>
+          </a:p>
+        </p:txBody>
+      </p:sp>
+      <p:sp>
+        <p:nvSpPr>
+          <p:cNvPr id="20" name="TextBox 19"/>
+          <p:cNvSpPr txBox="1"/>
+          <p:nvPr/>
+        </p:nvSpPr>
+        <p:spPr>
+          <a:xfrm>
+            <a:off x="1600200" y="3941064"/>
+            <a:ext cx="9765792" cy="438912"/>
+          </a:xfrm>
+          <a:prstGeom prst="rect">
+            <a:avLst/>
+          </a:prstGeom>
+          <a:noFill/>
+        </p:spPr>
+        <p:txBody>
+          <a:bodyPr wrap="square" lIns="0" tIns="0" rIns="0" bIns="0">
+            <a:spAutoFit/>
+          </a:bodyPr>
+          <a:lstStyle/>
+          <a:p>
+            <a:pPr>
+              <a:defRPr sz="1300">
+                <a:solidFill>
+                  <a:srgbClr val="334155"/>
+                </a:solidFill>
+                <a:latin typeface="Segoe UI"/>
+              </a:defRPr>
+            </a:pPr>
+            <a:r>
+              <a:t>Phase 2 Refactor -&gt; gemini-2.5-flash receives baseline formatting and optimizes syntax structures (implicit joins to explicit joins, subqueries to CTEs).</a:t>
+            </a:r>
+          </a:p>
+        </p:txBody>
+      </p:sp>
+      <p:sp>
+        <p:nvSpPr>
+          <p:cNvPr id="21" name="Rounded Rectangle 20"/>
+          <p:cNvSpPr/>
+          <p:nvPr/>
+        </p:nvSpPr>
+        <p:spPr>
+          <a:xfrm>
+            <a:off x="685800" y="4572000"/>
+            <a:ext cx="10817352" cy="640080"/>
+          </a:xfrm>
+          <a:prstGeom prst="roundRect">
+            <a:avLst/>
+          </a:prstGeom>
+          <a:solidFill>
+            <a:srgbClr val="FFFFFF"/>
+          </a:solidFill>
+          <a:ln w="19050">
+            <a:solidFill>
+              <a:srgbClr val="E0E7FF"/>
+            </a:solidFill>
+          </a:ln>
+        </p:spPr>
+        <p:style>
+          <a:lnRef idx="1">
+            <a:schemeClr val="accent1"/>
+          </a:lnRef>
+          <a:fillRef idx="3">
+            <a:schemeClr val="accent1"/>
+          </a:fillRef>
+          <a:effectRef idx="2">
+            <a:schemeClr val="accent1"/>
+          </a:effectRef>
+          <a:fontRef idx="minor">
+            <a:schemeClr val="lt1"/>
+          </a:fontRef>
+        </p:style>
+        <p:txBody>
+          <a:bodyPr rtlCol="0" anchor="ctr"/>
+          <a:lstStyle/>
+          <a:p>
+            <a:pPr algn="ctr"/>
+          </a:p>
+        </p:txBody>
+      </p:sp>
+      <p:sp>
+        <p:nvSpPr>
+          <p:cNvPr id="22" name="Rectangle 21"/>
+          <p:cNvSpPr/>
+          <p:nvPr/>
+        </p:nvSpPr>
+        <p:spPr>
+          <a:xfrm>
+            <a:off x="685800" y="4572000"/>
+            <a:ext cx="109728" cy="640080"/>
+          </a:xfrm>
+          <a:prstGeom prst="rect">
+            <a:avLst/>
+          </a:prstGeom>
+          <a:solidFill>
+            <a:srgbClr val="4F46E5"/>
+          </a:solidFill>
+          <a:ln>
+            <a:noFill/>
+          </a:ln>
+        </p:spPr>
+        <p:style>
+          <a:lnRef idx="1">
+            <a:schemeClr val="accent1"/>
+          </a:lnRef>
+          <a:fillRef idx="3">
+            <a:schemeClr val="accent1"/>
+          </a:fillRef>
+          <a:effectRef idx="2">
+            <a:schemeClr val="accent1"/>
+          </a:effectRef>
+          <a:fontRef idx="minor">
+            <a:schemeClr val="lt1"/>
+          </a:fontRef>
+        </p:style>
+        <p:txBody>
+          <a:bodyPr rtlCol="0" anchor="ctr"/>
+          <a:lstStyle/>
+          <a:p>
+            <a:pPr algn="ctr"/>
+          </a:p>
+        </p:txBody>
+      </p:sp>
+      <p:sp>
+        <p:nvSpPr>
+          <p:cNvPr id="23" name="TextBox 22"/>
+          <p:cNvSpPr txBox="1"/>
+          <p:nvPr/>
+        </p:nvSpPr>
+        <p:spPr>
+          <a:xfrm>
+            <a:off x="960120" y="4672584"/>
+            <a:ext cx="731520" cy="438912"/>
+          </a:xfrm>
+          <a:prstGeom prst="rect">
+            <a:avLst/>
+          </a:prstGeom>
+          <a:noFill/>
+        </p:spPr>
+        <p:txBody>
+          <a:bodyPr wrap="square" lIns="0" tIns="0" rIns="0" bIns="0">
+            <a:spAutoFit/>
+          </a:bodyPr>
+          <a:lstStyle/>
+          <a:p>
+            <a:pPr>
+              <a:defRPr sz="1700" b="1">
+                <a:solidFill>
+                  <a:srgbClr val="4F46E5"/>
+                </a:solidFill>
+                <a:latin typeface="Segoe UI"/>
+              </a:defRPr>
+            </a:pPr>
+            <a:r>
+              <a:t>05</a:t>
+            </a:r>
+          </a:p>
+        </p:txBody>
+      </p:sp>
+      <p:sp>
+        <p:nvSpPr>
+          <p:cNvPr id="24" name="TextBox 23"/>
+          <p:cNvSpPr txBox="1"/>
+          <p:nvPr/>
+        </p:nvSpPr>
+        <p:spPr>
+          <a:xfrm>
+            <a:off x="1600200" y="4672584"/>
+            <a:ext cx="9765792" cy="438912"/>
+          </a:xfrm>
+          <a:prstGeom prst="rect">
+            <a:avLst/>
+          </a:prstGeom>
+          <a:noFill/>
+        </p:spPr>
+        <p:txBody>
+          <a:bodyPr wrap="square" lIns="0" tIns="0" rIns="0" bIns="0">
+            <a:spAutoFit/>
+          </a:bodyPr>
+          <a:lstStyle/>
+          <a:p>
+            <a:pPr>
+              <a:defRPr sz="1300">
+                <a:solidFill>
+                  <a:srgbClr val="334155"/>
+                </a:solidFill>
+                <a:latin typeface="Segoe UI"/>
+              </a:defRPr>
+            </a:pPr>
+            <a:r>
+              <a:t>Self-Correction Loop -&gt; Output SQL is evaluated by local parser. If syntax errors occur, the traceback is fed back to the LLM to self-heal (up to 3 iterations).</a:t>
+            </a:r>
+          </a:p>
+        </p:txBody>
+      </p:sp>
+      <p:sp>
+        <p:nvSpPr>
+          <p:cNvPr id="25" name="Rounded Rectangle 24"/>
+          <p:cNvSpPr/>
+          <p:nvPr/>
+        </p:nvSpPr>
+        <p:spPr>
+          <a:xfrm>
+            <a:off x="685800" y="5303520"/>
+            <a:ext cx="10817352" cy="640080"/>
+          </a:xfrm>
+          <a:prstGeom prst="roundRect">
+            <a:avLst/>
+          </a:prstGeom>
+          <a:solidFill>
+            <a:srgbClr val="FFFFFF"/>
+          </a:solidFill>
+          <a:ln w="19050">
+            <a:solidFill>
+              <a:srgbClr val="E0E7FF"/>
+            </a:solidFill>
+          </a:ln>
+        </p:spPr>
+        <p:style>
+          <a:lnRef idx="1">
+            <a:schemeClr val="accent1"/>
+          </a:lnRef>
+          <a:fillRef idx="3">
+            <a:schemeClr val="accent1"/>
+          </a:fillRef>
+          <a:effectRef idx="2">
+            <a:schemeClr val="accent1"/>
+          </a:effectRef>
+          <a:fontRef idx="minor">
+            <a:schemeClr val="lt1"/>
+          </a:fontRef>
+        </p:style>
+        <p:txBody>
+          <a:bodyPr rtlCol="0" anchor="ctr"/>
+          <a:lstStyle/>
+          <a:p>
+            <a:pPr algn="ctr"/>
+          </a:p>
+        </p:txBody>
+      </p:sp>
+      <p:sp>
+        <p:nvSpPr>
+          <p:cNvPr id="26" name="Rectangle 25"/>
+          <p:cNvSpPr/>
+          <p:nvPr/>
+        </p:nvSpPr>
+        <p:spPr>
+          <a:xfrm>
+            <a:off x="685800" y="5303520"/>
+            <a:ext cx="109728" cy="640080"/>
+          </a:xfrm>
+          <a:prstGeom prst="rect">
+            <a:avLst/>
+          </a:prstGeom>
+          <a:solidFill>
+            <a:srgbClr val="4F46E5"/>
+          </a:solidFill>
+          <a:ln>
+            <a:noFill/>
+          </a:ln>
+        </p:spPr>
+        <p:style>
+          <a:lnRef idx="1">
+            <a:schemeClr val="accent1"/>
+          </a:lnRef>
+          <a:fillRef idx="3">
+            <a:schemeClr val="accent1"/>
+          </a:fillRef>
+          <a:effectRef idx="2">
+            <a:schemeClr val="accent1"/>
+          </a:effectRef>
+          <a:fontRef idx="minor">
+            <a:schemeClr val="lt1"/>
+          </a:fontRef>
+        </p:style>
+        <p:txBody>
+          <a:bodyPr rtlCol="0" anchor="ctr"/>
+          <a:lstStyle/>
+          <a:p>
+            <a:pPr algn="ctr"/>
+          </a:p>
+        </p:txBody>
+      </p:sp>
+      <p:sp>
+        <p:nvSpPr>
+          <p:cNvPr id="27" name="TextBox 26"/>
+          <p:cNvSpPr txBox="1"/>
+          <p:nvPr/>
+        </p:nvSpPr>
+        <p:spPr>
+          <a:xfrm>
+            <a:off x="960120" y="5404104"/>
+            <a:ext cx="731520" cy="438912"/>
+          </a:xfrm>
+          <a:prstGeom prst="rect">
+            <a:avLst/>
+          </a:prstGeom>
+          <a:noFill/>
+        </p:spPr>
+        <p:txBody>
+          <a:bodyPr wrap="square" lIns="0" tIns="0" rIns="0" bIns="0">
+            <a:spAutoFit/>
+          </a:bodyPr>
+          <a:lstStyle/>
+          <a:p>
+            <a:pPr>
+              <a:defRPr sz="1700" b="1">
+                <a:solidFill>
+                  <a:srgbClr val="4F46E5"/>
+                </a:solidFill>
+                <a:latin typeface="Segoe UI"/>
+              </a:defRPr>
+            </a:pPr>
+            <a:r>
+              <a:t>06</a:t>
+            </a:r>
+          </a:p>
+        </p:txBody>
+      </p:sp>
+      <p:sp>
+        <p:nvSpPr>
+          <p:cNvPr id="28" name="TextBox 27"/>
+          <p:cNvSpPr txBox="1"/>
+          <p:nvPr/>
+        </p:nvSpPr>
+        <p:spPr>
+          <a:xfrm>
+            <a:off x="1600200" y="5404104"/>
+            <a:ext cx="9765792" cy="438912"/>
+          </a:xfrm>
+          <a:prstGeom prst="rect">
+            <a:avLst/>
+          </a:prstGeom>
+          <a:noFill/>
+        </p:spPr>
+        <p:txBody>
+          <a:bodyPr wrap="square" lIns="0" tIns="0" rIns="0" bIns="0">
+            <a:spAutoFit/>
+          </a:bodyPr>
+          <a:lstStyle/>
+          <a:p>
+            <a:pPr>
+              <a:defRPr sz="1300">
+                <a:solidFill>
+                  <a:srgbClr val="334155"/>
+                </a:solidFill>
+                <a:latin typeface="Segoe UI"/>
+              </a:defRPr>
+            </a:pPr>
+            <a:r>
+              <a:t>Finalization -&gt; Renders refactored SQL inside copyable st.code frames and outputs colored diff blocks.</a:t>
             </a:r>
           </a:p>
         </p:txBody>
@@ -4427,7 +6502,7 @@
     <p:bg>
       <p:bgPr>
         <a:solidFill>
-          <a:srgbClr val="0B1324"/>
+          <a:srgbClr val="F8FAFC"/>
         </a:solidFill>
         <a:effectLst/>
       </p:bgPr>
@@ -4464,7 +6539,7 @@
             <a:pPr>
               <a:defRPr sz="3200" b="1">
                 <a:solidFill>
-                  <a:srgbClr val="F8FAFC"/>
+                  <a:srgbClr val="0F172A"/>
                 </a:solidFill>
                 <a:latin typeface="Segoe UI"/>
               </a:defRPr>
@@ -4484,13 +6559,13 @@
         <p:spPr>
           <a:xfrm>
             <a:off x="685800" y="1188720"/>
-            <a:ext cx="10817352" cy="27432"/>
+            <a:ext cx="10817352" cy="36576"/>
           </a:xfrm>
           <a:prstGeom prst="rect">
             <a:avLst/>
           </a:prstGeom>
           <a:solidFill>
-            <a:srgbClr val="22D3EE"/>
+            <a:srgbClr val="4F46E5"/>
           </a:solidFill>
           <a:ln>
             <a:noFill/>
@@ -4526,7 +6601,7 @@
         </p:nvSpPr>
         <p:spPr>
           <a:xfrm>
-            <a:off x="685800" y="6309360"/>
+            <a:off x="685800" y="6355080"/>
             <a:ext cx="10817352" cy="274320"/>
           </a:xfrm>
           <a:prstGeom prst="rect">
@@ -4556,14 +6631,102 @@
       </p:sp>
       <p:sp>
         <p:nvSpPr>
-          <p:cNvPr id="5" name="TextBox 4"/>
+          <p:cNvPr id="5" name="Rounded Rectangle 4"/>
+          <p:cNvSpPr/>
+          <p:nvPr/>
+        </p:nvSpPr>
+        <p:spPr>
+          <a:xfrm>
+            <a:off x="685800" y="1645920"/>
+            <a:ext cx="10817352" cy="777240"/>
+          </a:xfrm>
+          <a:prstGeom prst="roundRect">
+            <a:avLst/>
+          </a:prstGeom>
+          <a:solidFill>
+            <a:srgbClr val="FFFFFF"/>
+          </a:solidFill>
+          <a:ln w="19050">
+            <a:solidFill>
+              <a:srgbClr val="E0E7FF"/>
+            </a:solidFill>
+          </a:ln>
+        </p:spPr>
+        <p:style>
+          <a:lnRef idx="1">
+            <a:schemeClr val="accent1"/>
+          </a:lnRef>
+          <a:fillRef idx="3">
+            <a:schemeClr val="accent1"/>
+          </a:fillRef>
+          <a:effectRef idx="2">
+            <a:schemeClr val="accent1"/>
+          </a:effectRef>
+          <a:fontRef idx="minor">
+            <a:schemeClr val="lt1"/>
+          </a:fontRef>
+        </p:style>
+        <p:txBody>
+          <a:bodyPr rtlCol="0" anchor="ctr"/>
+          <a:lstStyle/>
+          <a:p>
+            <a:pPr algn="ctr"/>
+          </a:p>
+        </p:txBody>
+      </p:sp>
+      <p:sp>
+        <p:nvSpPr>
+          <p:cNvPr id="6" name="Rectangle 5"/>
+          <p:cNvSpPr/>
+          <p:nvPr/>
+        </p:nvSpPr>
+        <p:spPr>
+          <a:xfrm>
+            <a:off x="685800" y="1645920"/>
+            <a:ext cx="109728" cy="777240"/>
+          </a:xfrm>
+          <a:prstGeom prst="rect">
+            <a:avLst/>
+          </a:prstGeom>
+          <a:solidFill>
+            <a:srgbClr val="4F46E5"/>
+          </a:solidFill>
+          <a:ln>
+            <a:noFill/>
+          </a:ln>
+        </p:spPr>
+        <p:style>
+          <a:lnRef idx="1">
+            <a:schemeClr val="accent1"/>
+          </a:lnRef>
+          <a:fillRef idx="3">
+            <a:schemeClr val="accent1"/>
+          </a:fillRef>
+          <a:effectRef idx="2">
+            <a:schemeClr val="accent1"/>
+          </a:effectRef>
+          <a:fontRef idx="minor">
+            <a:schemeClr val="lt1"/>
+          </a:fontRef>
+        </p:style>
+        <p:txBody>
+          <a:bodyPr rtlCol="0" anchor="ctr"/>
+          <a:lstStyle/>
+          <a:p>
+            <a:pPr algn="ctr"/>
+          </a:p>
+        </p:txBody>
+      </p:sp>
+      <p:sp>
+        <p:nvSpPr>
+          <p:cNvPr id="7" name="TextBox 6"/>
           <p:cNvSpPr txBox="1"/>
           <p:nvPr/>
         </p:nvSpPr>
         <p:spPr>
           <a:xfrm>
-            <a:off x="685800" y="1645920"/>
-            <a:ext cx="10817352" cy="4389120"/>
+            <a:off x="1005840" y="1719072"/>
+            <a:ext cx="10314432" cy="630936"/>
           </a:xfrm>
           <a:prstGeom prst="rect">
             <a:avLst/>
@@ -4577,123 +6740,552 @@
           <a:lstStyle/>
           <a:p>
             <a:pPr>
-              <a:spcAft>
-                <a:spcPts val="1000"/>
-              </a:spcAft>
-              <a:defRPr sz="1500" b="1">
-                <a:solidFill>
-                  <a:srgbClr val="22D3EE"/>
+              <a:defRPr sz="1350" b="1">
+                <a:solidFill>
+                  <a:srgbClr val="0F172A"/>
                 </a:solidFill>
                 <a:latin typeface="Segoe UI"/>
               </a:defRPr>
             </a:pPr>
             <a:r>
-              <a:t>•  Sanitization &amp; Cleaning Module: </a:t>
-            </a:r>
-            <a:r>
-              <a:rPr sz="1500" b="0">
-                <a:solidFill>
-                  <a:srgbClr val="CBD5E1"/>
+              <a:t>Sanitization &amp; Cleaning Module: </a:t>
+            </a:r>
+            <a:r>
+              <a:rPr sz="1300" b="0">
+                <a:solidFill>
+                  <a:srgbClr val="334155"/>
                 </a:solidFill>
                 <a:latin typeface="Segoe UI"/>
               </a:rPr>
               <a:t>Contains lookbehind/lookahead regular expressions that clean styling artifacts from incoming text without corrupting snake_case columns.</a:t>
             </a:r>
           </a:p>
+        </p:txBody>
+      </p:sp>
+      <p:sp>
+        <p:nvSpPr>
+          <p:cNvPr id="8" name="Rounded Rectangle 7"/>
+          <p:cNvSpPr/>
+          <p:nvPr/>
+        </p:nvSpPr>
+        <p:spPr>
+          <a:xfrm>
+            <a:off x="685800" y="2514600"/>
+            <a:ext cx="10817352" cy="777240"/>
+          </a:xfrm>
+          <a:prstGeom prst="roundRect">
+            <a:avLst/>
+          </a:prstGeom>
+          <a:solidFill>
+            <a:srgbClr val="FFFFFF"/>
+          </a:solidFill>
+          <a:ln w="19050">
+            <a:solidFill>
+              <a:srgbClr val="E0E7FF"/>
+            </a:solidFill>
+          </a:ln>
+        </p:spPr>
+        <p:style>
+          <a:lnRef idx="1">
+            <a:schemeClr val="accent1"/>
+          </a:lnRef>
+          <a:fillRef idx="3">
+            <a:schemeClr val="accent1"/>
+          </a:fillRef>
+          <a:effectRef idx="2">
+            <a:schemeClr val="accent1"/>
+          </a:effectRef>
+          <a:fontRef idx="minor">
+            <a:schemeClr val="lt1"/>
+          </a:fontRef>
+        </p:style>
+        <p:txBody>
+          <a:bodyPr rtlCol="0" anchor="ctr"/>
+          <a:lstStyle/>
+          <a:p>
+            <a:pPr algn="ctr"/>
+          </a:p>
+        </p:txBody>
+      </p:sp>
+      <p:sp>
+        <p:nvSpPr>
+          <p:cNvPr id="9" name="Rectangle 8"/>
+          <p:cNvSpPr/>
+          <p:nvPr/>
+        </p:nvSpPr>
+        <p:spPr>
+          <a:xfrm>
+            <a:off x="685800" y="2514600"/>
+            <a:ext cx="109728" cy="777240"/>
+          </a:xfrm>
+          <a:prstGeom prst="rect">
+            <a:avLst/>
+          </a:prstGeom>
+          <a:solidFill>
+            <a:srgbClr val="4F46E5"/>
+          </a:solidFill>
+          <a:ln>
+            <a:noFill/>
+          </a:ln>
+        </p:spPr>
+        <p:style>
+          <a:lnRef idx="1">
+            <a:schemeClr val="accent1"/>
+          </a:lnRef>
+          <a:fillRef idx="3">
+            <a:schemeClr val="accent1"/>
+          </a:fillRef>
+          <a:effectRef idx="2">
+            <a:schemeClr val="accent1"/>
+          </a:effectRef>
+          <a:fontRef idx="minor">
+            <a:schemeClr val="lt1"/>
+          </a:fontRef>
+        </p:style>
+        <p:txBody>
+          <a:bodyPr rtlCol="0" anchor="ctr"/>
+          <a:lstStyle/>
+          <a:p>
+            <a:pPr algn="ctr"/>
+          </a:p>
+        </p:txBody>
+      </p:sp>
+      <p:sp>
+        <p:nvSpPr>
+          <p:cNvPr id="10" name="TextBox 9"/>
+          <p:cNvSpPr txBox="1"/>
+          <p:nvPr/>
+        </p:nvSpPr>
+        <p:spPr>
+          <a:xfrm>
+            <a:off x="1005840" y="2587752"/>
+            <a:ext cx="10314432" cy="630936"/>
+          </a:xfrm>
+          <a:prstGeom prst="rect">
+            <a:avLst/>
+          </a:prstGeom>
+          <a:noFill/>
+        </p:spPr>
+        <p:txBody>
+          <a:bodyPr wrap="square" lIns="0" tIns="0" rIns="0" bIns="0">
+            <a:spAutoFit/>
+          </a:bodyPr>
+          <a:lstStyle/>
           <a:p>
             <a:pPr>
-              <a:spcAft>
-                <a:spcPts val="1000"/>
-              </a:spcAft>
-              <a:defRPr sz="1500" b="1">
-                <a:solidFill>
-                  <a:srgbClr val="22D3EE"/>
+              <a:defRPr sz="1350" b="1">
+                <a:solidFill>
+                  <a:srgbClr val="0F172A"/>
                 </a:solidFill>
                 <a:latin typeface="Segoe UI"/>
               </a:defRPr>
             </a:pPr>
             <a:r>
-              <a:t>•  Phase 1: Local Linter Module: </a:t>
-            </a:r>
-            <a:r>
-              <a:rPr sz="1500" b="0">
-                <a:solidFill>
-                  <a:srgbClr val="CBD5E1"/>
+              <a:t>Phase 1: Local Linter Module: </a:t>
+            </a:r>
+            <a:r>
+              <a:rPr sz="1300" b="0">
+                <a:solidFill>
+                  <a:srgbClr val="334155"/>
                 </a:solidFill>
                 <a:latin typeface="Segoe UI"/>
               </a:rPr>
               <a:t>Zero-cost deterministic casing cleaner and capitalization compiler. Enforces standard keywords and casing conventions locally before network calls.</a:t>
             </a:r>
           </a:p>
+        </p:txBody>
+      </p:sp>
+      <p:sp>
+        <p:nvSpPr>
+          <p:cNvPr id="11" name="Rounded Rectangle 10"/>
+          <p:cNvSpPr/>
+          <p:nvPr/>
+        </p:nvSpPr>
+        <p:spPr>
+          <a:xfrm>
+            <a:off x="685800" y="3383280"/>
+            <a:ext cx="10817352" cy="777240"/>
+          </a:xfrm>
+          <a:prstGeom prst="roundRect">
+            <a:avLst/>
+          </a:prstGeom>
+          <a:solidFill>
+            <a:srgbClr val="FFFFFF"/>
+          </a:solidFill>
+          <a:ln w="19050">
+            <a:solidFill>
+              <a:srgbClr val="E0E7FF"/>
+            </a:solidFill>
+          </a:ln>
+        </p:spPr>
+        <p:style>
+          <a:lnRef idx="1">
+            <a:schemeClr val="accent1"/>
+          </a:lnRef>
+          <a:fillRef idx="3">
+            <a:schemeClr val="accent1"/>
+          </a:fillRef>
+          <a:effectRef idx="2">
+            <a:schemeClr val="accent1"/>
+          </a:effectRef>
+          <a:fontRef idx="minor">
+            <a:schemeClr val="lt1"/>
+          </a:fontRef>
+        </p:style>
+        <p:txBody>
+          <a:bodyPr rtlCol="0" anchor="ctr"/>
+          <a:lstStyle/>
+          <a:p>
+            <a:pPr algn="ctr"/>
+          </a:p>
+        </p:txBody>
+      </p:sp>
+      <p:sp>
+        <p:nvSpPr>
+          <p:cNvPr id="12" name="Rectangle 11"/>
+          <p:cNvSpPr/>
+          <p:nvPr/>
+        </p:nvSpPr>
+        <p:spPr>
+          <a:xfrm>
+            <a:off x="685800" y="3383280"/>
+            <a:ext cx="109728" cy="777240"/>
+          </a:xfrm>
+          <a:prstGeom prst="rect">
+            <a:avLst/>
+          </a:prstGeom>
+          <a:solidFill>
+            <a:srgbClr val="4F46E5"/>
+          </a:solidFill>
+          <a:ln>
+            <a:noFill/>
+          </a:ln>
+        </p:spPr>
+        <p:style>
+          <a:lnRef idx="1">
+            <a:schemeClr val="accent1"/>
+          </a:lnRef>
+          <a:fillRef idx="3">
+            <a:schemeClr val="accent1"/>
+          </a:fillRef>
+          <a:effectRef idx="2">
+            <a:schemeClr val="accent1"/>
+          </a:effectRef>
+          <a:fontRef idx="minor">
+            <a:schemeClr val="lt1"/>
+          </a:fontRef>
+        </p:style>
+        <p:txBody>
+          <a:bodyPr rtlCol="0" anchor="ctr"/>
+          <a:lstStyle/>
+          <a:p>
+            <a:pPr algn="ctr"/>
+          </a:p>
+        </p:txBody>
+      </p:sp>
+      <p:sp>
+        <p:nvSpPr>
+          <p:cNvPr id="13" name="TextBox 12"/>
+          <p:cNvSpPr txBox="1"/>
+          <p:nvPr/>
+        </p:nvSpPr>
+        <p:spPr>
+          <a:xfrm>
+            <a:off x="1005840" y="3456432"/>
+            <a:ext cx="10314432" cy="630936"/>
+          </a:xfrm>
+          <a:prstGeom prst="rect">
+            <a:avLst/>
+          </a:prstGeom>
+          <a:noFill/>
+        </p:spPr>
+        <p:txBody>
+          <a:bodyPr wrap="square" lIns="0" tIns="0" rIns="0" bIns="0">
+            <a:spAutoFit/>
+          </a:bodyPr>
+          <a:lstStyle/>
           <a:p>
             <a:pPr>
-              <a:spcAft>
-                <a:spcPts val="1000"/>
-              </a:spcAft>
-              <a:defRPr sz="1500" b="1">
-                <a:solidFill>
-                  <a:srgbClr val="22D3EE"/>
+              <a:defRPr sz="1350" b="1">
+                <a:solidFill>
+                  <a:srgbClr val="0F172A"/>
                 </a:solidFill>
                 <a:latin typeface="Segoe UI"/>
               </a:defRPr>
             </a:pPr>
             <a:r>
-              <a:t>•  Phase 2: AI Refactoring Module: </a:t>
-            </a:r>
-            <a:r>
-              <a:rPr sz="1500" b="0">
-                <a:solidFill>
-                  <a:srgbClr val="CBD5E1"/>
+              <a:t>Phase 2: AI Refactoring Module: </a:t>
+            </a:r>
+            <a:r>
+              <a:rPr sz="1300" b="0">
+                <a:solidFill>
+                  <a:srgbClr val="334155"/>
                 </a:solidFill>
                 <a:latin typeface="Segoe UI"/>
               </a:rPr>
               <a:t>Leverages Gemini LLM with few-shot instructions to translate legacy comma-joins and extract subqueries into CTEs.</a:t>
             </a:r>
           </a:p>
+        </p:txBody>
+      </p:sp>
+      <p:sp>
+        <p:nvSpPr>
+          <p:cNvPr id="14" name="Rounded Rectangle 13"/>
+          <p:cNvSpPr/>
+          <p:nvPr/>
+        </p:nvSpPr>
+        <p:spPr>
+          <a:xfrm>
+            <a:off x="685800" y="4251960"/>
+            <a:ext cx="10817352" cy="777240"/>
+          </a:xfrm>
+          <a:prstGeom prst="roundRect">
+            <a:avLst/>
+          </a:prstGeom>
+          <a:solidFill>
+            <a:srgbClr val="FFFFFF"/>
+          </a:solidFill>
+          <a:ln w="19050">
+            <a:solidFill>
+              <a:srgbClr val="E0E7FF"/>
+            </a:solidFill>
+          </a:ln>
+        </p:spPr>
+        <p:style>
+          <a:lnRef idx="1">
+            <a:schemeClr val="accent1"/>
+          </a:lnRef>
+          <a:fillRef idx="3">
+            <a:schemeClr val="accent1"/>
+          </a:fillRef>
+          <a:effectRef idx="2">
+            <a:schemeClr val="accent1"/>
+          </a:effectRef>
+          <a:fontRef idx="minor">
+            <a:schemeClr val="lt1"/>
+          </a:fontRef>
+        </p:style>
+        <p:txBody>
+          <a:bodyPr rtlCol="0" anchor="ctr"/>
+          <a:lstStyle/>
+          <a:p>
+            <a:pPr algn="ctr"/>
+          </a:p>
+        </p:txBody>
+      </p:sp>
+      <p:sp>
+        <p:nvSpPr>
+          <p:cNvPr id="15" name="Rectangle 14"/>
+          <p:cNvSpPr/>
+          <p:nvPr/>
+        </p:nvSpPr>
+        <p:spPr>
+          <a:xfrm>
+            <a:off x="685800" y="4251960"/>
+            <a:ext cx="109728" cy="777240"/>
+          </a:xfrm>
+          <a:prstGeom prst="rect">
+            <a:avLst/>
+          </a:prstGeom>
+          <a:solidFill>
+            <a:srgbClr val="4F46E5"/>
+          </a:solidFill>
+          <a:ln>
+            <a:noFill/>
+          </a:ln>
+        </p:spPr>
+        <p:style>
+          <a:lnRef idx="1">
+            <a:schemeClr val="accent1"/>
+          </a:lnRef>
+          <a:fillRef idx="3">
+            <a:schemeClr val="accent1"/>
+          </a:fillRef>
+          <a:effectRef idx="2">
+            <a:schemeClr val="accent1"/>
+          </a:effectRef>
+          <a:fontRef idx="minor">
+            <a:schemeClr val="lt1"/>
+          </a:fontRef>
+        </p:style>
+        <p:txBody>
+          <a:bodyPr rtlCol="0" anchor="ctr"/>
+          <a:lstStyle/>
+          <a:p>
+            <a:pPr algn="ctr"/>
+          </a:p>
+        </p:txBody>
+      </p:sp>
+      <p:sp>
+        <p:nvSpPr>
+          <p:cNvPr id="16" name="TextBox 15"/>
+          <p:cNvSpPr txBox="1"/>
+          <p:nvPr/>
+        </p:nvSpPr>
+        <p:spPr>
+          <a:xfrm>
+            <a:off x="1005840" y="4325112"/>
+            <a:ext cx="10314432" cy="630936"/>
+          </a:xfrm>
+          <a:prstGeom prst="rect">
+            <a:avLst/>
+          </a:prstGeom>
+          <a:noFill/>
+        </p:spPr>
+        <p:txBody>
+          <a:bodyPr wrap="square" lIns="0" tIns="0" rIns="0" bIns="0">
+            <a:spAutoFit/>
+          </a:bodyPr>
+          <a:lstStyle/>
           <a:p>
             <a:pPr>
-              <a:spcAft>
-                <a:spcPts val="1000"/>
-              </a:spcAft>
-              <a:defRPr sz="1500" b="1">
-                <a:solidFill>
-                  <a:srgbClr val="22D3EE"/>
+              <a:defRPr sz="1350" b="1">
+                <a:solidFill>
+                  <a:srgbClr val="0F172A"/>
                 </a:solidFill>
                 <a:latin typeface="Segoe UI"/>
               </a:defRPr>
             </a:pPr>
             <a:r>
-              <a:t>•  Validation &amp; Critic Module: </a:t>
-            </a:r>
-            <a:r>
-              <a:rPr sz="1500" b="0">
-                <a:solidFill>
-                  <a:srgbClr val="CBD5E1"/>
+              <a:t>Validation &amp; Critic Module: </a:t>
+            </a:r>
+            <a:r>
+              <a:rPr sz="1300" b="0">
+                <a:solidFill>
+                  <a:srgbClr val="334155"/>
                 </a:solidFill>
                 <a:latin typeface="Segoe UI"/>
               </a:rPr>
               <a:t>Compares LLM outputs against local syntax rules using sqlglot, orchestrating the self-correcting logic loop if discrepancies are found.</a:t>
             </a:r>
           </a:p>
+        </p:txBody>
+      </p:sp>
+      <p:sp>
+        <p:nvSpPr>
+          <p:cNvPr id="17" name="Rounded Rectangle 16"/>
+          <p:cNvSpPr/>
+          <p:nvPr/>
+        </p:nvSpPr>
+        <p:spPr>
+          <a:xfrm>
+            <a:off x="685800" y="5120640"/>
+            <a:ext cx="10817352" cy="777240"/>
+          </a:xfrm>
+          <a:prstGeom prst="roundRect">
+            <a:avLst/>
+          </a:prstGeom>
+          <a:solidFill>
+            <a:srgbClr val="FFFFFF"/>
+          </a:solidFill>
+          <a:ln w="19050">
+            <a:solidFill>
+              <a:srgbClr val="E0E7FF"/>
+            </a:solidFill>
+          </a:ln>
+        </p:spPr>
+        <p:style>
+          <a:lnRef idx="1">
+            <a:schemeClr val="accent1"/>
+          </a:lnRef>
+          <a:fillRef idx="3">
+            <a:schemeClr val="accent1"/>
+          </a:fillRef>
+          <a:effectRef idx="2">
+            <a:schemeClr val="accent1"/>
+          </a:effectRef>
+          <a:fontRef idx="minor">
+            <a:schemeClr val="lt1"/>
+          </a:fontRef>
+        </p:style>
+        <p:txBody>
+          <a:bodyPr rtlCol="0" anchor="ctr"/>
+          <a:lstStyle/>
+          <a:p>
+            <a:pPr algn="ctr"/>
+          </a:p>
+        </p:txBody>
+      </p:sp>
+      <p:sp>
+        <p:nvSpPr>
+          <p:cNvPr id="18" name="Rectangle 17"/>
+          <p:cNvSpPr/>
+          <p:nvPr/>
+        </p:nvSpPr>
+        <p:spPr>
+          <a:xfrm>
+            <a:off x="685800" y="5120640"/>
+            <a:ext cx="109728" cy="777240"/>
+          </a:xfrm>
+          <a:prstGeom prst="rect">
+            <a:avLst/>
+          </a:prstGeom>
+          <a:solidFill>
+            <a:srgbClr val="4F46E5"/>
+          </a:solidFill>
+          <a:ln>
+            <a:noFill/>
+          </a:ln>
+        </p:spPr>
+        <p:style>
+          <a:lnRef idx="1">
+            <a:schemeClr val="accent1"/>
+          </a:lnRef>
+          <a:fillRef idx="3">
+            <a:schemeClr val="accent1"/>
+          </a:fillRef>
+          <a:effectRef idx="2">
+            <a:schemeClr val="accent1"/>
+          </a:effectRef>
+          <a:fontRef idx="minor">
+            <a:schemeClr val="lt1"/>
+          </a:fontRef>
+        </p:style>
+        <p:txBody>
+          <a:bodyPr rtlCol="0" anchor="ctr"/>
+          <a:lstStyle/>
+          <a:p>
+            <a:pPr algn="ctr"/>
+          </a:p>
+        </p:txBody>
+      </p:sp>
+      <p:sp>
+        <p:nvSpPr>
+          <p:cNvPr id="19" name="TextBox 18"/>
+          <p:cNvSpPr txBox="1"/>
+          <p:nvPr/>
+        </p:nvSpPr>
+        <p:spPr>
+          <a:xfrm>
+            <a:off x="1005840" y="5193792"/>
+            <a:ext cx="10314432" cy="630936"/>
+          </a:xfrm>
+          <a:prstGeom prst="rect">
+            <a:avLst/>
+          </a:prstGeom>
+          <a:noFill/>
+        </p:spPr>
+        <p:txBody>
+          <a:bodyPr wrap="square" lIns="0" tIns="0" rIns="0" bIns="0">
+            <a:spAutoFit/>
+          </a:bodyPr>
+          <a:lstStyle/>
           <a:p>
             <a:pPr>
-              <a:spcAft>
-                <a:spcPts val="1000"/>
-              </a:spcAft>
-              <a:defRPr sz="1500" b="1">
-                <a:solidFill>
-                  <a:srgbClr val="22D3EE"/>
+              <a:defRPr sz="1350" b="1">
+                <a:solidFill>
+                  <a:srgbClr val="0F172A"/>
                 </a:solidFill>
                 <a:latin typeface="Segoe UI"/>
               </a:defRPr>
             </a:pPr>
             <a:r>
-              <a:t>•  Interface &amp; Download Module: </a:t>
-            </a:r>
-            <a:r>
-              <a:rPr sz="1500" b="0">
-                <a:solidFill>
-                  <a:srgbClr val="CBD5E1"/>
+              <a:t>Interface &amp; Download Module: </a:t>
+            </a:r>
+            <a:r>
+              <a:rPr sz="1300" b="0">
+                <a:solidFill>
+                  <a:srgbClr val="334155"/>
                 </a:solidFill>
                 <a:latin typeface="Segoe UI"/>
               </a:rPr>
@@ -4716,7 +7308,7 @@
     <p:bg>
       <p:bgPr>
         <a:solidFill>
-          <a:srgbClr val="0B1324"/>
+          <a:srgbClr val="F8FAFC"/>
         </a:solidFill>
         <a:effectLst/>
       </p:bgPr>
@@ -4753,7 +7345,7 @@
             <a:pPr>
               <a:defRPr sz="3200" b="1">
                 <a:solidFill>
-                  <a:srgbClr val="F8FAFC"/>
+                  <a:srgbClr val="0F172A"/>
                 </a:solidFill>
                 <a:latin typeface="Segoe UI"/>
               </a:defRPr>
@@ -4773,13 +7365,13 @@
         <p:spPr>
           <a:xfrm>
             <a:off x="685800" y="1188720"/>
-            <a:ext cx="10817352" cy="27432"/>
+            <a:ext cx="10817352" cy="36576"/>
           </a:xfrm>
           <a:prstGeom prst="rect">
             <a:avLst/>
           </a:prstGeom>
           <a:solidFill>
-            <a:srgbClr val="22D3EE"/>
+            <a:srgbClr val="4F46E5"/>
           </a:solidFill>
           <a:ln>
             <a:noFill/>
@@ -4815,7 +7407,7 @@
         </p:nvSpPr>
         <p:spPr>
           <a:xfrm>
-            <a:off x="685800" y="6309360"/>
+            <a:off x="685800" y="6355080"/>
             <a:ext cx="10817352" cy="274320"/>
           </a:xfrm>
           <a:prstGeom prst="rect">
@@ -4845,14 +7437,102 @@
       </p:sp>
       <p:sp>
         <p:nvSpPr>
-          <p:cNvPr id="5" name="TextBox 4"/>
+          <p:cNvPr id="5" name="Rounded Rectangle 4"/>
+          <p:cNvSpPr/>
+          <p:nvPr/>
+        </p:nvSpPr>
+        <p:spPr>
+          <a:xfrm>
+            <a:off x="685800" y="1645920"/>
+            <a:ext cx="5212080" cy="2011680"/>
+          </a:xfrm>
+          <a:prstGeom prst="roundRect">
+            <a:avLst/>
+          </a:prstGeom>
+          <a:solidFill>
+            <a:srgbClr val="FFFFFF"/>
+          </a:solidFill>
+          <a:ln w="19050">
+            <a:solidFill>
+              <a:srgbClr val="E0E7FF"/>
+            </a:solidFill>
+          </a:ln>
+        </p:spPr>
+        <p:style>
+          <a:lnRef idx="1">
+            <a:schemeClr val="accent1"/>
+          </a:lnRef>
+          <a:fillRef idx="3">
+            <a:schemeClr val="accent1"/>
+          </a:fillRef>
+          <a:effectRef idx="2">
+            <a:schemeClr val="accent1"/>
+          </a:effectRef>
+          <a:fontRef idx="minor">
+            <a:schemeClr val="lt1"/>
+          </a:fontRef>
+        </p:style>
+        <p:txBody>
+          <a:bodyPr rtlCol="0" anchor="ctr"/>
+          <a:lstStyle/>
+          <a:p>
+            <a:pPr algn="ctr"/>
+          </a:p>
+        </p:txBody>
+      </p:sp>
+      <p:sp>
+        <p:nvSpPr>
+          <p:cNvPr id="6" name="Rectangle 5"/>
+          <p:cNvSpPr/>
+          <p:nvPr/>
+        </p:nvSpPr>
+        <p:spPr>
+          <a:xfrm>
+            <a:off x="685800" y="1645920"/>
+            <a:ext cx="109728" cy="2011680"/>
+          </a:xfrm>
+          <a:prstGeom prst="rect">
+            <a:avLst/>
+          </a:prstGeom>
+          <a:solidFill>
+            <a:srgbClr val="10B981"/>
+          </a:solidFill>
+          <a:ln>
+            <a:noFill/>
+          </a:ln>
+        </p:spPr>
+        <p:style>
+          <a:lnRef idx="1">
+            <a:schemeClr val="accent1"/>
+          </a:lnRef>
+          <a:fillRef idx="3">
+            <a:schemeClr val="accent1"/>
+          </a:fillRef>
+          <a:effectRef idx="2">
+            <a:schemeClr val="accent1"/>
+          </a:effectRef>
+          <a:fontRef idx="minor">
+            <a:schemeClr val="lt1"/>
+          </a:fontRef>
+        </p:style>
+        <p:txBody>
+          <a:bodyPr rtlCol="0" anchor="ctr"/>
+          <a:lstStyle/>
+          <a:p>
+            <a:pPr algn="ctr"/>
+          </a:p>
+        </p:txBody>
+      </p:sp>
+      <p:sp>
+        <p:nvSpPr>
+          <p:cNvPr id="7" name="TextBox 6"/>
           <p:cNvSpPr txBox="1"/>
           <p:nvPr/>
         </p:nvSpPr>
         <p:spPr>
           <a:xfrm>
-            <a:off x="685800" y="1645920"/>
-            <a:ext cx="10817352" cy="4389120"/>
+            <a:off x="1005840" y="1828800"/>
+            <a:ext cx="4709160" cy="1645920"/>
           </a:xfrm>
           <a:prstGeom prst="rect">
             <a:avLst/>
@@ -4867,100 +7547,449 @@
           <a:p>
             <a:pPr>
               <a:spcAft>
-                <a:spcPts val="1200"/>
+                <a:spcPts val="800"/>
               </a:spcAft>
-              <a:defRPr sz="1550" b="1">
-                <a:solidFill>
-                  <a:srgbClr val="22D3EE"/>
+              <a:defRPr sz="1600" b="1">
+                <a:solidFill>
+                  <a:srgbClr val="0F172A"/>
                 </a:solidFill>
                 <a:latin typeface="Segoe UI"/>
               </a:defRPr>
             </a:pPr>
             <a:r>
-              <a:t>•  Cost-Efficiency: </a:t>
-            </a:r>
-            <a:r>
-              <a:rPr sz="1550" b="0">
-                <a:solidFill>
-                  <a:srgbClr val="CBD5E1"/>
+              <a:t>Cost-Efficiency</a:t>
+            </a:r>
+          </a:p>
+          <a:p>
+            <a:pPr>
+              <a:defRPr sz="1300">
+                <a:solidFill>
+                  <a:srgbClr val="334155"/>
                 </a:solidFill>
                 <a:latin typeface="Segoe UI"/>
-              </a:rPr>
+              </a:defRPr>
+            </a:pPr>
+            <a:r>
               <a:t>Capitalization and casing rules run locally at zero token cost, conserving expensive LLM API bandwidth for semantic restructuring tasks.</a:t>
             </a:r>
           </a:p>
+        </p:txBody>
+      </p:sp>
+      <p:sp>
+        <p:nvSpPr>
+          <p:cNvPr id="8" name="Rounded Rectangle 7"/>
+          <p:cNvSpPr/>
+          <p:nvPr/>
+        </p:nvSpPr>
+        <p:spPr>
+          <a:xfrm>
+            <a:off x="6291072" y="1645920"/>
+            <a:ext cx="5212080" cy="2011680"/>
+          </a:xfrm>
+          <a:prstGeom prst="roundRect">
+            <a:avLst/>
+          </a:prstGeom>
+          <a:solidFill>
+            <a:srgbClr val="FFFFFF"/>
+          </a:solidFill>
+          <a:ln w="19050">
+            <a:solidFill>
+              <a:srgbClr val="E0E7FF"/>
+            </a:solidFill>
+          </a:ln>
+        </p:spPr>
+        <p:style>
+          <a:lnRef idx="1">
+            <a:schemeClr val="accent1"/>
+          </a:lnRef>
+          <a:fillRef idx="3">
+            <a:schemeClr val="accent1"/>
+          </a:fillRef>
+          <a:effectRef idx="2">
+            <a:schemeClr val="accent1"/>
+          </a:effectRef>
+          <a:fontRef idx="minor">
+            <a:schemeClr val="lt1"/>
+          </a:fontRef>
+        </p:style>
+        <p:txBody>
+          <a:bodyPr rtlCol="0" anchor="ctr"/>
+          <a:lstStyle/>
+          <a:p>
+            <a:pPr algn="ctr"/>
+          </a:p>
+        </p:txBody>
+      </p:sp>
+      <p:sp>
+        <p:nvSpPr>
+          <p:cNvPr id="9" name="Rectangle 8"/>
+          <p:cNvSpPr/>
+          <p:nvPr/>
+        </p:nvSpPr>
+        <p:spPr>
+          <a:xfrm>
+            <a:off x="6291072" y="1645920"/>
+            <a:ext cx="109728" cy="2011680"/>
+          </a:xfrm>
+          <a:prstGeom prst="rect">
+            <a:avLst/>
+          </a:prstGeom>
+          <a:solidFill>
+            <a:srgbClr val="10B981"/>
+          </a:solidFill>
+          <a:ln>
+            <a:noFill/>
+          </a:ln>
+        </p:spPr>
+        <p:style>
+          <a:lnRef idx="1">
+            <a:schemeClr val="accent1"/>
+          </a:lnRef>
+          <a:fillRef idx="3">
+            <a:schemeClr val="accent1"/>
+          </a:fillRef>
+          <a:effectRef idx="2">
+            <a:schemeClr val="accent1"/>
+          </a:effectRef>
+          <a:fontRef idx="minor">
+            <a:schemeClr val="lt1"/>
+          </a:fontRef>
+        </p:style>
+        <p:txBody>
+          <a:bodyPr rtlCol="0" anchor="ctr"/>
+          <a:lstStyle/>
+          <a:p>
+            <a:pPr algn="ctr"/>
+          </a:p>
+        </p:txBody>
+      </p:sp>
+      <p:sp>
+        <p:nvSpPr>
+          <p:cNvPr id="10" name="TextBox 9"/>
+          <p:cNvSpPr txBox="1"/>
+          <p:nvPr/>
+        </p:nvSpPr>
+        <p:spPr>
+          <a:xfrm>
+            <a:off x="6611112" y="1828800"/>
+            <a:ext cx="4709160" cy="1645920"/>
+          </a:xfrm>
+          <a:prstGeom prst="rect">
+            <a:avLst/>
+          </a:prstGeom>
+          <a:noFill/>
+        </p:spPr>
+        <p:txBody>
+          <a:bodyPr wrap="square" lIns="0" tIns="0" rIns="0" bIns="0">
+            <a:spAutoFit/>
+          </a:bodyPr>
+          <a:lstStyle/>
           <a:p>
             <a:pPr>
               <a:spcAft>
-                <a:spcPts val="1200"/>
+                <a:spcPts val="800"/>
               </a:spcAft>
-              <a:defRPr sz="1550" b="1">
-                <a:solidFill>
-                  <a:srgbClr val="22D3EE"/>
+              <a:defRPr sz="1600" b="1">
+                <a:solidFill>
+                  <a:srgbClr val="0F172A"/>
                 </a:solidFill>
                 <a:latin typeface="Segoe UI"/>
               </a:defRPr>
             </a:pPr>
             <a:r>
-              <a:t>•  Syntax Security: </a:t>
-            </a:r>
-            <a:r>
-              <a:rPr sz="1550" b="0">
-                <a:solidFill>
-                  <a:srgbClr val="CBD5E1"/>
+              <a:t>Syntax Security</a:t>
+            </a:r>
+          </a:p>
+          <a:p>
+            <a:pPr>
+              <a:defRPr sz="1300">
+                <a:solidFill>
+                  <a:srgbClr val="334155"/>
                 </a:solidFill>
                 <a:latin typeface="Segoe UI"/>
-              </a:rPr>
+              </a:defRPr>
+            </a:pPr>
+            <a:r>
               <a:t>The self-correcting validation loop acts as a compiler guard, preventing code hallucinations and ensuring the user only receives valid, executable SQL.</a:t>
             </a:r>
           </a:p>
+        </p:txBody>
+      </p:sp>
+      <p:sp>
+        <p:nvSpPr>
+          <p:cNvPr id="11" name="Rounded Rectangle 10"/>
+          <p:cNvSpPr/>
+          <p:nvPr/>
+        </p:nvSpPr>
+        <p:spPr>
+          <a:xfrm>
+            <a:off x="685800" y="3840480"/>
+            <a:ext cx="5212080" cy="2011680"/>
+          </a:xfrm>
+          <a:prstGeom prst="roundRect">
+            <a:avLst/>
+          </a:prstGeom>
+          <a:solidFill>
+            <a:srgbClr val="FFFFFF"/>
+          </a:solidFill>
+          <a:ln w="19050">
+            <a:solidFill>
+              <a:srgbClr val="E0E7FF"/>
+            </a:solidFill>
+          </a:ln>
+        </p:spPr>
+        <p:style>
+          <a:lnRef idx="1">
+            <a:schemeClr val="accent1"/>
+          </a:lnRef>
+          <a:fillRef idx="3">
+            <a:schemeClr val="accent1"/>
+          </a:fillRef>
+          <a:effectRef idx="2">
+            <a:schemeClr val="accent1"/>
+          </a:effectRef>
+          <a:fontRef idx="minor">
+            <a:schemeClr val="lt1"/>
+          </a:fontRef>
+        </p:style>
+        <p:txBody>
+          <a:bodyPr rtlCol="0" anchor="ctr"/>
+          <a:lstStyle/>
+          <a:p>
+            <a:pPr algn="ctr"/>
+          </a:p>
+        </p:txBody>
+      </p:sp>
+      <p:sp>
+        <p:nvSpPr>
+          <p:cNvPr id="12" name="Rectangle 11"/>
+          <p:cNvSpPr/>
+          <p:nvPr/>
+        </p:nvSpPr>
+        <p:spPr>
+          <a:xfrm>
+            <a:off x="685800" y="3840480"/>
+            <a:ext cx="109728" cy="2011680"/>
+          </a:xfrm>
+          <a:prstGeom prst="rect">
+            <a:avLst/>
+          </a:prstGeom>
+          <a:solidFill>
+            <a:srgbClr val="10B981"/>
+          </a:solidFill>
+          <a:ln>
+            <a:noFill/>
+          </a:ln>
+        </p:spPr>
+        <p:style>
+          <a:lnRef idx="1">
+            <a:schemeClr val="accent1"/>
+          </a:lnRef>
+          <a:fillRef idx="3">
+            <a:schemeClr val="accent1"/>
+          </a:fillRef>
+          <a:effectRef idx="2">
+            <a:schemeClr val="accent1"/>
+          </a:effectRef>
+          <a:fontRef idx="minor">
+            <a:schemeClr val="lt1"/>
+          </a:fontRef>
+        </p:style>
+        <p:txBody>
+          <a:bodyPr rtlCol="0" anchor="ctr"/>
+          <a:lstStyle/>
+          <a:p>
+            <a:pPr algn="ctr"/>
+          </a:p>
+        </p:txBody>
+      </p:sp>
+      <p:sp>
+        <p:nvSpPr>
+          <p:cNvPr id="13" name="TextBox 12"/>
+          <p:cNvSpPr txBox="1"/>
+          <p:nvPr/>
+        </p:nvSpPr>
+        <p:spPr>
+          <a:xfrm>
+            <a:off x="1005840" y="4023360"/>
+            <a:ext cx="4709160" cy="1645920"/>
+          </a:xfrm>
+          <a:prstGeom prst="rect">
+            <a:avLst/>
+          </a:prstGeom>
+          <a:noFill/>
+        </p:spPr>
+        <p:txBody>
+          <a:bodyPr wrap="square" lIns="0" tIns="0" rIns="0" bIns="0">
+            <a:spAutoFit/>
+          </a:bodyPr>
+          <a:lstStyle/>
           <a:p>
             <a:pPr>
               <a:spcAft>
-                <a:spcPts val="1200"/>
+                <a:spcPts val="800"/>
               </a:spcAft>
-              <a:defRPr sz="1550" b="1">
-                <a:solidFill>
-                  <a:srgbClr val="22D3EE"/>
+              <a:defRPr sz="1600" b="1">
+                <a:solidFill>
+                  <a:srgbClr val="0F172A"/>
                 </a:solidFill>
                 <a:latin typeface="Segoe UI"/>
               </a:defRPr>
             </a:pPr>
             <a:r>
-              <a:t>•  Cloud Deployability: </a:t>
-            </a:r>
-            <a:r>
-              <a:rPr sz="1550" b="0">
-                <a:solidFill>
-                  <a:srgbClr val="CBD5E1"/>
+              <a:t>Cloud Deployability</a:t>
+            </a:r>
+          </a:p>
+          <a:p>
+            <a:pPr>
+              <a:defRPr sz="1300">
+                <a:solidFill>
+                  <a:srgbClr val="334155"/>
                 </a:solidFill>
                 <a:latin typeface="Segoe UI"/>
-              </a:rPr>
+              </a:defRPr>
+            </a:pPr>
+            <a:r>
               <a:t>Supports in-memory batch file uploads, allowing the application to run smoothly on isolated cloud deployment servers like Streamlit Community Cloud.</a:t>
             </a:r>
           </a:p>
+        </p:txBody>
+      </p:sp>
+      <p:sp>
+        <p:nvSpPr>
+          <p:cNvPr id="14" name="Rounded Rectangle 13"/>
+          <p:cNvSpPr/>
+          <p:nvPr/>
+        </p:nvSpPr>
+        <p:spPr>
+          <a:xfrm>
+            <a:off x="6291072" y="3840480"/>
+            <a:ext cx="5212080" cy="2011680"/>
+          </a:xfrm>
+          <a:prstGeom prst="roundRect">
+            <a:avLst/>
+          </a:prstGeom>
+          <a:solidFill>
+            <a:srgbClr val="FFFFFF"/>
+          </a:solidFill>
+          <a:ln w="19050">
+            <a:solidFill>
+              <a:srgbClr val="E0E7FF"/>
+            </a:solidFill>
+          </a:ln>
+        </p:spPr>
+        <p:style>
+          <a:lnRef idx="1">
+            <a:schemeClr val="accent1"/>
+          </a:lnRef>
+          <a:fillRef idx="3">
+            <a:schemeClr val="accent1"/>
+          </a:fillRef>
+          <a:effectRef idx="2">
+            <a:schemeClr val="accent1"/>
+          </a:effectRef>
+          <a:fontRef idx="minor">
+            <a:schemeClr val="lt1"/>
+          </a:fontRef>
+        </p:style>
+        <p:txBody>
+          <a:bodyPr rtlCol="0" anchor="ctr"/>
+          <a:lstStyle/>
+          <a:p>
+            <a:pPr algn="ctr"/>
+          </a:p>
+        </p:txBody>
+      </p:sp>
+      <p:sp>
+        <p:nvSpPr>
+          <p:cNvPr id="15" name="Rectangle 14"/>
+          <p:cNvSpPr/>
+          <p:nvPr/>
+        </p:nvSpPr>
+        <p:spPr>
+          <a:xfrm>
+            <a:off x="6291072" y="3840480"/>
+            <a:ext cx="109728" cy="2011680"/>
+          </a:xfrm>
+          <a:prstGeom prst="rect">
+            <a:avLst/>
+          </a:prstGeom>
+          <a:solidFill>
+            <a:srgbClr val="10B981"/>
+          </a:solidFill>
+          <a:ln>
+            <a:noFill/>
+          </a:ln>
+        </p:spPr>
+        <p:style>
+          <a:lnRef idx="1">
+            <a:schemeClr val="accent1"/>
+          </a:lnRef>
+          <a:fillRef idx="3">
+            <a:schemeClr val="accent1"/>
+          </a:fillRef>
+          <a:effectRef idx="2">
+            <a:schemeClr val="accent1"/>
+          </a:effectRef>
+          <a:fontRef idx="minor">
+            <a:schemeClr val="lt1"/>
+          </a:fontRef>
+        </p:style>
+        <p:txBody>
+          <a:bodyPr rtlCol="0" anchor="ctr"/>
+          <a:lstStyle/>
+          <a:p>
+            <a:pPr algn="ctr"/>
+          </a:p>
+        </p:txBody>
+      </p:sp>
+      <p:sp>
+        <p:nvSpPr>
+          <p:cNvPr id="16" name="TextBox 15"/>
+          <p:cNvSpPr txBox="1"/>
+          <p:nvPr/>
+        </p:nvSpPr>
+        <p:spPr>
+          <a:xfrm>
+            <a:off x="6611112" y="4023360"/>
+            <a:ext cx="4709160" cy="1645920"/>
+          </a:xfrm>
+          <a:prstGeom prst="rect">
+            <a:avLst/>
+          </a:prstGeom>
+          <a:noFill/>
+        </p:spPr>
+        <p:txBody>
+          <a:bodyPr wrap="square" lIns="0" tIns="0" rIns="0" bIns="0">
+            <a:spAutoFit/>
+          </a:bodyPr>
+          <a:lstStyle/>
           <a:p>
             <a:pPr>
               <a:spcAft>
-                <a:spcPts val="1200"/>
+                <a:spcPts val="800"/>
               </a:spcAft>
-              <a:defRPr sz="1550" b="1">
-                <a:solidFill>
-                  <a:srgbClr val="22D3EE"/>
+              <a:defRPr sz="1600" b="1">
+                <a:solidFill>
+                  <a:srgbClr val="0F172A"/>
                 </a:solidFill>
                 <a:latin typeface="Segoe UI"/>
               </a:defRPr>
             </a:pPr>
             <a:r>
-              <a:t>•  Pipeline Integration: </a:t>
-            </a:r>
-            <a:r>
-              <a:rPr sz="1550" b="0">
-                <a:solidFill>
-                  <a:srgbClr val="CBD5E1"/>
+              <a:t>Pipeline Integration</a:t>
+            </a:r>
+          </a:p>
+          <a:p>
+            <a:pPr>
+              <a:defRPr sz="1300">
+                <a:solidFill>
+                  <a:srgbClr val="334155"/>
                 </a:solidFill>
                 <a:latin typeface="Segoe UI"/>
-              </a:rPr>
+              </a:defRPr>
+            </a:pPr>
+            <a:r>
               <a:t>Dual CLI and web dashboard structure allows the tool to fit seamlessly into single-query debugging sessions or automated Git pre-commit hooks.</a:t>
             </a:r>
           </a:p>
@@ -4980,7 +8009,7 @@
     <p:bg>
       <p:bgPr>
         <a:solidFill>
-          <a:srgbClr val="0B1324"/>
+          <a:srgbClr val="F8FAFC"/>
         </a:solidFill>
         <a:effectLst/>
       </p:bgPr>
@@ -5017,7 +8046,7 @@
             <a:pPr>
               <a:defRPr sz="3200" b="1">
                 <a:solidFill>
-                  <a:srgbClr val="F8FAFC"/>
+                  <a:srgbClr val="0F172A"/>
                 </a:solidFill>
                 <a:latin typeface="Segoe UI"/>
               </a:defRPr>
@@ -5037,13 +8066,13 @@
         <p:spPr>
           <a:xfrm>
             <a:off x="685800" y="1188720"/>
-            <a:ext cx="10817352" cy="27432"/>
+            <a:ext cx="10817352" cy="36576"/>
           </a:xfrm>
           <a:prstGeom prst="rect">
             <a:avLst/>
           </a:prstGeom>
           <a:solidFill>
-            <a:srgbClr val="22D3EE"/>
+            <a:srgbClr val="4F46E5"/>
           </a:solidFill>
           <a:ln>
             <a:noFill/>
@@ -5079,7 +8108,7 @@
         </p:nvSpPr>
         <p:spPr>
           <a:xfrm>
-            <a:off x="685800" y="6309360"/>
+            <a:off x="685800" y="6355080"/>
             <a:ext cx="10817352" cy="274320"/>
           </a:xfrm>
           <a:prstGeom prst="rect">
@@ -5109,14 +8138,102 @@
       </p:sp>
       <p:sp>
         <p:nvSpPr>
-          <p:cNvPr id="5" name="TextBox 4"/>
+          <p:cNvPr id="5" name="Rounded Rectangle 4"/>
+          <p:cNvSpPr/>
+          <p:nvPr/>
+        </p:nvSpPr>
+        <p:spPr>
+          <a:xfrm>
+            <a:off x="685800" y="1645920"/>
+            <a:ext cx="4754880" cy="4297680"/>
+          </a:xfrm>
+          <a:prstGeom prst="roundRect">
+            <a:avLst/>
+          </a:prstGeom>
+          <a:solidFill>
+            <a:srgbClr val="ECFDF5"/>
+          </a:solidFill>
+          <a:ln w="19050">
+            <a:solidFill>
+              <a:srgbClr val="E0E7FF"/>
+            </a:solidFill>
+          </a:ln>
+        </p:spPr>
+        <p:style>
+          <a:lnRef idx="1">
+            <a:schemeClr val="accent1"/>
+          </a:lnRef>
+          <a:fillRef idx="3">
+            <a:schemeClr val="accent1"/>
+          </a:fillRef>
+          <a:effectRef idx="2">
+            <a:schemeClr val="accent1"/>
+          </a:effectRef>
+          <a:fontRef idx="minor">
+            <a:schemeClr val="lt1"/>
+          </a:fontRef>
+        </p:style>
+        <p:txBody>
+          <a:bodyPr rtlCol="0" anchor="ctr"/>
+          <a:lstStyle/>
+          <a:p>
+            <a:pPr algn="ctr"/>
+          </a:p>
+        </p:txBody>
+      </p:sp>
+      <p:sp>
+        <p:nvSpPr>
+          <p:cNvPr id="6" name="Rectangle 5"/>
+          <p:cNvSpPr/>
+          <p:nvPr/>
+        </p:nvSpPr>
+        <p:spPr>
+          <a:xfrm>
+            <a:off x="685800" y="1645920"/>
+            <a:ext cx="109728" cy="4297680"/>
+          </a:xfrm>
+          <a:prstGeom prst="rect">
+            <a:avLst/>
+          </a:prstGeom>
+          <a:solidFill>
+            <a:srgbClr val="10B981"/>
+          </a:solidFill>
+          <a:ln>
+            <a:noFill/>
+          </a:ln>
+        </p:spPr>
+        <p:style>
+          <a:lnRef idx="1">
+            <a:schemeClr val="accent1"/>
+          </a:lnRef>
+          <a:fillRef idx="3">
+            <a:schemeClr val="accent1"/>
+          </a:fillRef>
+          <a:effectRef idx="2">
+            <a:schemeClr val="accent1"/>
+          </a:effectRef>
+          <a:fontRef idx="minor">
+            <a:schemeClr val="lt1"/>
+          </a:fontRef>
+        </p:style>
+        <p:txBody>
+          <a:bodyPr rtlCol="0" anchor="ctr"/>
+          <a:lstStyle/>
+          <a:p>
+            <a:pPr algn="ctr"/>
+          </a:p>
+        </p:txBody>
+      </p:sp>
+      <p:sp>
+        <p:nvSpPr>
+          <p:cNvPr id="7" name="TextBox 6"/>
           <p:cNvSpPr txBox="1"/>
           <p:nvPr/>
         </p:nvSpPr>
         <p:spPr>
           <a:xfrm>
-            <a:off x="685800" y="1645920"/>
-            <a:ext cx="10817352" cy="4389120"/>
+            <a:off x="1051560" y="2011680"/>
+            <a:ext cx="4114800" cy="3566160"/>
           </a:xfrm>
           <a:prstGeom prst="rect">
             <a:avLst/>
@@ -5130,12 +8247,12 @@
           <a:lstStyle/>
           <a:p>
             <a:pPr>
-              <a:spcAft>
-                <a:spcPts val="2000"/>
-              </a:spcAft>
-              <a:defRPr sz="1900" b="1">
-                <a:solidFill>
-                  <a:srgbClr val="22D3EE"/>
+              <a:lnSpc>
+                <a:spcPct val="130000"/>
+              </a:lnSpc>
+              <a:defRPr sz="2000" b="1">
+                <a:solidFill>
+                  <a:srgbClr val="10B981"/>
                 </a:solidFill>
                 <a:latin typeface="Segoe UI"/>
               </a:defRPr>
@@ -5144,14 +8261,40 @@
               <a:t>The SQL Query Linter &amp; Style Fixer successfully bridges the gap between rule-based style cleaners and AI-driven semantic query model refactoring.</a:t>
             </a:r>
           </a:p>
+        </p:txBody>
+      </p:sp>
+      <p:sp>
+        <p:nvSpPr>
+          <p:cNvPr id="8" name="TextBox 7"/>
+          <p:cNvSpPr txBox="1"/>
+          <p:nvPr/>
+        </p:nvSpPr>
+        <p:spPr>
+          <a:xfrm>
+            <a:off x="5897880" y="1645920"/>
+            <a:ext cx="5605272" cy="4297680"/>
+          </a:xfrm>
+          <a:prstGeom prst="rect">
+            <a:avLst/>
+          </a:prstGeom>
+          <a:noFill/>
+        </p:spPr>
+        <p:txBody>
+          <a:bodyPr wrap="square" lIns="0" tIns="0" rIns="0" bIns="0">
+            <a:spAutoFit/>
+          </a:bodyPr>
+          <a:lstStyle/>
           <a:p>
             <a:pPr>
+              <a:lnSpc>
+                <a:spcPct val="120000"/>
+              </a:lnSpc>
               <a:spcBef>
-                <a:spcPts val="800"/>
+                <a:spcPts val="1000"/>
               </a:spcBef>
               <a:defRPr sz="1500">
                 <a:solidFill>
-                  <a:srgbClr val="CBD5E1"/>
+                  <a:srgbClr val="334155"/>
                 </a:solidFill>
                 <a:latin typeface="Segoe UI"/>
               </a:defRPr>
@@ -5162,12 +8305,15 @@
           </a:p>
           <a:p>
             <a:pPr>
+              <a:lnSpc>
+                <a:spcPct val="120000"/>
+              </a:lnSpc>
               <a:spcBef>
-                <a:spcPts val="800"/>
+                <a:spcPts val="1000"/>
               </a:spcBef>
               <a:defRPr sz="1500">
                 <a:solidFill>
-                  <a:srgbClr val="CBD5E1"/>
+                  <a:srgbClr val="334155"/>
                 </a:solidFill>
                 <a:latin typeface="Segoe UI"/>
               </a:defRPr>
@@ -5178,12 +8324,15 @@
           </a:p>
           <a:p>
             <a:pPr>
+              <a:lnSpc>
+                <a:spcPct val="120000"/>
+              </a:lnSpc>
               <a:spcBef>
-                <a:spcPts val="800"/>
+                <a:spcPts val="1000"/>
               </a:spcBef>
               <a:defRPr sz="1500">
                 <a:solidFill>
-                  <a:srgbClr val="CBD5E1"/>
+                  <a:srgbClr val="334155"/>
                 </a:solidFill>
                 <a:latin typeface="Segoe UI"/>
               </a:defRPr>
@@ -5194,12 +8343,15 @@
           </a:p>
           <a:p>
             <a:pPr>
+              <a:lnSpc>
+                <a:spcPct val="120000"/>
+              </a:lnSpc>
               <a:spcBef>
-                <a:spcPts val="800"/>
+                <a:spcPts val="1000"/>
               </a:spcBef>
               <a:defRPr sz="1500">
                 <a:solidFill>
-                  <a:srgbClr val="CBD5E1"/>
+                  <a:srgbClr val="334155"/>
                 </a:solidFill>
                 <a:latin typeface="Segoe UI"/>
               </a:defRPr>

</xml_diff>

<commit_message>
Update presentation Presentation.pptx with modern sky blue canvas theme
</commit_message>
<xml_diff>
--- a/Presentation.pptx
+++ b/Presentation.pptx
@@ -3091,7 +3091,7 @@
     <p:bg>
       <p:bgPr>
         <a:solidFill>
-          <a:srgbClr val="F8FAFC"/>
+          <a:srgbClr val="E6EDF6"/>
         </a:solidFill>
         <a:effectLst/>
       </p:bgPr>
@@ -3403,7 +3403,7 @@
     <p:bg>
       <p:bgPr>
         <a:solidFill>
-          <a:srgbClr val="F8FAFC"/>
+          <a:srgbClr val="E6EDF6"/>
         </a:solidFill>
         <a:effectLst/>
       </p:bgPr>
@@ -3545,7 +3545,7 @@
             <a:avLst/>
           </a:prstGeom>
           <a:solidFill>
-            <a:srgbClr val="F0F2FE"/>
+            <a:srgbClr val="D7E2FA"/>
           </a:solidFill>
           <a:ln w="19050">
             <a:solidFill>
@@ -3789,7 +3789,7 @@
     <p:bg>
       <p:bgPr>
         <a:solidFill>
-          <a:srgbClr val="F8FAFC"/>
+          <a:srgbClr val="E6EDF6"/>
         </a:solidFill>
         <a:effectLst/>
       </p:bgPr>
@@ -4595,7 +4595,7 @@
     <p:bg>
       <p:bgPr>
         <a:solidFill>
-          <a:srgbClr val="F8FAFC"/>
+          <a:srgbClr val="E6EDF6"/>
         </a:solidFill>
         <a:effectLst/>
       </p:bgPr>
@@ -5401,7 +5401,7 @@
     <p:bg>
       <p:bgPr>
         <a:solidFill>
-          <a:srgbClr val="F8FAFC"/>
+          <a:srgbClr val="E6EDF6"/>
         </a:solidFill>
         <a:effectLst/>
       </p:bgPr>
@@ -6502,7 +6502,7 @@
     <p:bg>
       <p:bgPr>
         <a:solidFill>
-          <a:srgbClr val="F8FAFC"/>
+          <a:srgbClr val="E6EDF6"/>
         </a:solidFill>
         <a:effectLst/>
       </p:bgPr>
@@ -7308,7 +7308,7 @@
     <p:bg>
       <p:bgPr>
         <a:solidFill>
-          <a:srgbClr val="F8FAFC"/>
+          <a:srgbClr val="E6EDF6"/>
         </a:solidFill>
         <a:effectLst/>
       </p:bgPr>
@@ -8009,7 +8009,7 @@
     <p:bg>
       <p:bgPr>
         <a:solidFill>
-          <a:srgbClr val="F8FAFC"/>
+          <a:srgbClr val="E6EDF6"/>
         </a:solidFill>
         <a:effectLst/>
       </p:bgPr>
@@ -8151,7 +8151,7 @@
             <a:avLst/>
           </a:prstGeom>
           <a:solidFill>
-            <a:srgbClr val="ECFDF5"/>
+            <a:srgbClr val="D1FAE5"/>
           </a:solidFill>
           <a:ln w="19050">
             <a:solidFill>

</xml_diff>

<commit_message>
Update presentation Presentation.pptx with modern corporate Indigo & Cream theme
</commit_message>
<xml_diff>
--- a/Presentation.pptx
+++ b/Presentation.pptx
@@ -3091,7 +3091,7 @@
     <p:bg>
       <p:bgPr>
         <a:solidFill>
-          <a:srgbClr val="E6EDF6"/>
+          <a:srgbClr val="FAF8F5"/>
         </a:solidFill>
         <a:effectLst/>
       </p:bgPr>
@@ -3403,7 +3403,7 @@
     <p:bg>
       <p:bgPr>
         <a:solidFill>
-          <a:srgbClr val="E6EDF6"/>
+          <a:srgbClr val="FAF8F5"/>
         </a:solidFill>
         <a:effectLst/>
       </p:bgPr>
@@ -3545,7 +3545,7 @@
             <a:avLst/>
           </a:prstGeom>
           <a:solidFill>
-            <a:srgbClr val="D7E2FA"/>
+            <a:srgbClr val="F0F2FE"/>
           </a:solidFill>
           <a:ln w="19050">
             <a:solidFill>
@@ -3789,7 +3789,7 @@
     <p:bg>
       <p:bgPr>
         <a:solidFill>
-          <a:srgbClr val="E6EDF6"/>
+          <a:srgbClr val="FAF8F5"/>
         </a:solidFill>
         <a:effectLst/>
       </p:bgPr>
@@ -4595,7 +4595,7 @@
     <p:bg>
       <p:bgPr>
         <a:solidFill>
-          <a:srgbClr val="E6EDF6"/>
+          <a:srgbClr val="FAF8F5"/>
         </a:solidFill>
         <a:effectLst/>
       </p:bgPr>
@@ -5401,7 +5401,7 @@
     <p:bg>
       <p:bgPr>
         <a:solidFill>
-          <a:srgbClr val="E6EDF6"/>
+          <a:srgbClr val="FAF8F5"/>
         </a:solidFill>
         <a:effectLst/>
       </p:bgPr>
@@ -6502,7 +6502,7 @@
     <p:bg>
       <p:bgPr>
         <a:solidFill>
-          <a:srgbClr val="E6EDF6"/>
+          <a:srgbClr val="FAF8F5"/>
         </a:solidFill>
         <a:effectLst/>
       </p:bgPr>
@@ -7308,7 +7308,7 @@
     <p:bg>
       <p:bgPr>
         <a:solidFill>
-          <a:srgbClr val="E6EDF6"/>
+          <a:srgbClr val="FAF8F5"/>
         </a:solidFill>
         <a:effectLst/>
       </p:bgPr>
@@ -8009,7 +8009,7 @@
     <p:bg>
       <p:bgPr>
         <a:solidFill>
-          <a:srgbClr val="E6EDF6"/>
+          <a:srgbClr val="FAF8F5"/>
         </a:solidFill>
         <a:effectLst/>
       </p:bgPr>
@@ -8151,7 +8151,7 @@
             <a:avLst/>
           </a:prstGeom>
           <a:solidFill>
-            <a:srgbClr val="D1FAE5"/>
+            <a:srgbClr val="ECFDF5"/>
           </a:solidFill>
           <a:ln w="19050">
             <a:solidFill>

</xml_diff>

<commit_message>
Update presentation Presentation.pptx with luxury Champagne Executive light theme
</commit_message>
<xml_diff>
--- a/Presentation.pptx
+++ b/Presentation.pptx
@@ -3091,7 +3091,7 @@
     <p:bg>
       <p:bgPr>
         <a:solidFill>
-          <a:srgbClr val="0B0F1A"/>
+          <a:srgbClr val="FAF5EB"/>
         </a:solidFill>
         <a:effectLst/>
       </p:bgPr>
@@ -3118,7 +3118,7 @@
             <a:avLst/>
           </a:prstGeom>
           <a:solidFill>
-            <a:srgbClr val="06B6D4"/>
+            <a:srgbClr val="C5A059"/>
           </a:solidFill>
           <a:ln>
             <a:noFill/>
@@ -3161,11 +3161,11 @@
             <a:avLst/>
           </a:prstGeom>
           <a:solidFill>
-            <a:srgbClr val="141A2B"/>
+            <a:srgbClr val="FFFFFF"/>
           </a:solidFill>
           <a:ln w="38100">
             <a:solidFill>
-              <a:srgbClr val="06B6D4"/>
+              <a:srgbClr val="C5A059"/>
             </a:solidFill>
           </a:ln>
         </p:spPr>
@@ -3206,7 +3206,7 @@
             <a:avLst/>
           </a:prstGeom>
           <a:solidFill>
-            <a:srgbClr val="06B6D4"/>
+            <a:srgbClr val="C5A059"/>
           </a:solidFill>
           <a:ln>
             <a:noFill/>
@@ -3259,7 +3259,7 @@
             <a:pPr>
               <a:defRPr sz="4600" b="1">
                 <a:solidFill>
-                  <a:srgbClr val="FFFFFF"/>
+                  <a:srgbClr val="0F172A"/>
                 </a:solidFill>
                 <a:latin typeface="Segoe UI"/>
               </a:defRPr>
@@ -3275,7 +3275,7 @@
               </a:spcBef>
               <a:defRPr sz="2200" b="1">
                 <a:solidFill>
-                  <a:srgbClr val="06B6D4"/>
+                  <a:srgbClr val="C5A059"/>
                 </a:solidFill>
                 <a:latin typeface="Segoe UI"/>
               </a:defRPr>
@@ -3301,11 +3301,11 @@
             <a:avLst/>
           </a:prstGeom>
           <a:solidFill>
-            <a:srgbClr val="141A2B"/>
+            <a:srgbClr val="FFFFFF"/>
           </a:solidFill>
           <a:ln w="19050">
             <a:solidFill>
-              <a:srgbClr val="26304F"/>
+              <a:srgbClr val="E0DACC"/>
             </a:solidFill>
           </a:ln>
         </p:spPr>
@@ -3346,7 +3346,7 @@
             <a:avLst/>
           </a:prstGeom>
           <a:solidFill>
-            <a:srgbClr val="8B5CF6"/>
+            <a:srgbClr val="4F46E5"/>
           </a:solidFill>
           <a:ln>
             <a:noFill/>
@@ -3402,7 +3402,7 @@
               </a:spcAft>
               <a:defRPr sz="1300" b="1">
                 <a:solidFill>
-                  <a:srgbClr val="8B5CF6"/>
+                  <a:srgbClr val="4F46E5"/>
                 </a:solidFill>
                 <a:latin typeface="Segoe UI"/>
               </a:defRPr>
@@ -3418,7 +3418,7 @@
               </a:spcBef>
               <a:defRPr sz="1300">
                 <a:solidFill>
-                  <a:srgbClr val="BFDBFE"/>
+                  <a:srgbClr val="475569"/>
                 </a:solidFill>
                 <a:latin typeface="Segoe UI"/>
               </a:defRPr>
@@ -3434,7 +3434,7 @@
               </a:spcBef>
               <a:defRPr sz="1300">
                 <a:solidFill>
-                  <a:srgbClr val="BFDBFE"/>
+                  <a:srgbClr val="475569"/>
                 </a:solidFill>
                 <a:latin typeface="Segoe UI"/>
               </a:defRPr>
@@ -3450,7 +3450,7 @@
               </a:spcBef>
               <a:defRPr sz="1300">
                 <a:solidFill>
-                  <a:srgbClr val="BFDBFE"/>
+                  <a:srgbClr val="475569"/>
                 </a:solidFill>
                 <a:latin typeface="Segoe UI"/>
               </a:defRPr>
@@ -3466,7 +3466,7 @@
               </a:spcBef>
               <a:defRPr sz="1300">
                 <a:solidFill>
-                  <a:srgbClr val="BFDBFE"/>
+                  <a:srgbClr val="475569"/>
                 </a:solidFill>
                 <a:latin typeface="Segoe UI"/>
               </a:defRPr>
@@ -3491,7 +3491,7 @@
     <p:bg>
       <p:bgPr>
         <a:solidFill>
-          <a:srgbClr val="0B0F1A"/>
+          <a:srgbClr val="FAF5EB"/>
         </a:solidFill>
         <a:effectLst/>
       </p:bgPr>
@@ -3528,7 +3528,7 @@
             <a:pPr>
               <a:defRPr sz="3200" b="1">
                 <a:solidFill>
-                  <a:srgbClr val="FFFFFF"/>
+                  <a:srgbClr val="0F172A"/>
                 </a:solidFill>
                 <a:latin typeface="Segoe UI"/>
               </a:defRPr>
@@ -3554,7 +3554,7 @@
             <a:avLst/>
           </a:prstGeom>
           <a:solidFill>
-            <a:srgbClr val="06B6D4"/>
+            <a:srgbClr val="C5A059"/>
           </a:solidFill>
           <a:ln>
             <a:noFill/>
@@ -3607,7 +3607,7 @@
             <a:pPr algn="l">
               <a:defRPr sz="1000">
                 <a:solidFill>
-                  <a:srgbClr val="5A6B8C"/>
+                  <a:srgbClr val="8C8273"/>
                 </a:solidFill>
                 <a:latin typeface="Segoe UI"/>
               </a:defRPr>
@@ -3633,11 +3633,11 @@
             <a:avLst/>
           </a:prstGeom>
           <a:solidFill>
-            <a:srgbClr val="141A2B"/>
+            <a:srgbClr val="FFFFFF"/>
           </a:solidFill>
           <a:ln w="19050">
             <a:solidFill>
-              <a:srgbClr val="26304F"/>
+              <a:srgbClr val="E0DACC"/>
             </a:solidFill>
           </a:ln>
         </p:spPr>
@@ -3678,7 +3678,7 @@
             <a:avLst/>
           </a:prstGeom>
           <a:solidFill>
-            <a:srgbClr val="06B6D4"/>
+            <a:srgbClr val="C5A059"/>
           </a:solidFill>
           <a:ln>
             <a:noFill/>
@@ -3734,7 +3734,7 @@
               </a:lnSpc>
               <a:defRPr sz="1900" b="1">
                 <a:solidFill>
-                  <a:srgbClr val="06B6D4"/>
+                  <a:srgbClr val="C5A059"/>
                 </a:solidFill>
                 <a:latin typeface="Segoe UI"/>
               </a:defRPr>
@@ -3776,7 +3776,7 @@
               </a:spcBef>
               <a:defRPr sz="1500">
                 <a:solidFill>
-                  <a:srgbClr val="BFDBFE"/>
+                  <a:srgbClr val="475569"/>
                 </a:solidFill>
                 <a:latin typeface="Segoe UI"/>
               </a:defRPr>
@@ -3795,7 +3795,7 @@
               </a:spcBef>
               <a:defRPr sz="1500">
                 <a:solidFill>
-                  <a:srgbClr val="BFDBFE"/>
+                  <a:srgbClr val="475569"/>
                 </a:solidFill>
                 <a:latin typeface="Segoe UI"/>
               </a:defRPr>
@@ -3814,7 +3814,7 @@
               </a:spcBef>
               <a:defRPr sz="1500">
                 <a:solidFill>
-                  <a:srgbClr val="BFDBFE"/>
+                  <a:srgbClr val="475569"/>
                 </a:solidFill>
                 <a:latin typeface="Segoe UI"/>
               </a:defRPr>
@@ -3833,7 +3833,7 @@
               </a:spcBef>
               <a:defRPr sz="1500">
                 <a:solidFill>
-                  <a:srgbClr val="BFDBFE"/>
+                  <a:srgbClr val="475569"/>
                 </a:solidFill>
                 <a:latin typeface="Segoe UI"/>
               </a:defRPr>
@@ -3852,7 +3852,7 @@
               </a:spcBef>
               <a:defRPr sz="1500">
                 <a:solidFill>
-                  <a:srgbClr val="BFDBFE"/>
+                  <a:srgbClr val="475569"/>
                 </a:solidFill>
                 <a:latin typeface="Segoe UI"/>
               </a:defRPr>
@@ -3877,7 +3877,7 @@
     <p:bg>
       <p:bgPr>
         <a:solidFill>
-          <a:srgbClr val="0B0F1A"/>
+          <a:srgbClr val="FAF5EB"/>
         </a:solidFill>
         <a:effectLst/>
       </p:bgPr>
@@ -3914,7 +3914,7 @@
             <a:pPr>
               <a:defRPr sz="3200" b="1">
                 <a:solidFill>
-                  <a:srgbClr val="FFFFFF"/>
+                  <a:srgbClr val="0F172A"/>
                 </a:solidFill>
                 <a:latin typeface="Segoe UI"/>
               </a:defRPr>
@@ -3940,7 +3940,7 @@
             <a:avLst/>
           </a:prstGeom>
           <a:solidFill>
-            <a:srgbClr val="06B6D4"/>
+            <a:srgbClr val="C5A059"/>
           </a:solidFill>
           <a:ln>
             <a:noFill/>
@@ -3993,7 +3993,7 @@
             <a:pPr algn="l">
               <a:defRPr sz="1000">
                 <a:solidFill>
-                  <a:srgbClr val="5A6B8C"/>
+                  <a:srgbClr val="8C8273"/>
                 </a:solidFill>
                 <a:latin typeface="Segoe UI"/>
               </a:defRPr>
@@ -4019,11 +4019,11 @@
             <a:avLst/>
           </a:prstGeom>
           <a:solidFill>
-            <a:srgbClr val="141A2B"/>
+            <a:srgbClr val="FFFFFF"/>
           </a:solidFill>
           <a:ln w="19050">
             <a:solidFill>
-              <a:srgbClr val="26304F"/>
+              <a:srgbClr val="E0DACC"/>
             </a:solidFill>
           </a:ln>
         </p:spPr>
@@ -4064,7 +4064,7 @@
             <a:avLst/>
           </a:prstGeom>
           <a:solidFill>
-            <a:srgbClr val="F43F5E"/>
+            <a:srgbClr val="E11D48"/>
           </a:solidFill>
           <a:ln>
             <a:noFill/>
@@ -4107,7 +4107,7 @@
             <a:avLst/>
           </a:prstGeom>
           <a:solidFill>
-            <a:srgbClr val="F43F5E"/>
+            <a:srgbClr val="E11D48"/>
           </a:solidFill>
           <a:ln>
             <a:noFill/>
@@ -4170,7 +4170,7 @@
             <a:pPr>
               <a:defRPr sz="1350" b="1">
                 <a:solidFill>
-                  <a:srgbClr val="FFFFFF"/>
+                  <a:srgbClr val="0F172A"/>
                 </a:solidFill>
                 <a:latin typeface="Segoe UI"/>
               </a:defRPr>
@@ -4181,7 +4181,7 @@
             <a:r>
               <a:rPr sz="1300" b="0">
                 <a:solidFill>
-                  <a:srgbClr val="BFDBFE"/>
+                  <a:srgbClr val="475569"/>
                 </a:solidFill>
                 <a:latin typeface="Segoe UI"/>
               </a:rPr>
@@ -4205,11 +4205,11 @@
             <a:avLst/>
           </a:prstGeom>
           <a:solidFill>
-            <a:srgbClr val="141A2B"/>
+            <a:srgbClr val="FFFFFF"/>
           </a:solidFill>
           <a:ln w="19050">
             <a:solidFill>
-              <a:srgbClr val="26304F"/>
+              <a:srgbClr val="E0DACC"/>
             </a:solidFill>
           </a:ln>
         </p:spPr>
@@ -4250,7 +4250,7 @@
             <a:avLst/>
           </a:prstGeom>
           <a:solidFill>
-            <a:srgbClr val="F43F5E"/>
+            <a:srgbClr val="E11D48"/>
           </a:solidFill>
           <a:ln>
             <a:noFill/>
@@ -4293,7 +4293,7 @@
             <a:avLst/>
           </a:prstGeom>
           <a:solidFill>
-            <a:srgbClr val="F43F5E"/>
+            <a:srgbClr val="E11D48"/>
           </a:solidFill>
           <a:ln>
             <a:noFill/>
@@ -4356,7 +4356,7 @@
             <a:pPr>
               <a:defRPr sz="1350" b="1">
                 <a:solidFill>
-                  <a:srgbClr val="FFFFFF"/>
+                  <a:srgbClr val="0F172A"/>
                 </a:solidFill>
                 <a:latin typeface="Segoe UI"/>
               </a:defRPr>
@@ -4367,7 +4367,7 @@
             <a:r>
               <a:rPr sz="1300" b="0">
                 <a:solidFill>
-                  <a:srgbClr val="BFDBFE"/>
+                  <a:srgbClr val="475569"/>
                 </a:solidFill>
                 <a:latin typeface="Segoe UI"/>
               </a:rPr>
@@ -4391,11 +4391,11 @@
             <a:avLst/>
           </a:prstGeom>
           <a:solidFill>
-            <a:srgbClr val="141A2B"/>
+            <a:srgbClr val="FFFFFF"/>
           </a:solidFill>
           <a:ln w="19050">
             <a:solidFill>
-              <a:srgbClr val="26304F"/>
+              <a:srgbClr val="E0DACC"/>
             </a:solidFill>
           </a:ln>
         </p:spPr>
@@ -4436,7 +4436,7 @@
             <a:avLst/>
           </a:prstGeom>
           <a:solidFill>
-            <a:srgbClr val="F43F5E"/>
+            <a:srgbClr val="E11D48"/>
           </a:solidFill>
           <a:ln>
             <a:noFill/>
@@ -4479,7 +4479,7 @@
             <a:avLst/>
           </a:prstGeom>
           <a:solidFill>
-            <a:srgbClr val="F43F5E"/>
+            <a:srgbClr val="E11D48"/>
           </a:solidFill>
           <a:ln>
             <a:noFill/>
@@ -4542,7 +4542,7 @@
             <a:pPr>
               <a:defRPr sz="1350" b="1">
                 <a:solidFill>
-                  <a:srgbClr val="FFFFFF"/>
+                  <a:srgbClr val="0F172A"/>
                 </a:solidFill>
                 <a:latin typeface="Segoe UI"/>
               </a:defRPr>
@@ -4553,7 +4553,7 @@
             <a:r>
               <a:rPr sz="1300" b="0">
                 <a:solidFill>
-                  <a:srgbClr val="BFDBFE"/>
+                  <a:srgbClr val="475569"/>
                 </a:solidFill>
                 <a:latin typeface="Segoe UI"/>
               </a:rPr>
@@ -4577,11 +4577,11 @@
             <a:avLst/>
           </a:prstGeom>
           <a:solidFill>
-            <a:srgbClr val="141A2B"/>
+            <a:srgbClr val="FFFFFF"/>
           </a:solidFill>
           <a:ln w="19050">
             <a:solidFill>
-              <a:srgbClr val="26304F"/>
+              <a:srgbClr val="E0DACC"/>
             </a:solidFill>
           </a:ln>
         </p:spPr>
@@ -4622,7 +4622,7 @@
             <a:avLst/>
           </a:prstGeom>
           <a:solidFill>
-            <a:srgbClr val="F43F5E"/>
+            <a:srgbClr val="E11D48"/>
           </a:solidFill>
           <a:ln>
             <a:noFill/>
@@ -4665,7 +4665,7 @@
             <a:avLst/>
           </a:prstGeom>
           <a:solidFill>
-            <a:srgbClr val="F43F5E"/>
+            <a:srgbClr val="E11D48"/>
           </a:solidFill>
           <a:ln>
             <a:noFill/>
@@ -4728,7 +4728,7 @@
             <a:pPr>
               <a:defRPr sz="1350" b="1">
                 <a:solidFill>
-                  <a:srgbClr val="FFFFFF"/>
+                  <a:srgbClr val="0F172A"/>
                 </a:solidFill>
                 <a:latin typeface="Segoe UI"/>
               </a:defRPr>
@@ -4739,7 +4739,7 @@
             <a:r>
               <a:rPr sz="1300" b="0">
                 <a:solidFill>
-                  <a:srgbClr val="BFDBFE"/>
+                  <a:srgbClr val="475569"/>
                 </a:solidFill>
                 <a:latin typeface="Segoe UI"/>
               </a:rPr>
@@ -4763,11 +4763,11 @@
             <a:avLst/>
           </a:prstGeom>
           <a:solidFill>
-            <a:srgbClr val="141A2B"/>
+            <a:srgbClr val="FFFFFF"/>
           </a:solidFill>
           <a:ln w="19050">
             <a:solidFill>
-              <a:srgbClr val="26304F"/>
+              <a:srgbClr val="E0DACC"/>
             </a:solidFill>
           </a:ln>
         </p:spPr>
@@ -4808,7 +4808,7 @@
             <a:avLst/>
           </a:prstGeom>
           <a:solidFill>
-            <a:srgbClr val="F43F5E"/>
+            <a:srgbClr val="E11D48"/>
           </a:solidFill>
           <a:ln>
             <a:noFill/>
@@ -4851,7 +4851,7 @@
             <a:avLst/>
           </a:prstGeom>
           <a:solidFill>
-            <a:srgbClr val="F43F5E"/>
+            <a:srgbClr val="E11D48"/>
           </a:solidFill>
           <a:ln>
             <a:noFill/>
@@ -4914,7 +4914,7 @@
             <a:pPr>
               <a:defRPr sz="1350" b="1">
                 <a:solidFill>
-                  <a:srgbClr val="FFFFFF"/>
+                  <a:srgbClr val="0F172A"/>
                 </a:solidFill>
                 <a:latin typeface="Segoe UI"/>
               </a:defRPr>
@@ -4925,7 +4925,7 @@
             <a:r>
               <a:rPr sz="1300" b="0">
                 <a:solidFill>
-                  <a:srgbClr val="BFDBFE"/>
+                  <a:srgbClr val="475569"/>
                 </a:solidFill>
                 <a:latin typeface="Segoe UI"/>
               </a:rPr>
@@ -4948,7 +4948,7 @@
     <p:bg>
       <p:bgPr>
         <a:solidFill>
-          <a:srgbClr val="0B0F1A"/>
+          <a:srgbClr val="FAF5EB"/>
         </a:solidFill>
         <a:effectLst/>
       </p:bgPr>
@@ -4985,7 +4985,7 @@
             <a:pPr>
               <a:defRPr sz="3200" b="1">
                 <a:solidFill>
-                  <a:srgbClr val="FFFFFF"/>
+                  <a:srgbClr val="0F172A"/>
                 </a:solidFill>
                 <a:latin typeface="Segoe UI"/>
               </a:defRPr>
@@ -5011,7 +5011,7 @@
             <a:avLst/>
           </a:prstGeom>
           <a:solidFill>
-            <a:srgbClr val="06B6D4"/>
+            <a:srgbClr val="C5A059"/>
           </a:solidFill>
           <a:ln>
             <a:noFill/>
@@ -5064,7 +5064,7 @@
             <a:pPr algn="l">
               <a:defRPr sz="1000">
                 <a:solidFill>
-                  <a:srgbClr val="5A6B8C"/>
+                  <a:srgbClr val="8C8273"/>
                 </a:solidFill>
                 <a:latin typeface="Segoe UI"/>
               </a:defRPr>
@@ -5090,11 +5090,11 @@
             <a:avLst/>
           </a:prstGeom>
           <a:solidFill>
-            <a:srgbClr val="141A2B"/>
+            <a:srgbClr val="FFFFFF"/>
           </a:solidFill>
           <a:ln w="19050">
             <a:solidFill>
-              <a:srgbClr val="26304F"/>
+              <a:srgbClr val="E0DACC"/>
             </a:solidFill>
           </a:ln>
         </p:spPr>
@@ -5135,7 +5135,7 @@
             <a:avLst/>
           </a:prstGeom>
           <a:solidFill>
-            <a:srgbClr val="06B6D4"/>
+            <a:srgbClr val="C5A059"/>
           </a:solidFill>
           <a:ln>
             <a:noFill/>
@@ -5178,7 +5178,7 @@
             <a:avLst/>
           </a:prstGeom>
           <a:solidFill>
-            <a:srgbClr val="8B5CF6"/>
+            <a:srgbClr val="4F46E5"/>
           </a:solidFill>
           <a:ln>
             <a:noFill/>
@@ -5241,7 +5241,7 @@
             <a:pPr>
               <a:defRPr sz="1350" b="1">
                 <a:solidFill>
-                  <a:srgbClr val="FFFFFF"/>
+                  <a:srgbClr val="0F172A"/>
                 </a:solidFill>
                 <a:latin typeface="Segoe UI"/>
               </a:defRPr>
@@ -5252,7 +5252,7 @@
             <a:r>
               <a:rPr sz="1300" b="0">
                 <a:solidFill>
-                  <a:srgbClr val="BFDBFE"/>
+                  <a:srgbClr val="475569"/>
                 </a:solidFill>
                 <a:latin typeface="Segoe UI"/>
               </a:rPr>
@@ -5276,11 +5276,11 @@
             <a:avLst/>
           </a:prstGeom>
           <a:solidFill>
-            <a:srgbClr val="141A2B"/>
+            <a:srgbClr val="FFFFFF"/>
           </a:solidFill>
           <a:ln w="19050">
             <a:solidFill>
-              <a:srgbClr val="26304F"/>
+              <a:srgbClr val="E0DACC"/>
             </a:solidFill>
           </a:ln>
         </p:spPr>
@@ -5321,7 +5321,7 @@
             <a:avLst/>
           </a:prstGeom>
           <a:solidFill>
-            <a:srgbClr val="06B6D4"/>
+            <a:srgbClr val="C5A059"/>
           </a:solidFill>
           <a:ln>
             <a:noFill/>
@@ -5364,7 +5364,7 @@
             <a:avLst/>
           </a:prstGeom>
           <a:solidFill>
-            <a:srgbClr val="8B5CF6"/>
+            <a:srgbClr val="4F46E5"/>
           </a:solidFill>
           <a:ln>
             <a:noFill/>
@@ -5427,7 +5427,7 @@
             <a:pPr>
               <a:defRPr sz="1350" b="1">
                 <a:solidFill>
-                  <a:srgbClr val="FFFFFF"/>
+                  <a:srgbClr val="0F172A"/>
                 </a:solidFill>
                 <a:latin typeface="Segoe UI"/>
               </a:defRPr>
@@ -5438,7 +5438,7 @@
             <a:r>
               <a:rPr sz="1300" b="0">
                 <a:solidFill>
-                  <a:srgbClr val="BFDBFE"/>
+                  <a:srgbClr val="475569"/>
                 </a:solidFill>
                 <a:latin typeface="Segoe UI"/>
               </a:rPr>
@@ -5462,11 +5462,11 @@
             <a:avLst/>
           </a:prstGeom>
           <a:solidFill>
-            <a:srgbClr val="141A2B"/>
+            <a:srgbClr val="FFFFFF"/>
           </a:solidFill>
           <a:ln w="19050">
             <a:solidFill>
-              <a:srgbClr val="26304F"/>
+              <a:srgbClr val="E0DACC"/>
             </a:solidFill>
           </a:ln>
         </p:spPr>
@@ -5507,7 +5507,7 @@
             <a:avLst/>
           </a:prstGeom>
           <a:solidFill>
-            <a:srgbClr val="06B6D4"/>
+            <a:srgbClr val="C5A059"/>
           </a:solidFill>
           <a:ln>
             <a:noFill/>
@@ -5550,7 +5550,7 @@
             <a:avLst/>
           </a:prstGeom>
           <a:solidFill>
-            <a:srgbClr val="8B5CF6"/>
+            <a:srgbClr val="4F46E5"/>
           </a:solidFill>
           <a:ln>
             <a:noFill/>
@@ -5613,7 +5613,7 @@
             <a:pPr>
               <a:defRPr sz="1350" b="1">
                 <a:solidFill>
-                  <a:srgbClr val="FFFFFF"/>
+                  <a:srgbClr val="0F172A"/>
                 </a:solidFill>
                 <a:latin typeface="Segoe UI"/>
               </a:defRPr>
@@ -5624,7 +5624,7 @@
             <a:r>
               <a:rPr sz="1300" b="0">
                 <a:solidFill>
-                  <a:srgbClr val="BFDBFE"/>
+                  <a:srgbClr val="475569"/>
                 </a:solidFill>
                 <a:latin typeface="Segoe UI"/>
               </a:rPr>
@@ -5648,11 +5648,11 @@
             <a:avLst/>
           </a:prstGeom>
           <a:solidFill>
-            <a:srgbClr val="141A2B"/>
+            <a:srgbClr val="FFFFFF"/>
           </a:solidFill>
           <a:ln w="19050">
             <a:solidFill>
-              <a:srgbClr val="26304F"/>
+              <a:srgbClr val="E0DACC"/>
             </a:solidFill>
           </a:ln>
         </p:spPr>
@@ -5693,7 +5693,7 @@
             <a:avLst/>
           </a:prstGeom>
           <a:solidFill>
-            <a:srgbClr val="06B6D4"/>
+            <a:srgbClr val="C5A059"/>
           </a:solidFill>
           <a:ln>
             <a:noFill/>
@@ -5736,7 +5736,7 @@
             <a:avLst/>
           </a:prstGeom>
           <a:solidFill>
-            <a:srgbClr val="8B5CF6"/>
+            <a:srgbClr val="4F46E5"/>
           </a:solidFill>
           <a:ln>
             <a:noFill/>
@@ -5799,7 +5799,7 @@
             <a:pPr>
               <a:defRPr sz="1350" b="1">
                 <a:solidFill>
-                  <a:srgbClr val="FFFFFF"/>
+                  <a:srgbClr val="0F172A"/>
                 </a:solidFill>
                 <a:latin typeface="Segoe UI"/>
               </a:defRPr>
@@ -5810,7 +5810,7 @@
             <a:r>
               <a:rPr sz="1300" b="0">
                 <a:solidFill>
-                  <a:srgbClr val="BFDBFE"/>
+                  <a:srgbClr val="475569"/>
                 </a:solidFill>
                 <a:latin typeface="Segoe UI"/>
               </a:rPr>
@@ -5834,11 +5834,11 @@
             <a:avLst/>
           </a:prstGeom>
           <a:solidFill>
-            <a:srgbClr val="141A2B"/>
+            <a:srgbClr val="FFFFFF"/>
           </a:solidFill>
           <a:ln w="19050">
             <a:solidFill>
-              <a:srgbClr val="26304F"/>
+              <a:srgbClr val="E0DACC"/>
             </a:solidFill>
           </a:ln>
         </p:spPr>
@@ -5879,7 +5879,7 @@
             <a:avLst/>
           </a:prstGeom>
           <a:solidFill>
-            <a:srgbClr val="06B6D4"/>
+            <a:srgbClr val="C5A059"/>
           </a:solidFill>
           <a:ln>
             <a:noFill/>
@@ -5922,7 +5922,7 @@
             <a:avLst/>
           </a:prstGeom>
           <a:solidFill>
-            <a:srgbClr val="8B5CF6"/>
+            <a:srgbClr val="4F46E5"/>
           </a:solidFill>
           <a:ln>
             <a:noFill/>
@@ -5985,7 +5985,7 @@
             <a:pPr>
               <a:defRPr sz="1350" b="1">
                 <a:solidFill>
-                  <a:srgbClr val="FFFFFF"/>
+                  <a:srgbClr val="0F172A"/>
                 </a:solidFill>
                 <a:latin typeface="Segoe UI"/>
               </a:defRPr>
@@ -5996,7 +5996,7 @@
             <a:r>
               <a:rPr sz="1300" b="0">
                 <a:solidFill>
-                  <a:srgbClr val="BFDBFE"/>
+                  <a:srgbClr val="475569"/>
                 </a:solidFill>
                 <a:latin typeface="Segoe UI"/>
               </a:rPr>
@@ -6019,7 +6019,7 @@
     <p:bg>
       <p:bgPr>
         <a:solidFill>
-          <a:srgbClr val="0B0F1A"/>
+          <a:srgbClr val="FAF5EB"/>
         </a:solidFill>
         <a:effectLst/>
       </p:bgPr>
@@ -6056,7 +6056,7 @@
             <a:pPr>
               <a:defRPr sz="3200" b="1">
                 <a:solidFill>
-                  <a:srgbClr val="FFFFFF"/>
+                  <a:srgbClr val="0F172A"/>
                 </a:solidFill>
                 <a:latin typeface="Segoe UI"/>
               </a:defRPr>
@@ -6082,7 +6082,7 @@
             <a:avLst/>
           </a:prstGeom>
           <a:solidFill>
-            <a:srgbClr val="06B6D4"/>
+            <a:srgbClr val="C5A059"/>
           </a:solidFill>
           <a:ln>
             <a:noFill/>
@@ -6135,7 +6135,7 @@
             <a:pPr algn="l">
               <a:defRPr sz="1000">
                 <a:solidFill>
-                  <a:srgbClr val="5A6B8C"/>
+                  <a:srgbClr val="8C8273"/>
                 </a:solidFill>
                 <a:latin typeface="Segoe UI"/>
               </a:defRPr>
@@ -6161,11 +6161,11 @@
             <a:avLst/>
           </a:prstGeom>
           <a:solidFill>
-            <a:srgbClr val="141A2B"/>
+            <a:srgbClr val="FFFFFF"/>
           </a:solidFill>
           <a:ln w="19050">
             <a:solidFill>
-              <a:srgbClr val="26304F"/>
+              <a:srgbClr val="E0DACC"/>
             </a:solidFill>
           </a:ln>
         </p:spPr>
@@ -6206,7 +6206,7 @@
             <a:avLst/>
           </a:prstGeom>
           <a:solidFill>
-            <a:srgbClr val="06B6D4"/>
+            <a:srgbClr val="C5A059"/>
           </a:solidFill>
           <a:ln>
             <a:noFill/>
@@ -6249,7 +6249,7 @@
             <a:avLst/>
           </a:prstGeom>
           <a:solidFill>
-            <a:srgbClr val="8B5CF6"/>
+            <a:srgbClr val="4F46E5"/>
           </a:solidFill>
           <a:ln>
             <a:noFill/>
@@ -6312,7 +6312,7 @@
             <a:pPr>
               <a:defRPr sz="1350" b="1">
                 <a:solidFill>
-                  <a:srgbClr val="FFFFFF"/>
+                  <a:srgbClr val="0F172A"/>
                 </a:solidFill>
                 <a:latin typeface="Segoe UI"/>
               </a:defRPr>
@@ -6323,7 +6323,7 @@
             <a:r>
               <a:rPr sz="1300" b="0">
                 <a:solidFill>
-                  <a:srgbClr val="BFDBFE"/>
+                  <a:srgbClr val="475569"/>
                 </a:solidFill>
                 <a:latin typeface="Segoe UI"/>
               </a:rPr>
@@ -6347,11 +6347,11 @@
             <a:avLst/>
           </a:prstGeom>
           <a:solidFill>
-            <a:srgbClr val="141A2B"/>
+            <a:srgbClr val="FFFFFF"/>
           </a:solidFill>
           <a:ln w="19050">
             <a:solidFill>
-              <a:srgbClr val="26304F"/>
+              <a:srgbClr val="E0DACC"/>
             </a:solidFill>
           </a:ln>
         </p:spPr>
@@ -6392,7 +6392,7 @@
             <a:avLst/>
           </a:prstGeom>
           <a:solidFill>
-            <a:srgbClr val="06B6D4"/>
+            <a:srgbClr val="C5A059"/>
           </a:solidFill>
           <a:ln>
             <a:noFill/>
@@ -6435,7 +6435,7 @@
             <a:avLst/>
           </a:prstGeom>
           <a:solidFill>
-            <a:srgbClr val="8B5CF6"/>
+            <a:srgbClr val="4F46E5"/>
           </a:solidFill>
           <a:ln>
             <a:noFill/>
@@ -6498,7 +6498,7 @@
             <a:pPr>
               <a:defRPr sz="1350" b="1">
                 <a:solidFill>
-                  <a:srgbClr val="FFFFFF"/>
+                  <a:srgbClr val="0F172A"/>
                 </a:solidFill>
                 <a:latin typeface="Segoe UI"/>
               </a:defRPr>
@@ -6509,7 +6509,7 @@
             <a:r>
               <a:rPr sz="1300" b="0">
                 <a:solidFill>
-                  <a:srgbClr val="BFDBFE"/>
+                  <a:srgbClr val="475569"/>
                 </a:solidFill>
                 <a:latin typeface="Segoe UI"/>
               </a:rPr>
@@ -6533,11 +6533,11 @@
             <a:avLst/>
           </a:prstGeom>
           <a:solidFill>
-            <a:srgbClr val="141A2B"/>
+            <a:srgbClr val="FFFFFF"/>
           </a:solidFill>
           <a:ln w="19050">
             <a:solidFill>
-              <a:srgbClr val="26304F"/>
+              <a:srgbClr val="E0DACC"/>
             </a:solidFill>
           </a:ln>
         </p:spPr>
@@ -6578,7 +6578,7 @@
             <a:avLst/>
           </a:prstGeom>
           <a:solidFill>
-            <a:srgbClr val="06B6D4"/>
+            <a:srgbClr val="C5A059"/>
           </a:solidFill>
           <a:ln>
             <a:noFill/>
@@ -6621,7 +6621,7 @@
             <a:avLst/>
           </a:prstGeom>
           <a:solidFill>
-            <a:srgbClr val="8B5CF6"/>
+            <a:srgbClr val="4F46E5"/>
           </a:solidFill>
           <a:ln>
             <a:noFill/>
@@ -6684,7 +6684,7 @@
             <a:pPr>
               <a:defRPr sz="1350" b="1">
                 <a:solidFill>
-                  <a:srgbClr val="FFFFFF"/>
+                  <a:srgbClr val="0F172A"/>
                 </a:solidFill>
                 <a:latin typeface="Segoe UI"/>
               </a:defRPr>
@@ -6695,7 +6695,7 @@
             <a:r>
               <a:rPr sz="1300" b="0">
                 <a:solidFill>
-                  <a:srgbClr val="BFDBFE"/>
+                  <a:srgbClr val="475569"/>
                 </a:solidFill>
                 <a:latin typeface="Segoe UI"/>
               </a:rPr>
@@ -6719,11 +6719,11 @@
             <a:avLst/>
           </a:prstGeom>
           <a:solidFill>
-            <a:srgbClr val="141A2B"/>
+            <a:srgbClr val="FFFFFF"/>
           </a:solidFill>
           <a:ln w="19050">
             <a:solidFill>
-              <a:srgbClr val="26304F"/>
+              <a:srgbClr val="E0DACC"/>
             </a:solidFill>
           </a:ln>
         </p:spPr>
@@ -6764,7 +6764,7 @@
             <a:avLst/>
           </a:prstGeom>
           <a:solidFill>
-            <a:srgbClr val="06B6D4"/>
+            <a:srgbClr val="C5A059"/>
           </a:solidFill>
           <a:ln>
             <a:noFill/>
@@ -6807,7 +6807,7 @@
             <a:avLst/>
           </a:prstGeom>
           <a:solidFill>
-            <a:srgbClr val="8B5CF6"/>
+            <a:srgbClr val="4F46E5"/>
           </a:solidFill>
           <a:ln>
             <a:noFill/>
@@ -6870,7 +6870,7 @@
             <a:pPr>
               <a:defRPr sz="1350" b="1">
                 <a:solidFill>
-                  <a:srgbClr val="FFFFFF"/>
+                  <a:srgbClr val="0F172A"/>
                 </a:solidFill>
                 <a:latin typeface="Segoe UI"/>
               </a:defRPr>
@@ -6881,7 +6881,7 @@
             <a:r>
               <a:rPr sz="1300" b="0">
                 <a:solidFill>
-                  <a:srgbClr val="BFDBFE"/>
+                  <a:srgbClr val="475569"/>
                 </a:solidFill>
                 <a:latin typeface="Segoe UI"/>
               </a:rPr>
@@ -6905,11 +6905,11 @@
             <a:avLst/>
           </a:prstGeom>
           <a:solidFill>
-            <a:srgbClr val="141A2B"/>
+            <a:srgbClr val="FFFFFF"/>
           </a:solidFill>
           <a:ln w="19050">
             <a:solidFill>
-              <a:srgbClr val="26304F"/>
+              <a:srgbClr val="E0DACC"/>
             </a:solidFill>
           </a:ln>
         </p:spPr>
@@ -6950,7 +6950,7 @@
             <a:avLst/>
           </a:prstGeom>
           <a:solidFill>
-            <a:srgbClr val="06B6D4"/>
+            <a:srgbClr val="C5A059"/>
           </a:solidFill>
           <a:ln>
             <a:noFill/>
@@ -6993,7 +6993,7 @@
             <a:avLst/>
           </a:prstGeom>
           <a:solidFill>
-            <a:srgbClr val="8B5CF6"/>
+            <a:srgbClr val="4F46E5"/>
           </a:solidFill>
           <a:ln>
             <a:noFill/>
@@ -7056,7 +7056,7 @@
             <a:pPr>
               <a:defRPr sz="1350" b="1">
                 <a:solidFill>
-                  <a:srgbClr val="FFFFFF"/>
+                  <a:srgbClr val="0F172A"/>
                 </a:solidFill>
                 <a:latin typeface="Segoe UI"/>
               </a:defRPr>
@@ -7067,7 +7067,7 @@
             <a:r>
               <a:rPr sz="1300" b="0">
                 <a:solidFill>
-                  <a:srgbClr val="BFDBFE"/>
+                  <a:srgbClr val="475569"/>
                 </a:solidFill>
                 <a:latin typeface="Segoe UI"/>
               </a:rPr>
@@ -7091,11 +7091,11 @@
             <a:avLst/>
           </a:prstGeom>
           <a:solidFill>
-            <a:srgbClr val="141A2B"/>
+            <a:srgbClr val="FFFFFF"/>
           </a:solidFill>
           <a:ln w="19050">
             <a:solidFill>
-              <a:srgbClr val="26304F"/>
+              <a:srgbClr val="E0DACC"/>
             </a:solidFill>
           </a:ln>
         </p:spPr>
@@ -7136,7 +7136,7 @@
             <a:avLst/>
           </a:prstGeom>
           <a:solidFill>
-            <a:srgbClr val="06B6D4"/>
+            <a:srgbClr val="C5A059"/>
           </a:solidFill>
           <a:ln>
             <a:noFill/>
@@ -7179,7 +7179,7 @@
             <a:avLst/>
           </a:prstGeom>
           <a:solidFill>
-            <a:srgbClr val="8B5CF6"/>
+            <a:srgbClr val="4F46E5"/>
           </a:solidFill>
           <a:ln>
             <a:noFill/>
@@ -7242,7 +7242,7 @@
             <a:pPr>
               <a:defRPr sz="1350" b="1">
                 <a:solidFill>
-                  <a:srgbClr val="FFFFFF"/>
+                  <a:srgbClr val="0F172A"/>
                 </a:solidFill>
                 <a:latin typeface="Segoe UI"/>
               </a:defRPr>
@@ -7253,7 +7253,7 @@
             <a:r>
               <a:rPr sz="1300" b="0">
                 <a:solidFill>
-                  <a:srgbClr val="BFDBFE"/>
+                  <a:srgbClr val="475569"/>
                 </a:solidFill>
                 <a:latin typeface="Segoe UI"/>
               </a:rPr>
@@ -7276,7 +7276,7 @@
     <p:bg>
       <p:bgPr>
         <a:solidFill>
-          <a:srgbClr val="0B0F1A"/>
+          <a:srgbClr val="FAF5EB"/>
         </a:solidFill>
         <a:effectLst/>
       </p:bgPr>
@@ -7313,7 +7313,7 @@
             <a:pPr>
               <a:defRPr sz="3200" b="1">
                 <a:solidFill>
-                  <a:srgbClr val="FFFFFF"/>
+                  <a:srgbClr val="0F172A"/>
                 </a:solidFill>
                 <a:latin typeface="Segoe UI"/>
               </a:defRPr>
@@ -7339,7 +7339,7 @@
             <a:avLst/>
           </a:prstGeom>
           <a:solidFill>
-            <a:srgbClr val="06B6D4"/>
+            <a:srgbClr val="C5A059"/>
           </a:solidFill>
           <a:ln>
             <a:noFill/>
@@ -7392,7 +7392,7 @@
             <a:pPr algn="l">
               <a:defRPr sz="1000">
                 <a:solidFill>
-                  <a:srgbClr val="5A6B8C"/>
+                  <a:srgbClr val="8C8273"/>
                 </a:solidFill>
                 <a:latin typeface="Segoe UI"/>
               </a:defRPr>
@@ -7418,11 +7418,11 @@
             <a:avLst/>
           </a:prstGeom>
           <a:solidFill>
-            <a:srgbClr val="141A2B"/>
+            <a:srgbClr val="FFFFFF"/>
           </a:solidFill>
           <a:ln w="19050">
             <a:solidFill>
-              <a:srgbClr val="26304F"/>
+              <a:srgbClr val="E0DACC"/>
             </a:solidFill>
           </a:ln>
         </p:spPr>
@@ -7463,7 +7463,7 @@
             <a:avLst/>
           </a:prstGeom>
           <a:solidFill>
-            <a:srgbClr val="06B6D4"/>
+            <a:srgbClr val="C5A059"/>
           </a:solidFill>
           <a:ln>
             <a:noFill/>
@@ -7506,7 +7506,7 @@
             <a:avLst/>
           </a:prstGeom>
           <a:solidFill>
-            <a:srgbClr val="8B5CF6"/>
+            <a:srgbClr val="4F46E5"/>
           </a:solidFill>
           <a:ln>
             <a:noFill/>
@@ -7569,7 +7569,7 @@
             <a:pPr>
               <a:defRPr sz="1350" b="1">
                 <a:solidFill>
-                  <a:srgbClr val="FFFFFF"/>
+                  <a:srgbClr val="0F172A"/>
                 </a:solidFill>
                 <a:latin typeface="Segoe UI"/>
               </a:defRPr>
@@ -7580,7 +7580,7 @@
             <a:r>
               <a:rPr sz="1300" b="0">
                 <a:solidFill>
-                  <a:srgbClr val="BFDBFE"/>
+                  <a:srgbClr val="475569"/>
                 </a:solidFill>
                 <a:latin typeface="Segoe UI"/>
               </a:rPr>
@@ -7604,11 +7604,11 @@
             <a:avLst/>
           </a:prstGeom>
           <a:solidFill>
-            <a:srgbClr val="141A2B"/>
+            <a:srgbClr val="FFFFFF"/>
           </a:solidFill>
           <a:ln w="19050">
             <a:solidFill>
-              <a:srgbClr val="26304F"/>
+              <a:srgbClr val="E0DACC"/>
             </a:solidFill>
           </a:ln>
         </p:spPr>
@@ -7649,7 +7649,7 @@
             <a:avLst/>
           </a:prstGeom>
           <a:solidFill>
-            <a:srgbClr val="06B6D4"/>
+            <a:srgbClr val="C5A059"/>
           </a:solidFill>
           <a:ln>
             <a:noFill/>
@@ -7692,7 +7692,7 @@
             <a:avLst/>
           </a:prstGeom>
           <a:solidFill>
-            <a:srgbClr val="8B5CF6"/>
+            <a:srgbClr val="4F46E5"/>
           </a:solidFill>
           <a:ln>
             <a:noFill/>
@@ -7755,7 +7755,7 @@
             <a:pPr>
               <a:defRPr sz="1350" b="1">
                 <a:solidFill>
-                  <a:srgbClr val="FFFFFF"/>
+                  <a:srgbClr val="0F172A"/>
                 </a:solidFill>
                 <a:latin typeface="Segoe UI"/>
               </a:defRPr>
@@ -7766,7 +7766,7 @@
             <a:r>
               <a:rPr sz="1300" b="0">
                 <a:solidFill>
-                  <a:srgbClr val="BFDBFE"/>
+                  <a:srgbClr val="475569"/>
                 </a:solidFill>
                 <a:latin typeface="Segoe UI"/>
               </a:rPr>
@@ -7790,11 +7790,11 @@
             <a:avLst/>
           </a:prstGeom>
           <a:solidFill>
-            <a:srgbClr val="141A2B"/>
+            <a:srgbClr val="FFFFFF"/>
           </a:solidFill>
           <a:ln w="19050">
             <a:solidFill>
-              <a:srgbClr val="26304F"/>
+              <a:srgbClr val="E0DACC"/>
             </a:solidFill>
           </a:ln>
         </p:spPr>
@@ -7835,7 +7835,7 @@
             <a:avLst/>
           </a:prstGeom>
           <a:solidFill>
-            <a:srgbClr val="06B6D4"/>
+            <a:srgbClr val="C5A059"/>
           </a:solidFill>
           <a:ln>
             <a:noFill/>
@@ -7878,7 +7878,7 @@
             <a:avLst/>
           </a:prstGeom>
           <a:solidFill>
-            <a:srgbClr val="8B5CF6"/>
+            <a:srgbClr val="4F46E5"/>
           </a:solidFill>
           <a:ln>
             <a:noFill/>
@@ -7941,7 +7941,7 @@
             <a:pPr>
               <a:defRPr sz="1350" b="1">
                 <a:solidFill>
-                  <a:srgbClr val="FFFFFF"/>
+                  <a:srgbClr val="0F172A"/>
                 </a:solidFill>
                 <a:latin typeface="Segoe UI"/>
               </a:defRPr>
@@ -7952,7 +7952,7 @@
             <a:r>
               <a:rPr sz="1300" b="0">
                 <a:solidFill>
-                  <a:srgbClr val="BFDBFE"/>
+                  <a:srgbClr val="475569"/>
                 </a:solidFill>
                 <a:latin typeface="Segoe UI"/>
               </a:rPr>
@@ -7976,11 +7976,11 @@
             <a:avLst/>
           </a:prstGeom>
           <a:solidFill>
-            <a:srgbClr val="141A2B"/>
+            <a:srgbClr val="FFFFFF"/>
           </a:solidFill>
           <a:ln w="19050">
             <a:solidFill>
-              <a:srgbClr val="26304F"/>
+              <a:srgbClr val="E0DACC"/>
             </a:solidFill>
           </a:ln>
         </p:spPr>
@@ -8021,7 +8021,7 @@
             <a:avLst/>
           </a:prstGeom>
           <a:solidFill>
-            <a:srgbClr val="06B6D4"/>
+            <a:srgbClr val="C5A059"/>
           </a:solidFill>
           <a:ln>
             <a:noFill/>
@@ -8064,7 +8064,7 @@
             <a:avLst/>
           </a:prstGeom>
           <a:solidFill>
-            <a:srgbClr val="8B5CF6"/>
+            <a:srgbClr val="4F46E5"/>
           </a:solidFill>
           <a:ln>
             <a:noFill/>
@@ -8127,7 +8127,7 @@
             <a:pPr>
               <a:defRPr sz="1350" b="1">
                 <a:solidFill>
-                  <a:srgbClr val="FFFFFF"/>
+                  <a:srgbClr val="0F172A"/>
                 </a:solidFill>
                 <a:latin typeface="Segoe UI"/>
               </a:defRPr>
@@ -8138,7 +8138,7 @@
             <a:r>
               <a:rPr sz="1300" b="0">
                 <a:solidFill>
-                  <a:srgbClr val="BFDBFE"/>
+                  <a:srgbClr val="475569"/>
                 </a:solidFill>
                 <a:latin typeface="Segoe UI"/>
               </a:rPr>
@@ -8162,11 +8162,11 @@
             <a:avLst/>
           </a:prstGeom>
           <a:solidFill>
-            <a:srgbClr val="141A2B"/>
+            <a:srgbClr val="FFFFFF"/>
           </a:solidFill>
           <a:ln w="19050">
             <a:solidFill>
-              <a:srgbClr val="26304F"/>
+              <a:srgbClr val="E0DACC"/>
             </a:solidFill>
           </a:ln>
         </p:spPr>
@@ -8207,7 +8207,7 @@
             <a:avLst/>
           </a:prstGeom>
           <a:solidFill>
-            <a:srgbClr val="06B6D4"/>
+            <a:srgbClr val="C5A059"/>
           </a:solidFill>
           <a:ln>
             <a:noFill/>
@@ -8250,7 +8250,7 @@
             <a:avLst/>
           </a:prstGeom>
           <a:solidFill>
-            <a:srgbClr val="8B5CF6"/>
+            <a:srgbClr val="4F46E5"/>
           </a:solidFill>
           <a:ln>
             <a:noFill/>
@@ -8313,7 +8313,7 @@
             <a:pPr>
               <a:defRPr sz="1350" b="1">
                 <a:solidFill>
-                  <a:srgbClr val="FFFFFF"/>
+                  <a:srgbClr val="0F172A"/>
                 </a:solidFill>
                 <a:latin typeface="Segoe UI"/>
               </a:defRPr>
@@ -8324,7 +8324,7 @@
             <a:r>
               <a:rPr sz="1300" b="0">
                 <a:solidFill>
-                  <a:srgbClr val="BFDBFE"/>
+                  <a:srgbClr val="475569"/>
                 </a:solidFill>
                 <a:latin typeface="Segoe UI"/>
               </a:rPr>
@@ -8347,7 +8347,7 @@
     <p:bg>
       <p:bgPr>
         <a:solidFill>
-          <a:srgbClr val="0B0F1A"/>
+          <a:srgbClr val="FAF5EB"/>
         </a:solidFill>
         <a:effectLst/>
       </p:bgPr>
@@ -8384,7 +8384,7 @@
             <a:pPr>
               <a:defRPr sz="3200" b="1">
                 <a:solidFill>
-                  <a:srgbClr val="FFFFFF"/>
+                  <a:srgbClr val="0F172A"/>
                 </a:solidFill>
                 <a:latin typeface="Segoe UI"/>
               </a:defRPr>
@@ -8410,7 +8410,7 @@
             <a:avLst/>
           </a:prstGeom>
           <a:solidFill>
-            <a:srgbClr val="06B6D4"/>
+            <a:srgbClr val="C5A059"/>
           </a:solidFill>
           <a:ln>
             <a:noFill/>
@@ -8463,7 +8463,7 @@
             <a:pPr algn="l">
               <a:defRPr sz="1000">
                 <a:solidFill>
-                  <a:srgbClr val="5A6B8C"/>
+                  <a:srgbClr val="8C8273"/>
                 </a:solidFill>
                 <a:latin typeface="Segoe UI"/>
               </a:defRPr>
@@ -8489,11 +8489,11 @@
             <a:avLst/>
           </a:prstGeom>
           <a:solidFill>
-            <a:srgbClr val="141A2B"/>
+            <a:srgbClr val="FFFFFF"/>
           </a:solidFill>
           <a:ln w="19050">
             <a:solidFill>
-              <a:srgbClr val="26304F"/>
+              <a:srgbClr val="E0DACC"/>
             </a:solidFill>
           </a:ln>
         </p:spPr>
@@ -8590,7 +8590,7 @@
               </a:spcAft>
               <a:defRPr sz="1600" b="1">
                 <a:solidFill>
-                  <a:srgbClr val="FFFFFF"/>
+                  <a:srgbClr val="0F172A"/>
                 </a:solidFill>
                 <a:latin typeface="Segoe UI"/>
               </a:defRPr>
@@ -8603,7 +8603,7 @@
             <a:pPr>
               <a:defRPr sz="1300">
                 <a:solidFill>
-                  <a:srgbClr val="BFDBFE"/>
+                  <a:srgbClr val="475569"/>
                 </a:solidFill>
                 <a:latin typeface="Segoe UI"/>
               </a:defRPr>
@@ -8629,11 +8629,11 @@
             <a:avLst/>
           </a:prstGeom>
           <a:solidFill>
-            <a:srgbClr val="141A2B"/>
+            <a:srgbClr val="FFFFFF"/>
           </a:solidFill>
           <a:ln w="19050">
             <a:solidFill>
-              <a:srgbClr val="26304F"/>
+              <a:srgbClr val="E0DACC"/>
             </a:solidFill>
           </a:ln>
         </p:spPr>
@@ -8730,7 +8730,7 @@
               </a:spcAft>
               <a:defRPr sz="1600" b="1">
                 <a:solidFill>
-                  <a:srgbClr val="FFFFFF"/>
+                  <a:srgbClr val="0F172A"/>
                 </a:solidFill>
                 <a:latin typeface="Segoe UI"/>
               </a:defRPr>
@@ -8743,7 +8743,7 @@
             <a:pPr>
               <a:defRPr sz="1300">
                 <a:solidFill>
-                  <a:srgbClr val="BFDBFE"/>
+                  <a:srgbClr val="475569"/>
                 </a:solidFill>
                 <a:latin typeface="Segoe UI"/>
               </a:defRPr>
@@ -8769,11 +8769,11 @@
             <a:avLst/>
           </a:prstGeom>
           <a:solidFill>
-            <a:srgbClr val="141A2B"/>
+            <a:srgbClr val="FFFFFF"/>
           </a:solidFill>
           <a:ln w="19050">
             <a:solidFill>
-              <a:srgbClr val="26304F"/>
+              <a:srgbClr val="E0DACC"/>
             </a:solidFill>
           </a:ln>
         </p:spPr>
@@ -8870,7 +8870,7 @@
               </a:spcAft>
               <a:defRPr sz="1600" b="1">
                 <a:solidFill>
-                  <a:srgbClr val="FFFFFF"/>
+                  <a:srgbClr val="0F172A"/>
                 </a:solidFill>
                 <a:latin typeface="Segoe UI"/>
               </a:defRPr>
@@ -8883,7 +8883,7 @@
             <a:pPr>
               <a:defRPr sz="1300">
                 <a:solidFill>
-                  <a:srgbClr val="BFDBFE"/>
+                  <a:srgbClr val="475569"/>
                 </a:solidFill>
                 <a:latin typeface="Segoe UI"/>
               </a:defRPr>
@@ -8909,11 +8909,11 @@
             <a:avLst/>
           </a:prstGeom>
           <a:solidFill>
-            <a:srgbClr val="141A2B"/>
+            <a:srgbClr val="FFFFFF"/>
           </a:solidFill>
           <a:ln w="19050">
             <a:solidFill>
-              <a:srgbClr val="26304F"/>
+              <a:srgbClr val="E0DACC"/>
             </a:solidFill>
           </a:ln>
         </p:spPr>
@@ -9010,7 +9010,7 @@
               </a:spcAft>
               <a:defRPr sz="1600" b="1">
                 <a:solidFill>
-                  <a:srgbClr val="FFFFFF"/>
+                  <a:srgbClr val="0F172A"/>
                 </a:solidFill>
                 <a:latin typeface="Segoe UI"/>
               </a:defRPr>
@@ -9023,7 +9023,7 @@
             <a:pPr>
               <a:defRPr sz="1300">
                 <a:solidFill>
-                  <a:srgbClr val="BFDBFE"/>
+                  <a:srgbClr val="475569"/>
                 </a:solidFill>
                 <a:latin typeface="Segoe UI"/>
               </a:defRPr>
@@ -9048,7 +9048,7 @@
     <p:bg>
       <p:bgPr>
         <a:solidFill>
-          <a:srgbClr val="0B0F1A"/>
+          <a:srgbClr val="FAF5EB"/>
         </a:solidFill>
         <a:effectLst/>
       </p:bgPr>
@@ -9085,7 +9085,7 @@
             <a:pPr>
               <a:defRPr sz="3200" b="1">
                 <a:solidFill>
-                  <a:srgbClr val="FFFFFF"/>
+                  <a:srgbClr val="0F172A"/>
                 </a:solidFill>
                 <a:latin typeface="Segoe UI"/>
               </a:defRPr>
@@ -9111,7 +9111,7 @@
             <a:avLst/>
           </a:prstGeom>
           <a:solidFill>
-            <a:srgbClr val="06B6D4"/>
+            <a:srgbClr val="C5A059"/>
           </a:solidFill>
           <a:ln>
             <a:noFill/>
@@ -9164,7 +9164,7 @@
             <a:pPr algn="l">
               <a:defRPr sz="1000">
                 <a:solidFill>
-                  <a:srgbClr val="5A6B8C"/>
+                  <a:srgbClr val="8C8273"/>
                 </a:solidFill>
                 <a:latin typeface="Segoe UI"/>
               </a:defRPr>
@@ -9190,7 +9190,7 @@
             <a:avLst/>
           </a:prstGeom>
           <a:solidFill>
-            <a:srgbClr val="141A2B"/>
+            <a:srgbClr val="FFFFFF"/>
           </a:solidFill>
           <a:ln w="25400">
             <a:solidFill>
@@ -9333,7 +9333,7 @@
               </a:spcBef>
               <a:defRPr sz="1500">
                 <a:solidFill>
-                  <a:srgbClr val="BFDBFE"/>
+                  <a:srgbClr val="475569"/>
                 </a:solidFill>
                 <a:latin typeface="Segoe UI"/>
               </a:defRPr>
@@ -9352,7 +9352,7 @@
               </a:spcBef>
               <a:defRPr sz="1500">
                 <a:solidFill>
-                  <a:srgbClr val="BFDBFE"/>
+                  <a:srgbClr val="475569"/>
                 </a:solidFill>
                 <a:latin typeface="Segoe UI"/>
               </a:defRPr>
@@ -9371,7 +9371,7 @@
               </a:spcBef>
               <a:defRPr sz="1500">
                 <a:solidFill>
-                  <a:srgbClr val="BFDBFE"/>
+                  <a:srgbClr val="475569"/>
                 </a:solidFill>
                 <a:latin typeface="Segoe UI"/>
               </a:defRPr>
@@ -9390,7 +9390,7 @@
               </a:spcBef>
               <a:defRPr sz="1500">
                 <a:solidFill>
-                  <a:srgbClr val="BFDBFE"/>
+                  <a:srgbClr val="475569"/>
                 </a:solidFill>
                 <a:latin typeface="Segoe UI"/>
               </a:defRPr>

</xml_diff>